<commit_message>
Update daily industry briefing
</commit_message>
<xml_diff>
--- a/docs/reports/latest.pptx
+++ b/docs/reports/latest.pptx
@@ -1876,7 +1876,7 @@
                 <a:ea typeface="Aptos" pitchFamily="34" charset="-122"/>
                 <a:cs typeface="Aptos" pitchFamily="34" charset="-120"/>
               </a:rPr>
-              <a:t>2026-10-12</a:t>
+              <a:t>2026-10-19</a:t>
             </a:r>
             <a:endParaRPr lang="en-US" sz="800" dirty="0"/>
           </a:p>
@@ -2160,7 +2160,7 @@
                 <a:ea typeface="Microsoft YaHei" pitchFamily="34" charset="-122"/>
                 <a:cs typeface="Microsoft YaHei" pitchFamily="34" charset="-120"/>
               </a:rPr>
-              <a:t>今日磷酸铁锂行业信号密集：湖南裕能20万吨纳米磷酸铁锂项目落地，龙蟠科技锁定最高56.78万吨长协，供给端与需求端同步扩张；碳酸锂价格暴跌近90%导致回收行业洗牌，成本端压力与盈利分化加剧；欧盟要求中国自限插混出口，叠加国内19项新质生产力举措，政策博弈升温。整体看，产能扩张与长协锁定并行，但价格下行和贸易壁垒可能压制盈利，需关注项目投产节奏与政策落地细节。</a:t>
+              <a:t>今日磷酸铁锂行业信号集中在技术路线与产能扩张：宝马第六代动力电池量产，强调制造韧性，可能加速高端车型对磷酸铁锂体系的结构性采用；中国储能电池产能激增110%，全球市场同步增长，显示储能端对磷酸铁锂需求形成支撑；电动摩托车锂电池强制性国标发布，明年7月实施，将提高小动力电池安全门槛，利好合规产能。需关注产能扩张与需求增速的匹配度，以及政策对低端产能的挤出效应。</a:t>
             </a:r>
             <a:endParaRPr lang="en-US" sz="1400" dirty="0"/>
           </a:p>
@@ -2898,7 +2898,7 @@
                 <a:ea typeface="Microsoft YaHei" pitchFamily="34" charset="-122"/>
                 <a:cs typeface="Microsoft YaHei" pitchFamily="34" charset="-120"/>
               </a:rPr>
-              <a:t>今日磷酸铁锂行业信号密集：湖南裕能20万吨纳米磷酸铁锂项目落地，龙蟠科技锁定最高56.78万吨长协，供给端与需求端同步扩张；碳酸锂价格暴跌近9</a:t>
+              <a:t>今日磷酸铁锂行业信号集中在技术路线与产能扩张：宝马第六代动力电池量产，强调制造韧性，可能加速高端车型对磷酸铁锂体系的结构性采用；中国储能电池产</a:t>
             </a:r>
             <a:endParaRPr lang="en-US" sz="1020" dirty="0"/>
           </a:p>
@@ -3047,7 +3047,7 @@
                 <a:ea typeface="Aptos" pitchFamily="34" charset="-122"/>
                 <a:cs typeface="Aptos" pitchFamily="34" charset="-120"/>
               </a:rPr>
-              <a:t>2026-10-12</a:t>
+              <a:t>2026-10-19</a:t>
             </a:r>
             <a:endParaRPr lang="en-US" sz="800" dirty="0"/>
           </a:p>
@@ -3612,7 +3612,7 @@
                 <a:ea typeface="Microsoft YaHei" pitchFamily="34" charset="-122"/>
                 <a:cs typeface="Microsoft YaHei" pitchFamily="34" charset="-120"/>
               </a:rPr>
-              <a:t>投资20亿元！湖南裕能于湖南湘潭加码20万吨纳米磷酸铁锂项目 - 新浪</a:t>
+              <a:t>宝马第六代动力电池量产，新世代的底牌藏在制造的韧性里 - 搜狐网</a:t>
             </a:r>
             <a:endParaRPr lang="en-US" sz="680" dirty="0"/>
           </a:p>
@@ -3653,7 +3653,7 @@
                 <a:ea typeface="Aptos" pitchFamily="34" charset="-122"/>
                 <a:cs typeface="Aptos" pitchFamily="34" charset="-120"/>
               </a:rPr>
-              <a:t>https://news.google.com/rss/articles/CBMieEFVX3lxTE5renNSMVJMYldBa2VLd184alVERVRmcTVCWmVhcC1VQ3JkVThycXZ2cGI4YVpsalM5T3BIeE9NM0VtSy1QLVVQVkQ5dF9qSi1qbEVMREc1cGhsbGpXQnJGSFRQWFlMMndGSEljVnF4a0NodndyMk9XRQ?oc=5</a:t>
+              <a:t>https://www.sohu.com/a/1089530167_126781</a:t>
             </a:r>
             <a:endParaRPr lang="en-US" sz="580" dirty="0"/>
           </a:p>
@@ -3799,7 +3799,7 @@
                 <a:ea typeface="Microsoft YaHei" pitchFamily="34" charset="-122"/>
                 <a:cs typeface="Microsoft YaHei" pitchFamily="34" charset="-120"/>
               </a:rPr>
-              <a:t>再拿重磅长协！龙蟠科技锁定最高 56.78 万吨磷酸铁锂供货订单 - </a:t>
+              <a:t>中国储能电池产能激增110%，全球市场也随之增长 - VOI.ID</a:t>
             </a:r>
             <a:endParaRPr lang="en-US" sz="680" dirty="0"/>
           </a:p>
@@ -3840,7 +3840,7 @@
                 <a:ea typeface="Aptos" pitchFamily="34" charset="-122"/>
                 <a:cs typeface="Aptos" pitchFamily="34" charset="-120"/>
               </a:rPr>
-              <a:t>https://news.google.com/rss/articles/CBMiU0FVX3lxTFBjaVMtV3B3d1J1TXF2NDVRc0czZE5KbWYxTmQxb19NRDZ2WTYxRUFzeFAxbThfRkpWSWFETlRUaDNnOUhMWkJFd2VLcDZvUDRxWGFv?oc=5</a:t>
+              <a:t>https://news.google.com/rss/articles/CBMiQkFVX3lxTE9QeV8xZG04REVrOV93OERzNGNlNFdmUmtfYkxzSWUtay1zX2UxWXZJQ2R3TFRmQ0c3eFhtcWp5M3hQd9IBQkFVX3lxTE9QeV8xZG04REVrOV93OERzNGNlNFdmUmtfYkxzSWUtay1zX2UxWXZJQ2R3TFRmQ0c3eFhtcWp5M3hQdw?oc=5</a:t>
             </a:r>
             <a:endParaRPr lang="en-US" sz="580" dirty="0"/>
           </a:p>
@@ -3986,7 +3986,7 @@
                 <a:ea typeface="Microsoft YaHei" pitchFamily="34" charset="-122"/>
                 <a:cs typeface="Microsoft YaHei" pitchFamily="34" charset="-120"/>
               </a:rPr>
-              <a:t>碳酸锂价格暴跌近90%，动力电池回收行业进入洗牌深水区 - 虎嗅网</a:t>
+              <a:t>明年7月起实施！电动摩托车锂电池强制性国标发布 - 温州新闻</a:t>
             </a:r>
             <a:endParaRPr lang="en-US" sz="680" dirty="0"/>
           </a:p>
@@ -4027,7 +4027,7 @@
                 <a:ea typeface="Aptos" pitchFamily="34" charset="-122"/>
                 <a:cs typeface="Aptos" pitchFamily="34" charset="-120"/>
               </a:rPr>
-              <a:t>https://news.google.com/rss/articles/CBMiX0FVX3lxTE9QVERsMUZQTld4RXN4cUNwMkx5c044dEJCcEJqanFrT1hod1hNdzhUVWxXUktSNXZjSW4xOEZ2OWI5N2FJQ1BWY05kMGw2elNWUVQwN0hOMThidzVRY3kw?oc=5</a:t>
+              <a:t>https://auto.66wz.com/system/2026/10/19/105856160.shtml</a:t>
             </a:r>
             <a:endParaRPr lang="en-US" sz="580" dirty="0"/>
           </a:p>
@@ -4173,7 +4173,7 @@
                 <a:ea typeface="Microsoft YaHei" pitchFamily="34" charset="-122"/>
                 <a:cs typeface="Microsoft YaHei" pitchFamily="34" charset="-120"/>
               </a:rPr>
-              <a:t>欧盟要求中国自限插混出口：让竞争者为政策失误买单 - 新浪网</a:t>
+              <a:t>专访中国工程院外籍院士张久俊：还要加大研发力度，使固态电池的优势发挥出</a:t>
             </a:r>
             <a:endParaRPr lang="en-US" sz="680" dirty="0"/>
           </a:p>
@@ -4214,7 +4214,7 @@
                 <a:ea typeface="Aptos" pitchFamily="34" charset="-122"/>
                 <a:cs typeface="Aptos" pitchFamily="34" charset="-120"/>
               </a:rPr>
-              <a:t>https://k.sina.com.cn/article_1628609891_61129d63001019rvw.html?</a:t>
+              <a:t>https://www.nbd.com.cn/articles/2026-10-18/4607644.html</a:t>
             </a:r>
             <a:endParaRPr lang="en-US" sz="580" dirty="0"/>
           </a:p>
@@ -4360,7 +4360,7 @@
                 <a:ea typeface="Microsoft YaHei" pitchFamily="34" charset="-122"/>
                 <a:cs typeface="Microsoft YaHei" pitchFamily="34" charset="-120"/>
               </a:rPr>
-              <a:t>吉利开卖电芯 - 新浪网</a:t>
+              <a:t>“任丘样本”给行业上了一课：全国首批锂+钠示范落地河北，大电芯为何看远</a:t>
             </a:r>
             <a:endParaRPr lang="en-US" sz="680" dirty="0"/>
           </a:p>
@@ -4401,7 +4401,7 @@
                 <a:ea typeface="Aptos" pitchFamily="34" charset="-122"/>
                 <a:cs typeface="Aptos" pitchFamily="34" charset="-120"/>
               </a:rPr>
-              <a:t>https://news.google.com/rss/articles/CBMif0FVX3lxTE5ETXppcDA5OTRKVTR0R0kxcEhpei01WmNhNnpvUGxSYmxVdGVSV3BHOGtscmlfN01mVUw1TjBHSWp3bFpiUmZOelFqbzNjR3o1V0ZOV0NlVjFkOEdfNEVnMzVOa3dVbFE2QzEzV3FoU1pLY0tHeFE0QThOREotNHc?oc=5</a:t>
+              <a:t>https://news.google.com/rss/articles/CBMiiAFBVV95cUxNV202anJVUnowYVNVcUxvaVRqdEJUQ2tCOTEyRnE4ZW1NR3N5MWUxV2JNcFFTRGlxeGg2OUJXYUc4dEhhXzctU1Jaa2Q2eDFyTTRBTS1RZ2RySTFYVUQ2NTczMmcxMEtmSGQwc3J1UDZTM2h4MUc4bEtTVXZ2S2x5cm5kZVZRc2lJ?oc=5</a:t>
             </a:r>
             <a:endParaRPr lang="en-US" sz="580" dirty="0"/>
           </a:p>
@@ -4547,7 +4547,7 @@
                 <a:ea typeface="Microsoft YaHei" pitchFamily="34" charset="-122"/>
                 <a:cs typeface="Microsoft YaHei" pitchFamily="34" charset="-120"/>
               </a:rPr>
-              <a:t>华盛锂电(688353):国浩律师（南京）事务所关于江苏华盛锂电材料股</a:t>
+              <a:t>商务部：12项光伏技术列入禁止、限制出口名单 - 国际新能源网</a:t>
             </a:r>
             <a:endParaRPr lang="en-US" sz="680" dirty="0"/>
           </a:p>
@@ -4588,7 +4588,7 @@
                 <a:ea typeface="Aptos" pitchFamily="34" charset="-122"/>
                 <a:cs typeface="Aptos" pitchFamily="34" charset="-120"/>
               </a:rPr>
-              <a:t>https://news.google.com/rss/articles/CBMiVkFVX3lxTE52dEZqMkQzMXlSOFpsd0Y0ZWlxdXp1anI1VjVVR3ZrcnBlWVBWNFhVemVEamk2YndSYWVHU3pPNldWcWtuZWxfZmh2a0I1MnYtOU5tYkJ3?oc=5</a:t>
+              <a:t>https://mnewenergy.in-en.com/html/newenergy-2457963.shtml</a:t>
             </a:r>
             <a:endParaRPr lang="en-US" sz="580" dirty="0"/>
           </a:p>
@@ -4693,7 +4693,7 @@
                 <a:ea typeface="Microsoft YaHei" pitchFamily="34" charset="-122"/>
                 <a:cs typeface="Microsoft YaHei" pitchFamily="34" charset="-120"/>
               </a:rPr>
-              <a:t>中国磷酸铁锂行业官方政策与</a:t>
+              <a:t>中国电池网</a:t>
             </a:r>
             <a:endParaRPr lang="en-US" sz="680" dirty="0"/>
           </a:p>
@@ -4734,7 +4734,7 @@
                 <a:ea typeface="Microsoft YaHei" pitchFamily="34" charset="-122"/>
                 <a:cs typeface="Microsoft YaHei" pitchFamily="34" charset="-120"/>
               </a:rPr>
-              <a:t>开盘：三大指数集体低开 电池板块跌幅居前 - 新浪财经</a:t>
+              <a:t>【正极材料周报】全球第三大动力电池巨头锁单碳酸锂！万华化学再扩磷酸铁锂</a:t>
             </a:r>
             <a:endParaRPr lang="en-US" sz="680" dirty="0"/>
           </a:p>
@@ -4775,7 +4775,7 @@
                 <a:ea typeface="Aptos" pitchFamily="34" charset="-122"/>
                 <a:cs typeface="Aptos" pitchFamily="34" charset="-120"/>
               </a:rPr>
-              <a:t>https://finance.sina.cn/stock/dpps/2026-10-12/detail-iniuxmtt8586938.d.html</a:t>
+              <a:t>https://www.itdcw.com/news/dczk/101215T3H026.html</a:t>
             </a:r>
             <a:endParaRPr lang="en-US" sz="580" dirty="0"/>
           </a:p>
@@ -4880,7 +4880,7 @@
                 <a:ea typeface="Microsoft YaHei" pitchFamily="34" charset="-122"/>
                 <a:cs typeface="Microsoft YaHei" pitchFamily="34" charset="-120"/>
               </a:rPr>
-              <a:t>中国磷酸铁锂行业官方政策与</a:t>
+              <a:t>中国电池网</a:t>
             </a:r>
             <a:endParaRPr lang="en-US" sz="680" dirty="0"/>
           </a:p>
@@ -4921,7 +4921,7 @@
                 <a:ea typeface="Microsoft YaHei" pitchFamily="34" charset="-122"/>
                 <a:cs typeface="Microsoft YaHei" pitchFamily="34" charset="-120"/>
               </a:rPr>
-              <a:t>我国出台19项举措推进新质生产力发展；龙源电力9月发电量同比增长超7%</a:t>
+              <a:t>我国研发新型无钴高镍正极材料 显著提升快充效率与循环寿命_电池网</a:t>
             </a:r>
             <a:endParaRPr lang="en-US" sz="680" dirty="0"/>
           </a:p>
@@ -4962,7 +4962,7 @@
                 <a:ea typeface="Aptos" pitchFamily="34" charset="-122"/>
                 <a:cs typeface="Aptos" pitchFamily="34" charset="-120"/>
               </a:rPr>
-              <a:t>https://www.mrjjxw.com/articles/2026-10-11/4601022.html</a:t>
+              <a:t>https://www.itdcw.com/news/focus/100415Rb2026.html</a:t>
             </a:r>
             <a:endParaRPr lang="en-US" sz="580" dirty="0"/>
           </a:p>
@@ -5067,7 +5067,7 @@
                 <a:ea typeface="Microsoft YaHei" pitchFamily="34" charset="-122"/>
                 <a:cs typeface="Microsoft YaHei" pitchFamily="34" charset="-120"/>
               </a:rPr>
-              <a:t>中国磷酸铁锂行业官方政策与</a:t>
+              <a:t>中国电池网</a:t>
             </a:r>
             <a:endParaRPr lang="en-US" sz="680" dirty="0"/>
           </a:p>
@@ -5108,7 +5108,7 @@
                 <a:ea typeface="Microsoft YaHei" pitchFamily="34" charset="-122"/>
                 <a:cs typeface="Microsoft YaHei" pitchFamily="34" charset="-120"/>
               </a:rPr>
-              <a:t>嘴上支持对华加税，身体却很诚实，法国电池谷为何争抢中国企业？ - 新浪网</a:t>
+              <a:t>正力新能上半年动力电池收入45.77亿元 储能电池收入增长近8倍_电池网</a:t>
             </a:r>
             <a:endParaRPr lang="en-US" sz="680" dirty="0"/>
           </a:p>
@@ -5149,7 +5149,7 @@
                 <a:ea typeface="Aptos" pitchFamily="34" charset="-122"/>
                 <a:cs typeface="Aptos" pitchFamily="34" charset="-120"/>
               </a:rPr>
-              <a:t>https://k.sina.com.cn/article_7879996580_1d5af34a402001w6du.html</a:t>
+              <a:t>https://www.itdcw.com/news/qiye/0Z115L232026.html</a:t>
             </a:r>
             <a:endParaRPr lang="en-US" sz="580" dirty="0"/>
           </a:p>
@@ -5295,7 +5295,7 @@
                 <a:ea typeface="Microsoft YaHei" pitchFamily="34" charset="-122"/>
                 <a:cs typeface="Microsoft YaHei" pitchFamily="34" charset="-120"/>
               </a:rPr>
-              <a:t>中国电池网</a:t>
+              <a:t>同体积容量击穿行业纪录！多氟多两款大圆柱磷酸铁锂换电方案发布_电池网</a:t>
             </a:r>
             <a:endParaRPr lang="en-US" sz="680" dirty="0"/>
           </a:p>
@@ -5336,7 +5336,7 @@
                 <a:ea typeface="Aptos" pitchFamily="34" charset="-122"/>
                 <a:cs typeface="Aptos" pitchFamily="34" charset="-120"/>
               </a:rPr>
-              <a:t>https://www.itdcw.com/</a:t>
+              <a:t>https://www.itdcw.com/news/chanpinxinwen/06251562M2026.html</a:t>
             </a:r>
             <a:endParaRPr lang="en-US" sz="580" dirty="0"/>
           </a:p>
@@ -5964,7 +5964,7 @@
                 <a:ea typeface="Aptos" pitchFamily="34" charset="-122"/>
                 <a:cs typeface="Aptos" pitchFamily="34" charset="-120"/>
               </a:rPr>
-              <a:t>2026-10-12</a:t>
+              <a:t>2026-10-19</a:t>
             </a:r>
             <a:endParaRPr lang="en-US" sz="800" dirty="0"/>
           </a:p>
@@ -6903,7 +6903,7 @@
                 <a:ea typeface="Microsoft YaHei" pitchFamily="34" charset="-122"/>
                 <a:cs typeface="Microsoft YaHei" pitchFamily="34" charset="-120"/>
               </a:rPr>
-              <a:t>界面新闻</a:t>
+              <a:t>锂电产业链周记 | 前三季度国内动力和储能电池出口量增超50% 赛力斯</a:t>
             </a:r>
             <a:endParaRPr lang="en-US" sz="680" dirty="0"/>
           </a:p>
@@ -6944,7 +6944,7 @@
                 <a:ea typeface="Aptos" pitchFamily="34" charset="-122"/>
                 <a:cs typeface="Aptos" pitchFamily="34" charset="-120"/>
               </a:rPr>
-              <a:t>https://www.jiemian.com/</a:t>
+              <a:t>https://www.jiemian.com/article/15201129.html</a:t>
             </a:r>
             <a:endParaRPr lang="en-US" sz="580" dirty="0"/>
           </a:p>
@@ -7464,7 +7464,7 @@
                 <a:ea typeface="Microsoft YaHei" pitchFamily="34" charset="-122"/>
                 <a:cs typeface="Microsoft YaHei" pitchFamily="34" charset="-120"/>
               </a:rPr>
-              <a:t>工业和信息化部政策文件库</a:t>
+              <a:t>公开征求对光伏制造行业规范条件及公告管理办法（征求意见稿）的意见</a:t>
             </a:r>
             <a:endParaRPr lang="en-US" sz="680" dirty="0"/>
           </a:p>
@@ -7505,7 +7505,7 @@
                 <a:ea typeface="Aptos" pitchFamily="34" charset="-122"/>
                 <a:cs typeface="Aptos" pitchFamily="34" charset="-120"/>
               </a:rPr>
-              <a:t>https://www.miit.gov.cn/search/zcwjk.html?websiteid=110000000000000&amp;pg=&amp;p=&amp;tpl=14&amp;category=183&amp;q=</a:t>
+              <a:t>https://www.miit.gov.cn/gzcy/yjzj/art/2026/art_fcf91636ca1c480b9382f48f6fe22f23.html</a:t>
             </a:r>
             <a:endParaRPr lang="en-US" sz="580" dirty="0"/>
           </a:p>
@@ -7651,7 +7651,7 @@
                 <a:ea typeface="Microsoft YaHei" pitchFamily="34" charset="-122"/>
                 <a:cs typeface="Microsoft YaHei" pitchFamily="34" charset="-120"/>
               </a:rPr>
-              <a:t>宁夏通信管理局举办2026年国家网络安全宣传周“电信日”政策宣贯培训会</a:t>
+              <a:t>工业和信息化部政策文件库</a:t>
             </a:r>
             <a:endParaRPr lang="en-US" sz="680" dirty="0"/>
           </a:p>
@@ -7692,7 +7692,7 @@
                 <a:ea typeface="Aptos" pitchFamily="34" charset="-122"/>
                 <a:cs typeface="Aptos" pitchFamily="34" charset="-120"/>
               </a:rPr>
-              <a:t>https://www.miit.gov.cn/xwfb/gxdt/dfdt/art/2026/art_e6cc05a7b861405bbd9639e819a13567.html</a:t>
+              <a:t>https://www.miit.gov.cn/search/zcwjk.html?websiteid=110000000000000&amp;pg=&amp;p=&amp;tpl=14&amp;category=183&amp;q=</a:t>
             </a:r>
             <a:endParaRPr lang="en-US" sz="580" dirty="0"/>
           </a:p>
@@ -8881,7 +8881,7 @@
                 <a:ea typeface="Aptos" pitchFamily="34" charset="-122"/>
                 <a:cs typeface="Aptos" pitchFamily="34" charset="-120"/>
               </a:rPr>
-              <a:t>2026-10-12</a:t>
+              <a:t>2026-10-19</a:t>
             </a:r>
             <a:endParaRPr lang="en-US" sz="800" dirty="0"/>
           </a:p>
@@ -9085,7 +9085,7 @@
                 <a:ea typeface="Microsoft YaHei" pitchFamily="34" charset="-122"/>
                 <a:cs typeface="Microsoft YaHei" pitchFamily="34" charset="-120"/>
               </a:rPr>
-              <a:t>今日磷酸铁锂行业信号密集：湖南裕能20万吨纳米磷酸铁锂项目落地，龙蟠科技锁定最高56.78万吨长协，供给端与需求端同步扩张；碳酸锂价格暴跌近9</a:t>
+              <a:t>今日磷酸铁锂行业信号集中在技术路线与产能扩张：宝马第六代动力电池量产，强调制造韧性，可能加速高端车型对磷酸铁锂体系的结构性采用；中国储能电池产</a:t>
             </a:r>
             <a:endParaRPr lang="en-US" sz="940" dirty="0"/>
           </a:p>
@@ -9281,7 +9281,7 @@
                 <a:ea typeface="Microsoft YaHei" pitchFamily="34" charset="-122"/>
                 <a:cs typeface="Microsoft YaHei" pitchFamily="34" charset="-120"/>
               </a:rPr>
-              <a:t>湖南裕能加码20万吨纳米磷酸铁锂项目，龙蟠科技锁定最高56.78万吨长协，供给与需求同步扩张；碳酸锂价格暴跌近90%致回收行业洗牌，成本端压力凸显；欧盟要求中国自限插混出口，</a:t>
+              <a:t>宝马第六代动力电池量产，强调制造韧性，可能推动磷酸铁锂在高端车型渗透；中国储能电池产能激增110%，全球市场同步增长，储能端对磷酸铁锂需求形成支撑；电动摩托车锂电池强制性国标</a:t>
             </a:r>
             <a:endParaRPr lang="en-US" sz="920" dirty="0"/>
           </a:p>
@@ -9322,7 +9322,7 @@
                 <a:ea typeface="Aptos" pitchFamily="34" charset="-122"/>
                 <a:cs typeface="Aptos" pitchFamily="34" charset="-120"/>
               </a:rPr>
-              <a:t>[1][2][3][4]</a:t>
+              <a:t>[1][2][3]</a:t>
             </a:r>
             <a:endParaRPr lang="en-US" sz="750" dirty="0"/>
           </a:p>
@@ -9518,7 +9518,7 @@
                 <a:ea typeface="Microsoft YaHei" pitchFamily="34" charset="-122"/>
                 <a:cs typeface="Microsoft YaHei" pitchFamily="34" charset="-120"/>
               </a:rPr>
-              <a:t>湖南裕能投资20亿元加码20万吨纳米磷酸铁锂项目，指向纳米化技术路线受重视；吉利开卖电芯，可能推动磷酸铁锂在车企自供体系中的渗透。纳米磷酸铁锂可提升能量密度和倍率性能，但成本</a:t>
+              <a:t>宝马第六代动力电池量产，强调制造韧性，可能加速高端车型对磷酸铁锂体系的结构性采用；固态电池专家提出2030年实用化量产目标，短期对磷酸铁锂替代威胁有限，但长期技术路线竞争需持</a:t>
             </a:r>
             <a:endParaRPr lang="en-US" sz="920" dirty="0"/>
           </a:p>
@@ -9559,7 +9559,7 @@
                 <a:ea typeface="Aptos" pitchFamily="34" charset="-122"/>
                 <a:cs typeface="Aptos" pitchFamily="34" charset="-120"/>
               </a:rPr>
-              <a:t>[1][5]</a:t>
+              <a:t>[1][4]</a:t>
             </a:r>
             <a:endParaRPr lang="en-US" sz="750" dirty="0"/>
           </a:p>
@@ -9704,7 +9704,7 @@
         <p:spPr>
           <a:xfrm>
             <a:off x="1188720" y="4005072"/>
-            <a:ext cx="2194560" cy="54864"/>
+            <a:ext cx="1316736" cy="54864"/>
           </a:xfrm>
           <a:prstGeom prst="rect">
             <a:avLst/>
@@ -9755,7 +9755,7 @@
                 <a:ea typeface="Microsoft YaHei" pitchFamily="34" charset="-122"/>
                 <a:cs typeface="Microsoft YaHei" pitchFamily="34" charset="-120"/>
               </a:rPr>
-              <a:t>龙蟠科技锁定最高56.78万吨磷酸铁锂供货长协，湖南裕能20万吨项目落地，产能与订单同步扩张；华盛锂电差异化权益分派法律意见书发布，资本运作活跃。长协锁定反映下游对供应稳定的</a:t>
+              <a:t>中国储能电池产能激增110%，全球市场同步增长，显示储能端对磷酸铁锂需求形成支撑；全国首批锂+钠示范落地河北，大电芯路线推进，可能加剧储能电池技术路线竞争，磷酸铁锂需关注在储</a:t>
             </a:r>
             <a:endParaRPr lang="en-US" sz="920" dirty="0"/>
           </a:p>
@@ -9796,7 +9796,7 @@
                 <a:ea typeface="Aptos" pitchFamily="34" charset="-122"/>
                 <a:cs typeface="Aptos" pitchFamily="34" charset="-120"/>
               </a:rPr>
-              <a:t>[2][1][6]</a:t>
+              <a:t>[2][5]</a:t>
             </a:r>
             <a:endParaRPr lang="en-US" sz="750" dirty="0"/>
           </a:p>
@@ -9992,7 +9992,7 @@
                 <a:ea typeface="Microsoft YaHei" pitchFamily="34" charset="-122"/>
                 <a:cs typeface="Microsoft YaHei" pitchFamily="34" charset="-120"/>
               </a:rPr>
-              <a:t>碳酸锂价格暴跌近90%，动力电池回收行业进入洗牌深水区；电池板块跌幅居前，反映价格下行压力。成本端坍塌削弱磷酸铁锂价格支撑，回收企业退出可能加速，但上游材料企业盈利分化。</a:t>
+              <a:t>储能电池产能激增110%可能加剧行业供给竞争，对磷酸铁锂正极材料价格形成压制；电动摩托车锂电池强制性国标发布，可能提高小动力电池合规成本，推动低端产能出清，短期对磷酸铁锂价格</a:t>
             </a:r>
             <a:endParaRPr lang="en-US" sz="920" dirty="0"/>
           </a:p>
@@ -10033,7 +10033,7 @@
                 <a:ea typeface="Aptos" pitchFamily="34" charset="-122"/>
                 <a:cs typeface="Aptos" pitchFamily="34" charset="-120"/>
               </a:rPr>
-              <a:t>[3][7]</a:t>
+              <a:t>[2][3]</a:t>
             </a:r>
             <a:endParaRPr lang="en-US" sz="750" dirty="0"/>
           </a:p>
@@ -10138,7 +10138,7 @@
                 <a:ea typeface="Microsoft YaHei" pitchFamily="34" charset="-122"/>
                 <a:cs typeface="Microsoft YaHei" pitchFamily="34" charset="-120"/>
               </a:rPr>
-              <a:t>今日磷酸铁锂行业信号密集：湖南裕能20万吨纳米磷酸铁锂项目落地，龙蟠科技锁定最高56.78万吨长协，供给端与需求端同步扩张；碳酸锂价格暴跌近9</a:t>
+              <a:t>今日磷酸铁锂行业信号集中在技术路线与产能扩张：宝马第六代动力电池量产，强调制造韧性，可能加速高端车型对磷酸铁锂体系的结构性采用；中国储能电池产</a:t>
             </a:r>
             <a:endParaRPr lang="en-US" sz="1020" dirty="0"/>
           </a:p>
@@ -10287,7 +10287,7 @@
                 <a:ea typeface="Aptos" pitchFamily="34" charset="-122"/>
                 <a:cs typeface="Aptos" pitchFamily="34" charset="-120"/>
               </a:rPr>
-              <a:t>2026-10-12</a:t>
+              <a:t>2026-10-19</a:t>
             </a:r>
             <a:endParaRPr lang="en-US" sz="800" dirty="0"/>
           </a:p>
@@ -10493,7 +10493,7 @@
                 <a:ea typeface="Microsoft YaHei" pitchFamily="34" charset="-122"/>
                 <a:cs typeface="Microsoft YaHei" pitchFamily="34" charset="-120"/>
               </a:rPr>
-              <a:t>4 条公开来源交叉验证｜事实、影响与后续研判</a:t>
+              <a:t>3 条公开来源交叉验证｜事实、影响与后续研判</a:t>
             </a:r>
             <a:endParaRPr lang="en-US" sz="860" dirty="0"/>
           </a:p>
@@ -10602,7 +10602,7 @@
                 <a:ea typeface="Microsoft YaHei" pitchFamily="34" charset="-122"/>
                 <a:cs typeface="Microsoft YaHei" pitchFamily="34" charset="-120"/>
               </a:rPr>
-              <a:t>湖南裕能加码20万吨纳米磷酸铁锂项目，龙蟠科技锁定最高56.78万吨长协，供给与需求同步扩张；碳酸锂价格暴跌近90%致回收行业洗牌，成本端压力凸显；欧盟要求中国自限插混出口，贸易政策风险升温。行业呈现产能扩张与价格下行并存格局，企业盈利分化可能加剧。 [1][2][3][4]</a:t>
+              <a:t>宝马第六代动力电池量产，强调制造韧性，可能推动磷酸铁锂在高端车型渗透；中国储能电池产能激增110%，全球市场同步增长，储能端对磷酸铁锂需求形成支撑；电动摩托车锂电池强制性国标发布，明年7月实施，将提高小动力电池安全门槛，利好合规产能。 [1][2][3]</a:t>
             </a:r>
             <a:endParaRPr lang="en-US" sz="960" dirty="0"/>
           </a:p>
@@ -10643,7 +10643,7 @@
                 <a:ea typeface="Aptos" pitchFamily="34" charset="-122"/>
                 <a:cs typeface="Aptos" pitchFamily="34" charset="-120"/>
               </a:rPr>
-              <a:t>依据：[1][2][3][4]</a:t>
+              <a:t>依据：[1][2][3]</a:t>
             </a:r>
             <a:endParaRPr lang="en-US" sz="740" dirty="0"/>
           </a:p>
@@ -10752,7 +10752,7 @@
                 <a:ea typeface="Microsoft YaHei" pitchFamily="34" charset="-122"/>
                 <a:cs typeface="Microsoft YaHei" pitchFamily="34" charset="-120"/>
               </a:rPr>
-              <a:t>湖南裕能扩产与龙蟠科技长协反映磷酸铁锂需求预期仍强，但碳酸锂价格暴跌近90%削弱成本支撑，回收行业洗牌可能向上游传导；欧盟自限出口要求若落地，将影响插混车型对磷酸铁锂的需求。需验证：新项目投产时间、长协实际执行量、欧盟政策具体条款。</a:t>
+              <a:t>宝马量产信息与储能产能激增共同指向磷酸铁锂需求端扩张，但前者侧重技术路线验证，后者侧重产能供给；电摩国标则从合规端抬升小动力电池门槛。三者叠加可能加剧行业分化：具备技术储备和合规产能的企业受益，低端产能面临出清。需验证宝马第六代电池是否明确采用磷酸铁锂体系，以及储能产能激增是否伴随实际订单落地。</a:t>
             </a:r>
             <a:endParaRPr lang="en-US" sz="960" dirty="0"/>
           </a:p>
@@ -10886,7 +10886,7 @@
                 <a:ea typeface="Microsoft YaHei" pitchFamily="34" charset="-122"/>
                 <a:cs typeface="Microsoft YaHei" pitchFamily="34" charset="-120"/>
               </a:rPr>
-              <a:t>若碳酸锂价格持续低位，则磷酸铁锂成本支撑进一步弱化，回收企业退出可能加速，行业集中度提升；若欧盟自限出口政策落地，则插混出口受限可能拖累磷酸铁锂需求，需跟踪碳酸锂现货价、欧盟政策细则及龙头开工率。</a:t>
+              <a:t>若宝马第六代电池明确采用磷酸铁锂体系并逐步放量，则可能带动高端车型对磷酸铁锂的认可度提升，跟踪指标包括宝马官方技术参数披露和配套电池供应商名单；若储能产能激增伴随开工率维持高位，则可能支撑磷酸铁锂正极材料需求，跟踪指标为储能电池月度产量和出口数据；若电摩国标执行严格，则可能加速小动力电池行业集中度提升，跟踪指标为合规电池企业认证进度。证据边界限于公开报道，未覆盖企业实际订单和产能利用率。</a:t>
             </a:r>
             <a:endParaRPr lang="en-US" sz="960" dirty="0"/>
           </a:p>
@@ -10969,11 +10969,11 @@
         <p:spPr>
           <a:xfrm>
             <a:off x="7772400" y="1993392"/>
-            <a:ext cx="2560320" cy="786384"/>
+            <a:ext cx="2560320" cy="1389888"/>
           </a:xfrm>
           <a:prstGeom prst="roundRect">
             <a:avLst>
-              <a:gd name="adj" fmla="val 4651"/>
+              <a:gd name="adj" fmla="val 2632"/>
             </a:avLst>
           </a:prstGeom>
           <a:solidFill>
@@ -11014,7 +11014,7 @@
               <a:buNone/>
             </a:pPr>
             <a:r>
-              <a:rPr lang="en-US" sz="1600" b="1" dirty="0">
+              <a:rPr lang="en-US" sz="2100" b="1" dirty="0">
                 <a:solidFill>
                   <a:srgbClr val="487052"/>
                 </a:solidFill>
@@ -11022,9 +11022,9 @@
                 <a:ea typeface="Aptos" pitchFamily="34" charset="-122"/>
                 <a:cs typeface="Aptos" pitchFamily="34" charset="-120"/>
               </a:rPr>
-              <a:t>90%</a:t>
-            </a:r>
-            <a:endParaRPr lang="en-US" sz="1600" dirty="0"/>
+              <a:t>10%</a:t>
+            </a:r>
+            <a:endParaRPr lang="en-US" sz="2100" dirty="0"/>
           </a:p>
         </p:txBody>
       </p:sp>
@@ -11063,7 +11063,7 @@
                 <a:ea typeface="Microsoft YaHei" pitchFamily="34" charset="-122"/>
                 <a:cs typeface="Microsoft YaHei" pitchFamily="34" charset="-120"/>
               </a:rPr>
-              <a:t>致回收行业洗牌</a:t>
+              <a:t>中国储能电池产能激增1</a:t>
             </a:r>
             <a:endParaRPr lang="en-US" sz="820" dirty="0"/>
           </a:p>
@@ -11078,7 +11078,7 @@
         <p:spPr>
           <a:xfrm>
             <a:off x="7918704" y="2578608"/>
-            <a:ext cx="2176272" cy="201168"/>
+            <a:ext cx="2176272" cy="512064"/>
           </a:xfrm>
           <a:prstGeom prst="rect">
             <a:avLst/>
@@ -11104,7 +11104,7 @@
                 <a:ea typeface="Microsoft YaHei" pitchFamily="34" charset="-122"/>
                 <a:cs typeface="Microsoft YaHei" pitchFamily="34" charset="-120"/>
               </a:rPr>
-              <a:t>公开信息：碳酸锂价格暴跌近90%致回收行业洗牌，成本端压力凸显</a:t>
+              <a:t>公开信息：中国储能电池产能激增110%，全球市场同步增长，储能端对磷酸铁锂需求形成支撑</a:t>
             </a:r>
             <a:endParaRPr lang="en-US" sz="840" dirty="0"/>
           </a:p>
@@ -11112,157 +11112,7 @@
       </p:sp>
       <p:sp>
         <p:nvSpPr>
-          <p:cNvPr id="28" name="Shape 26"/>
-          <p:cNvSpPr/>
-          <p:nvPr/>
-        </p:nvSpPr>
-        <p:spPr>
-          <a:xfrm>
-            <a:off x="7772400" y="2926080"/>
-            <a:ext cx="2560320" cy="786384"/>
-          </a:xfrm>
-          <a:prstGeom prst="roundRect">
-            <a:avLst>
-              <a:gd name="adj" fmla="val 4651"/>
-            </a:avLst>
-          </a:prstGeom>
-          <a:solidFill>
-            <a:srgbClr val="FFFFFF"/>
-          </a:solidFill>
-          <a:ln w="7620">
-            <a:solidFill>
-              <a:srgbClr val="DADADA"/>
-            </a:solidFill>
-            <a:prstDash val="solid"/>
-          </a:ln>
-        </p:spPr>
-      </p:sp>
-      <p:sp>
-        <p:nvSpPr>
-          <p:cNvPr id="29" name="Text 27"/>
-          <p:cNvSpPr/>
-          <p:nvPr/>
-        </p:nvSpPr>
-        <p:spPr>
-          <a:xfrm>
-            <a:off x="7918704" y="3035808"/>
-            <a:ext cx="822960" cy="384048"/>
-          </a:xfrm>
-          <a:prstGeom prst="rect">
-            <a:avLst/>
-          </a:prstGeom>
-          <a:noFill/>
-          <a:ln/>
-        </p:spPr>
-        <p:txBody>
-          <a:bodyPr wrap="square" lIns="0" tIns="0" rIns="0" bIns="0" rtlCol="0" anchor="ctr">
-            <a:normAutofit/>
-          </a:bodyPr>
-          <a:lstStyle/>
-          <a:p>
-            <a:pPr indent="0" marL="0">
-              <a:buNone/>
-            </a:pPr>
-            <a:r>
-              <a:rPr lang="en-US" sz="1600" b="1" dirty="0">
-                <a:solidFill>
-                  <a:srgbClr val="487052"/>
-                </a:solidFill>
-                <a:latin typeface="Aptos" pitchFamily="34" charset="0"/>
-                <a:ea typeface="Aptos" pitchFamily="34" charset="-122"/>
-                <a:cs typeface="Aptos" pitchFamily="34" charset="-120"/>
-              </a:rPr>
-              <a:t>90%</a:t>
-            </a:r>
-            <a:endParaRPr lang="en-US" sz="1600" dirty="0"/>
-          </a:p>
-        </p:txBody>
-      </p:sp>
-      <p:sp>
-        <p:nvSpPr>
-          <p:cNvPr id="30" name="Text 28"/>
-          <p:cNvSpPr/>
-          <p:nvPr/>
-        </p:nvSpPr>
-        <p:spPr>
-          <a:xfrm>
-            <a:off x="8759952" y="3099816"/>
-            <a:ext cx="1371600" cy="201168"/>
-          </a:xfrm>
-          <a:prstGeom prst="rect">
-            <a:avLst/>
-          </a:prstGeom>
-          <a:noFill/>
-          <a:ln/>
-        </p:spPr>
-        <p:txBody>
-          <a:bodyPr wrap="square" lIns="0" tIns="0" rIns="0" bIns="0" rtlCol="0" anchor="ctr">
-            <a:normAutofit/>
-          </a:bodyPr>
-          <a:lstStyle/>
-          <a:p>
-            <a:pPr indent="0" marL="0">
-              <a:buNone/>
-            </a:pPr>
-            <a:r>
-              <a:rPr lang="en-US" sz="820" b="1" dirty="0">
-                <a:solidFill>
-                  <a:srgbClr val="121212"/>
-                </a:solidFill>
-                <a:latin typeface="Microsoft YaHei" pitchFamily="34" charset="0"/>
-                <a:ea typeface="Microsoft YaHei" pitchFamily="34" charset="-122"/>
-                <a:cs typeface="Microsoft YaHei" pitchFamily="34" charset="-120"/>
-              </a:rPr>
-              <a:t>削弱成本支撑</a:t>
-            </a:r>
-            <a:endParaRPr lang="en-US" sz="820" dirty="0"/>
-          </a:p>
-        </p:txBody>
-      </p:sp>
-      <p:sp>
-        <p:nvSpPr>
-          <p:cNvPr id="31" name="Text 29"/>
-          <p:cNvSpPr/>
-          <p:nvPr/>
-        </p:nvSpPr>
-        <p:spPr>
-          <a:xfrm>
-            <a:off x="7918704" y="3511296"/>
-            <a:ext cx="2176272" cy="201168"/>
-          </a:xfrm>
-          <a:prstGeom prst="rect">
-            <a:avLst/>
-          </a:prstGeom>
-          <a:noFill/>
-          <a:ln/>
-        </p:spPr>
-        <p:txBody>
-          <a:bodyPr wrap="square" lIns="0" tIns="0" rIns="0" bIns="0" rtlCol="0" anchor="t">
-            <a:normAutofit/>
-          </a:bodyPr>
-          <a:lstStyle/>
-          <a:p>
-            <a:pPr indent="0" marL="0">
-              <a:buNone/>
-            </a:pPr>
-            <a:r>
-              <a:rPr lang="en-US" sz="840" dirty="0">
-                <a:solidFill>
-                  <a:srgbClr val="121212"/>
-                </a:solidFill>
-                <a:latin typeface="Microsoft YaHei" pitchFamily="34" charset="0"/>
-                <a:ea typeface="Microsoft YaHei" pitchFamily="34" charset="-122"/>
-                <a:cs typeface="Microsoft YaHei" pitchFamily="34" charset="-120"/>
-              </a:rPr>
-              <a:t>公开信息：[1][2][3][4] 湖南裕能扩产与龙蟠科技长协反映磷</a:t>
-            </a:r>
-            <a:endParaRPr lang="en-US" sz="840" dirty="0"/>
-          </a:p>
-        </p:txBody>
-      </p:sp>
-      <p:sp>
-        <p:nvSpPr>
-          <p:cNvPr id="32" name="Text 30"/>
+          <p:cNvPr id="28" name="Text 26"/>
           <p:cNvSpPr/>
           <p:nvPr/>
         </p:nvSpPr>
@@ -11303,7 +11153,7 @@
       </p:sp>
       <p:sp>
         <p:nvSpPr>
-          <p:cNvPr id="33" name="Shape 31"/>
+          <p:cNvPr id="29" name="Shape 27"/>
           <p:cNvSpPr/>
           <p:nvPr/>
         </p:nvSpPr>
@@ -11328,7 +11178,7 @@
       </p:sp>
       <p:sp>
         <p:nvSpPr>
-          <p:cNvPr id="34" name="Text 32"/>
+          <p:cNvPr id="30" name="Text 28"/>
           <p:cNvSpPr/>
           <p:nvPr/>
         </p:nvSpPr>
@@ -11367,7 +11217,7 @@
       </p:sp>
       <p:sp>
         <p:nvSpPr>
-          <p:cNvPr id="35" name="Text 33"/>
+          <p:cNvPr id="31" name="Text 29"/>
           <p:cNvSpPr/>
           <p:nvPr/>
         </p:nvSpPr>
@@ -11400,7 +11250,7 @@
                 <a:ea typeface="Microsoft YaHei" pitchFamily="34" charset="-122"/>
                 <a:cs typeface="Microsoft YaHei" pitchFamily="34" charset="-120"/>
               </a:rPr>
-              <a:t>若碳酸锂价格持续低位，则磷酸铁锂成本支撑进一步弱化，回收企业退出可能加速，行业集中度提升</a:t>
+              <a:t>若宝马第六代电池明确采用磷酸铁锂体系并逐步放量，则可能带动高端车型对磷酸铁锂的认可度提升，跟踪指标包括宝马官方技术参数披露和配套电池供应商名单</a:t>
             </a:r>
             <a:endParaRPr lang="en-US" sz="1020" dirty="0"/>
           </a:p>
@@ -11549,7 +11399,7 @@
                 <a:ea typeface="Aptos" pitchFamily="34" charset="-122"/>
                 <a:cs typeface="Aptos" pitchFamily="34" charset="-120"/>
               </a:rPr>
-              <a:t>2026-10-12</a:t>
+              <a:t>2026-10-19</a:t>
             </a:r>
             <a:endParaRPr lang="en-US" sz="800" dirty="0"/>
           </a:p>
@@ -11864,7 +11714,7 @@
                 <a:ea typeface="Microsoft YaHei" pitchFamily="34" charset="-122"/>
                 <a:cs typeface="Microsoft YaHei" pitchFamily="34" charset="-120"/>
               </a:rPr>
-              <a:t>湖南裕能投资20亿元加码20万吨纳米磷酸铁锂项目，指向纳米化技术路线受重视；吉利开卖电芯，可能推动磷酸铁锂在车企自供体系中的渗透。纳米磷酸铁锂可提升能量密度和倍率性能，但成本控制仍是关键。 [1][5]</a:t>
+              <a:t>宝马第六代动力电池量产，强调制造韧性，可能加速高端车型对磷酸铁锂体系的结构性采用；固态电池专家提出2030年实用化量产目标，短期对磷酸铁锂替代威胁有限，但长期技术路线竞争需持续跟踪。 [1][4]</a:t>
             </a:r>
             <a:endParaRPr lang="en-US" sz="960" dirty="0"/>
           </a:p>
@@ -11905,7 +11755,7 @@
                 <a:ea typeface="Aptos" pitchFamily="34" charset="-122"/>
                 <a:cs typeface="Aptos" pitchFamily="34" charset="-120"/>
               </a:rPr>
-              <a:t>依据：[1][5]</a:t>
+              <a:t>依据：[1][4]</a:t>
             </a:r>
             <a:endParaRPr lang="en-US" sz="740" dirty="0"/>
           </a:p>
@@ -12014,7 +11864,7 @@
                 <a:ea typeface="Microsoft YaHei" pitchFamily="34" charset="-122"/>
                 <a:cs typeface="Microsoft YaHei" pitchFamily="34" charset="-120"/>
               </a:rPr>
-              <a:t>湖南裕能扩产纳米磷酸铁锂，反映行业向高性能产品升级；吉利开卖电芯表明车企垂直整合加速，可能改变磷酸铁锂采购格局。需验证：纳米磷酸铁锂量产成本、吉利电芯外供规模及技术参数。</a:t>
+              <a:t>宝马量产信息来自搜狐网，固态电池观点来自每日经济新闻专访，两者均涉及动力电池技术路线。宝马量产若采用磷酸铁锂体系，将强化磷酸铁锂在中高端车型的渗透逻辑；固态电池量产目标在2030年，短期不构成替代压力，但提醒行业关注技术迭代风险。需验证宝马第六代电池的具体化学体系，以及固态电池量产时间表是否有企业级进展。</a:t>
             </a:r>
             <a:endParaRPr lang="en-US" sz="960" dirty="0"/>
           </a:p>
@@ -12148,7 +11998,7 @@
                 <a:ea typeface="Microsoft YaHei" pitchFamily="34" charset="-122"/>
                 <a:cs typeface="Microsoft YaHei" pitchFamily="34" charset="-120"/>
               </a:rPr>
-              <a:t>若纳米磷酸铁锂量产成本下降，则高端车型渗透率可能提升；若吉利电芯外供规模扩大，则第三方磷酸铁锂供应商份额可能受挤压。跟踪指标：纳米产品出货占比、吉利电芯客户名单。</a:t>
+              <a:t>若宝马第六代电池确认采用磷酸铁锂或磷酸铁锰锂体系，则可能提升磷酸铁锂在高端乘用车市场的份额，跟踪指标为宝马新车型电池供应商公告和材料体系披露；若固态电池在2030年前实现小批量装车，则可能对磷酸铁锂长期需求预期形成扰动，跟踪指标为固态电池装车验证进度和成本下降曲线。证据边界限于公开报道，未覆盖宝马电池采购合同细节。</a:t>
             </a:r>
             <a:endParaRPr lang="en-US" sz="960" dirty="0"/>
           </a:p>
@@ -12216,7 +12066,7 @@
                 <a:ea typeface="Microsoft YaHei" pitchFamily="34" charset="-122"/>
                 <a:cs typeface="Microsoft YaHei" pitchFamily="34" charset="-120"/>
               </a:rPr>
-              <a:t>路线图</a:t>
+              <a:t>对比矩阵</a:t>
             </a:r>
             <a:endParaRPr lang="en-US" sz="1200" dirty="0"/>
           </a:p>
@@ -12230,18 +12080,89 @@
         </p:nvSpPr>
         <p:spPr>
           <a:xfrm>
-            <a:off x="7754112" y="2249424"/>
-            <a:ext cx="612648" cy="402336"/>
-          </a:xfrm>
-          <a:prstGeom prst="chevron">
+            <a:off x="7818120" y="2176272"/>
+            <a:ext cx="2487168" cy="1609344"/>
+          </a:xfrm>
+          <a:prstGeom prst="rect">
+            <a:avLst/>
+          </a:prstGeom>
+          <a:solidFill>
+            <a:srgbClr val="FFFFFF"/>
+          </a:solidFill>
+          <a:ln w="10160">
+            <a:solidFill>
+              <a:srgbClr val="DADADA"/>
+            </a:solidFill>
+            <a:prstDash val="solid"/>
+          </a:ln>
+        </p:spPr>
+      </p:sp>
+      <p:sp>
+        <p:nvSpPr>
+          <p:cNvPr id="25" name="Shape 23"/>
+          <p:cNvSpPr/>
+          <p:nvPr/>
+        </p:nvSpPr>
+        <p:spPr>
+          <a:xfrm>
+            <a:off x="9061704" y="2176272"/>
+            <a:ext cx="0" cy="1609344"/>
+          </a:xfrm>
+          <a:prstGeom prst="line">
+            <a:avLst/>
+          </a:prstGeom>
+          <a:noFill/>
+          <a:ln w="8890">
+            <a:solidFill>
+              <a:srgbClr val="DADADA"/>
+            </a:solidFill>
+            <a:prstDash val="solid"/>
+          </a:ln>
+        </p:spPr>
+      </p:sp>
+      <p:sp>
+        <p:nvSpPr>
+          <p:cNvPr id="26" name="Shape 24"/>
+          <p:cNvSpPr/>
+          <p:nvPr/>
+        </p:nvSpPr>
+        <p:spPr>
+          <a:xfrm>
+            <a:off x="7818120" y="2980944"/>
+            <a:ext cx="2487168" cy="0"/>
+          </a:xfrm>
+          <a:prstGeom prst="line">
+            <a:avLst/>
+          </a:prstGeom>
+          <a:noFill/>
+          <a:ln w="8890">
+            <a:solidFill>
+              <a:srgbClr val="DADADA"/>
+            </a:solidFill>
+            <a:prstDash val="solid"/>
+          </a:ln>
+        </p:spPr>
+      </p:sp>
+      <p:sp>
+        <p:nvSpPr>
+          <p:cNvPr id="27" name="Shape 25"/>
+          <p:cNvSpPr/>
+          <p:nvPr/>
+        </p:nvSpPr>
+        <p:spPr>
+          <a:xfrm>
+            <a:off x="7818120" y="2176272"/>
+            <a:ext cx="1243584" cy="804672"/>
+          </a:xfrm>
+          <a:prstGeom prst="rect">
             <a:avLst/>
           </a:prstGeom>
           <a:solidFill>
             <a:srgbClr val="DDEBE0"/>
           </a:solidFill>
-          <a:ln w="13970">
+          <a:ln w="3810">
             <a:solidFill>
-              <a:srgbClr val="487052"/>
+              <a:srgbClr val="DADADA"/>
             </a:solidFill>
             <a:prstDash val="solid"/>
           </a:ln>
@@ -12249,14 +12170,14 @@
       </p:sp>
       <p:sp>
         <p:nvSpPr>
-          <p:cNvPr id="25" name="Text 23"/>
-          <p:cNvSpPr/>
-          <p:nvPr/>
-        </p:nvSpPr>
-        <p:spPr>
-          <a:xfrm>
-            <a:off x="7827264" y="2386584"/>
-            <a:ext cx="448056" cy="109728"/>
+          <p:cNvPr id="28" name="Text 26"/>
+          <p:cNvSpPr/>
+          <p:nvPr/>
+        </p:nvSpPr>
+        <p:spPr>
+          <a:xfrm>
+            <a:off x="7891272" y="2286000"/>
+            <a:ext cx="438912" cy="109728"/>
           </a:xfrm>
           <a:prstGeom prst="rect">
             <a:avLst/>
@@ -12270,11 +12191,52 @@
           </a:bodyPr>
           <a:lstStyle/>
           <a:p>
-            <a:pPr algn="ctr" indent="0" marL="0">
-              <a:buNone/>
-            </a:pPr>
-            <a:r>
-              <a:rPr lang="en-US" sz="670" b="1" dirty="0">
+            <a:pPr indent="0" marL="0">
+              <a:buNone/>
+            </a:pPr>
+            <a:r>
+              <a:rPr lang="en-US" sz="710" b="1" dirty="0">
+                <a:solidFill>
+                  <a:srgbClr val="487052"/>
+                </a:solidFill>
+                <a:latin typeface="Microsoft YaHei" pitchFamily="34" charset="0"/>
+                <a:ea typeface="Microsoft YaHei" pitchFamily="34" charset="-122"/>
+                <a:cs typeface="Microsoft YaHei" pitchFamily="34" charset="-120"/>
+              </a:rPr>
+              <a:t>路线A</a:t>
+            </a:r>
+            <a:endParaRPr lang="en-US" sz="710" dirty="0"/>
+          </a:p>
+        </p:txBody>
+      </p:sp>
+      <p:sp>
+        <p:nvSpPr>
+          <p:cNvPr id="29" name="Text 27"/>
+          <p:cNvSpPr/>
+          <p:nvPr/>
+        </p:nvSpPr>
+        <p:spPr>
+          <a:xfrm>
+            <a:off x="7891272" y="2505456"/>
+            <a:ext cx="1024128" cy="201168"/>
+          </a:xfrm>
+          <a:prstGeom prst="rect">
+            <a:avLst/>
+          </a:prstGeom>
+          <a:noFill/>
+          <a:ln/>
+        </p:spPr>
+        <p:txBody>
+          <a:bodyPr wrap="square" lIns="0" tIns="0" rIns="0" bIns="0" rtlCol="0" anchor="t">
+            <a:normAutofit/>
+          </a:bodyPr>
+          <a:lstStyle/>
+          <a:p>
+            <a:pPr indent="0" marL="0">
+              <a:buNone/>
+            </a:pPr>
+            <a:r>
+              <a:rPr lang="en-US" sz="670" dirty="0">
                 <a:solidFill>
                   <a:srgbClr val="121212"/>
                 </a:solidFill>
@@ -12282,7 +12244,7 @@
                 <a:ea typeface="Microsoft YaHei" pitchFamily="34" charset="-122"/>
                 <a:cs typeface="Microsoft YaHei" pitchFamily="34" charset="-120"/>
               </a:rPr>
-              <a:t>技术</a:t>
+              <a:t>宝马第六代动力电池量产，强</a:t>
             </a:r>
             <a:endParaRPr lang="en-US" sz="670" dirty="0"/>
           </a:p>
@@ -12290,24 +12252,24 @@
       </p:sp>
       <p:sp>
         <p:nvSpPr>
-          <p:cNvPr id="26" name="Shape 24"/>
-          <p:cNvSpPr/>
-          <p:nvPr/>
-        </p:nvSpPr>
-        <p:spPr>
-          <a:xfrm>
-            <a:off x="8375904" y="2249424"/>
-            <a:ext cx="612648" cy="402336"/>
-          </a:xfrm>
-          <a:prstGeom prst="chevron">
+          <p:cNvPr id="30" name="Shape 28"/>
+          <p:cNvSpPr/>
+          <p:nvPr/>
+        </p:nvSpPr>
+        <p:spPr>
+          <a:xfrm>
+            <a:off x="9061704" y="2176272"/>
+            <a:ext cx="1243584" cy="804672"/>
+          </a:xfrm>
+          <a:prstGeom prst="rect">
             <a:avLst/>
           </a:prstGeom>
           <a:solidFill>
             <a:srgbClr val="FFFFFF"/>
           </a:solidFill>
-          <a:ln w="13970">
+          <a:ln w="3810">
             <a:solidFill>
-              <a:srgbClr val="487052"/>
+              <a:srgbClr val="DADADA"/>
             </a:solidFill>
             <a:prstDash val="solid"/>
           </a:ln>
@@ -12315,14 +12277,14 @@
       </p:sp>
       <p:sp>
         <p:nvSpPr>
-          <p:cNvPr id="27" name="Text 25"/>
-          <p:cNvSpPr/>
-          <p:nvPr/>
-        </p:nvSpPr>
-        <p:spPr>
-          <a:xfrm>
-            <a:off x="8449056" y="2386584"/>
-            <a:ext cx="448056" cy="109728"/>
+          <p:cNvPr id="31" name="Text 29"/>
+          <p:cNvSpPr/>
+          <p:nvPr/>
+        </p:nvSpPr>
+        <p:spPr>
+          <a:xfrm>
+            <a:off x="9134856" y="2286000"/>
+            <a:ext cx="438912" cy="109728"/>
           </a:xfrm>
           <a:prstGeom prst="rect">
             <a:avLst/>
@@ -12336,11 +12298,52 @@
           </a:bodyPr>
           <a:lstStyle/>
           <a:p>
-            <a:pPr algn="ctr" indent="0" marL="0">
-              <a:buNone/>
-            </a:pPr>
-            <a:r>
-              <a:rPr lang="en-US" sz="670" b="1" dirty="0">
+            <a:pPr indent="0" marL="0">
+              <a:buNone/>
+            </a:pPr>
+            <a:r>
+              <a:rPr lang="en-US" sz="710" b="1" dirty="0">
+                <a:solidFill>
+                  <a:srgbClr val="487052"/>
+                </a:solidFill>
+                <a:latin typeface="Microsoft YaHei" pitchFamily="34" charset="0"/>
+                <a:ea typeface="Microsoft YaHei" pitchFamily="34" charset="-122"/>
+                <a:cs typeface="Microsoft YaHei" pitchFamily="34" charset="-120"/>
+              </a:rPr>
+              <a:t>路线B</a:t>
+            </a:r>
+            <a:endParaRPr lang="en-US" sz="710" dirty="0"/>
+          </a:p>
+        </p:txBody>
+      </p:sp>
+      <p:sp>
+        <p:nvSpPr>
+          <p:cNvPr id="32" name="Text 30"/>
+          <p:cNvSpPr/>
+          <p:nvPr/>
+        </p:nvSpPr>
+        <p:spPr>
+          <a:xfrm>
+            <a:off x="9134856" y="2505456"/>
+            <a:ext cx="1024128" cy="201168"/>
+          </a:xfrm>
+          <a:prstGeom prst="rect">
+            <a:avLst/>
+          </a:prstGeom>
+          <a:noFill/>
+          <a:ln/>
+        </p:spPr>
+        <p:txBody>
+          <a:bodyPr wrap="square" lIns="0" tIns="0" rIns="0" bIns="0" rtlCol="0" anchor="t">
+            <a:normAutofit/>
+          </a:bodyPr>
+          <a:lstStyle/>
+          <a:p>
+            <a:pPr indent="0" marL="0">
+              <a:buNone/>
+            </a:pPr>
+            <a:r>
+              <a:rPr lang="en-US" sz="670" dirty="0">
                 <a:solidFill>
                   <a:srgbClr val="121212"/>
                 </a:solidFill>
@@ -12348,7 +12351,7 @@
                 <a:ea typeface="Microsoft YaHei" pitchFamily="34" charset="-122"/>
                 <a:cs typeface="Microsoft YaHei" pitchFamily="34" charset="-120"/>
               </a:rPr>
-              <a:t>产品</a:t>
+              <a:t>固态电池专家提出2030年</a:t>
             </a:r>
             <a:endParaRPr lang="en-US" sz="670" dirty="0"/>
           </a:p>
@@ -12356,24 +12359,24 @@
       </p:sp>
       <p:sp>
         <p:nvSpPr>
-          <p:cNvPr id="28" name="Shape 26"/>
-          <p:cNvSpPr/>
-          <p:nvPr/>
-        </p:nvSpPr>
-        <p:spPr>
-          <a:xfrm>
-            <a:off x="8997696" y="2249424"/>
-            <a:ext cx="612648" cy="402336"/>
-          </a:xfrm>
-          <a:prstGeom prst="chevron">
+          <p:cNvPr id="33" name="Shape 31"/>
+          <p:cNvSpPr/>
+          <p:nvPr/>
+        </p:nvSpPr>
+        <p:spPr>
+          <a:xfrm>
+            <a:off x="7818120" y="2980944"/>
+            <a:ext cx="1243584" cy="804672"/>
+          </a:xfrm>
+          <a:prstGeom prst="rect">
             <a:avLst/>
           </a:prstGeom>
           <a:solidFill>
             <a:srgbClr val="FFFFFF"/>
           </a:solidFill>
-          <a:ln w="13970">
+          <a:ln w="3810">
             <a:solidFill>
-              <a:srgbClr val="487052"/>
+              <a:srgbClr val="DADADA"/>
             </a:solidFill>
             <a:prstDash val="solid"/>
           </a:ln>
@@ -12381,14 +12384,14 @@
       </p:sp>
       <p:sp>
         <p:nvSpPr>
-          <p:cNvPr id="29" name="Text 27"/>
-          <p:cNvSpPr/>
-          <p:nvPr/>
-        </p:nvSpPr>
-        <p:spPr>
-          <a:xfrm>
-            <a:off x="9070848" y="2386584"/>
-            <a:ext cx="448056" cy="109728"/>
+          <p:cNvPr id="34" name="Text 32"/>
+          <p:cNvSpPr/>
+          <p:nvPr/>
+        </p:nvSpPr>
+        <p:spPr>
+          <a:xfrm>
+            <a:off x="7891272" y="3090672"/>
+            <a:ext cx="438912" cy="109728"/>
           </a:xfrm>
           <a:prstGeom prst="rect">
             <a:avLst/>
@@ -12402,11 +12405,52 @@
           </a:bodyPr>
           <a:lstStyle/>
           <a:p>
-            <a:pPr algn="ctr" indent="0" marL="0">
-              <a:buNone/>
-            </a:pPr>
-            <a:r>
-              <a:rPr lang="en-US" sz="670" b="1" dirty="0">
+            <a:pPr indent="0" marL="0">
+              <a:buNone/>
+            </a:pPr>
+            <a:r>
+              <a:rPr lang="en-US" sz="710" b="1" dirty="0">
+                <a:solidFill>
+                  <a:srgbClr val="487052"/>
+                </a:solidFill>
+                <a:latin typeface="Microsoft YaHei" pitchFamily="34" charset="0"/>
+                <a:ea typeface="Microsoft YaHei" pitchFamily="34" charset="-122"/>
+                <a:cs typeface="Microsoft YaHei" pitchFamily="34" charset="-120"/>
+              </a:rPr>
+              <a:t>机会</a:t>
+            </a:r>
+            <a:endParaRPr lang="en-US" sz="710" dirty="0"/>
+          </a:p>
+        </p:txBody>
+      </p:sp>
+      <p:sp>
+        <p:nvSpPr>
+          <p:cNvPr id="35" name="Text 33"/>
+          <p:cNvSpPr/>
+          <p:nvPr/>
+        </p:nvSpPr>
+        <p:spPr>
+          <a:xfrm>
+            <a:off x="7891272" y="3310128"/>
+            <a:ext cx="1024128" cy="201168"/>
+          </a:xfrm>
+          <a:prstGeom prst="rect">
+            <a:avLst/>
+          </a:prstGeom>
+          <a:noFill/>
+          <a:ln/>
+        </p:spPr>
+        <p:txBody>
+          <a:bodyPr wrap="square" lIns="0" tIns="0" rIns="0" bIns="0" rtlCol="0" anchor="t">
+            <a:normAutofit/>
+          </a:bodyPr>
+          <a:lstStyle/>
+          <a:p>
+            <a:pPr indent="0" marL="0">
+              <a:buNone/>
+            </a:pPr>
+            <a:r>
+              <a:rPr lang="en-US" sz="670" dirty="0">
                 <a:solidFill>
                   <a:srgbClr val="121212"/>
                 </a:solidFill>
@@ -12414,7 +12458,7 @@
                 <a:ea typeface="Microsoft YaHei" pitchFamily="34" charset="-122"/>
                 <a:cs typeface="Microsoft YaHei" pitchFamily="34" charset="-120"/>
               </a:rPr>
-              <a:t>验证</a:t>
+              <a:t>[1][4] 宝马量产信息</a:t>
             </a:r>
             <a:endParaRPr lang="en-US" sz="670" dirty="0"/>
           </a:p>
@@ -12422,24 +12466,24 @@
       </p:sp>
       <p:sp>
         <p:nvSpPr>
-          <p:cNvPr id="30" name="Shape 28"/>
-          <p:cNvSpPr/>
-          <p:nvPr/>
-        </p:nvSpPr>
-        <p:spPr>
-          <a:xfrm>
-            <a:off x="9619488" y="2249424"/>
-            <a:ext cx="612648" cy="402336"/>
-          </a:xfrm>
-          <a:prstGeom prst="chevron">
+          <p:cNvPr id="36" name="Shape 34"/>
+          <p:cNvSpPr/>
+          <p:nvPr/>
+        </p:nvSpPr>
+        <p:spPr>
+          <a:xfrm>
+            <a:off x="9061704" y="2980944"/>
+            <a:ext cx="1243584" cy="804672"/>
+          </a:xfrm>
+          <a:prstGeom prst="rect">
             <a:avLst/>
           </a:prstGeom>
           <a:solidFill>
-            <a:srgbClr val="FFFFFF"/>
+            <a:srgbClr val="F4FAF6"/>
           </a:solidFill>
-          <a:ln w="13970">
+          <a:ln w="3810">
             <a:solidFill>
-              <a:srgbClr val="487052"/>
+              <a:srgbClr val="DADADA"/>
             </a:solidFill>
             <a:prstDash val="solid"/>
           </a:ln>
@@ -12447,14 +12491,14 @@
       </p:sp>
       <p:sp>
         <p:nvSpPr>
-          <p:cNvPr id="31" name="Text 29"/>
-          <p:cNvSpPr/>
-          <p:nvPr/>
-        </p:nvSpPr>
-        <p:spPr>
-          <a:xfrm>
-            <a:off x="9692640" y="2386584"/>
-            <a:ext cx="448056" cy="109728"/>
+          <p:cNvPr id="37" name="Text 35"/>
+          <p:cNvSpPr/>
+          <p:nvPr/>
+        </p:nvSpPr>
+        <p:spPr>
+          <a:xfrm>
+            <a:off x="9134856" y="3090672"/>
+            <a:ext cx="438912" cy="109728"/>
           </a:xfrm>
           <a:prstGeom prst="rect">
             <a:avLst/>
@@ -12468,11 +12512,52 @@
           </a:bodyPr>
           <a:lstStyle/>
           <a:p>
-            <a:pPr algn="ctr" indent="0" marL="0">
-              <a:buNone/>
-            </a:pPr>
-            <a:r>
-              <a:rPr lang="en-US" sz="670" b="1" dirty="0">
+            <a:pPr indent="0" marL="0">
+              <a:buNone/>
+            </a:pPr>
+            <a:r>
+              <a:rPr lang="en-US" sz="710" b="1" dirty="0">
+                <a:solidFill>
+                  <a:srgbClr val="487052"/>
+                </a:solidFill>
+                <a:latin typeface="Microsoft YaHei" pitchFamily="34" charset="0"/>
+                <a:ea typeface="Microsoft YaHei" pitchFamily="34" charset="-122"/>
+                <a:cs typeface="Microsoft YaHei" pitchFamily="34" charset="-120"/>
+              </a:rPr>
+              <a:t>约束</a:t>
+            </a:r>
+            <a:endParaRPr lang="en-US" sz="710" dirty="0"/>
+          </a:p>
+        </p:txBody>
+      </p:sp>
+      <p:sp>
+        <p:nvSpPr>
+          <p:cNvPr id="38" name="Text 36"/>
+          <p:cNvSpPr/>
+          <p:nvPr/>
+        </p:nvSpPr>
+        <p:spPr>
+          <a:xfrm>
+            <a:off x="9134856" y="3310128"/>
+            <a:ext cx="1024128" cy="201168"/>
+          </a:xfrm>
+          <a:prstGeom prst="rect">
+            <a:avLst/>
+          </a:prstGeom>
+          <a:noFill/>
+          <a:ln/>
+        </p:spPr>
+        <p:txBody>
+          <a:bodyPr wrap="square" lIns="0" tIns="0" rIns="0" bIns="0" rtlCol="0" anchor="t">
+            <a:normAutofit/>
+          </a:bodyPr>
+          <a:lstStyle/>
+          <a:p>
+            <a:pPr indent="0" marL="0">
+              <a:buNone/>
+            </a:pPr>
+            <a:r>
+              <a:rPr lang="en-US" sz="670" dirty="0">
                 <a:solidFill>
                   <a:srgbClr val="121212"/>
                 </a:solidFill>
@@ -12480,7 +12565,7 @@
                 <a:ea typeface="Microsoft YaHei" pitchFamily="34" charset="-122"/>
                 <a:cs typeface="Microsoft YaHei" pitchFamily="34" charset="-120"/>
               </a:rPr>
-              <a:t>量产</a:t>
+              <a:t>宝马第六代动力电池量产，强</a:t>
             </a:r>
             <a:endParaRPr lang="en-US" sz="670" dirty="0"/>
           </a:p>
@@ -12488,62 +12573,14 @@
       </p:sp>
       <p:sp>
         <p:nvSpPr>
-          <p:cNvPr id="32" name="Shape 30"/>
-          <p:cNvSpPr/>
-          <p:nvPr/>
-        </p:nvSpPr>
-        <p:spPr>
-          <a:xfrm>
-            <a:off x="7882128" y="3063240"/>
-            <a:ext cx="2331720" cy="0"/>
-          </a:xfrm>
-          <a:prstGeom prst="line">
-            <a:avLst/>
-          </a:prstGeom>
-          <a:noFill/>
-          <a:ln w="13970">
-            <a:solidFill>
-              <a:srgbClr val="7F9D84"/>
-            </a:solidFill>
-            <a:prstDash val="solid"/>
-          </a:ln>
-        </p:spPr>
-      </p:sp>
-      <p:sp>
-        <p:nvSpPr>
-          <p:cNvPr id="33" name="Shape 31"/>
-          <p:cNvSpPr/>
-          <p:nvPr/>
-        </p:nvSpPr>
-        <p:spPr>
-          <a:xfrm>
-            <a:off x="7845552" y="2962656"/>
-            <a:ext cx="164592" cy="164592"/>
-          </a:xfrm>
-          <a:prstGeom prst="ellipse">
-            <a:avLst/>
-          </a:prstGeom>
-          <a:solidFill>
-            <a:srgbClr val="487052"/>
-          </a:solidFill>
-          <a:ln w="12700">
-            <a:solidFill>
-              <a:srgbClr val="FFFFFF"/>
-            </a:solidFill>
-            <a:prstDash val="solid"/>
-          </a:ln>
-        </p:spPr>
-      </p:sp>
-      <p:sp>
-        <p:nvSpPr>
-          <p:cNvPr id="34" name="Text 32"/>
-          <p:cNvSpPr/>
-          <p:nvPr/>
-        </p:nvSpPr>
-        <p:spPr>
-          <a:xfrm>
-            <a:off x="7754112" y="3291840"/>
-            <a:ext cx="603504" cy="310896"/>
+          <p:cNvPr id="39" name="Text 37"/>
+          <p:cNvSpPr/>
+          <p:nvPr/>
+        </p:nvSpPr>
+        <p:spPr>
+          <a:xfrm>
+            <a:off x="7726680" y="4187952"/>
+            <a:ext cx="2697480" cy="493776"/>
           </a:xfrm>
           <a:prstGeom prst="rect">
             <a:avLst/>
@@ -12557,245 +12594,6 @@
           </a:bodyPr>
           <a:lstStyle/>
           <a:p>
-            <a:pPr algn="ctr" indent="0" marL="0">
-              <a:buNone/>
-            </a:pPr>
-            <a:r>
-              <a:rPr lang="en-US" sz="670" dirty="0">
-                <a:solidFill>
-                  <a:srgbClr val="121212"/>
-                </a:solidFill>
-                <a:latin typeface="Microsoft YaHei" pitchFamily="34" charset="0"/>
-                <a:ea typeface="Microsoft YaHei" pitchFamily="34" charset="-122"/>
-                <a:cs typeface="Microsoft YaHei" pitchFamily="34" charset="-120"/>
-              </a:rPr>
-              <a:t>湖南裕能投资20亿元加</a:t>
-            </a:r>
-            <a:endParaRPr lang="en-US" sz="670" dirty="0"/>
-          </a:p>
-        </p:txBody>
-      </p:sp>
-      <p:sp>
-        <p:nvSpPr>
-          <p:cNvPr id="35" name="Shape 33"/>
-          <p:cNvSpPr/>
-          <p:nvPr/>
-        </p:nvSpPr>
-        <p:spPr>
-          <a:xfrm>
-            <a:off x="8503920" y="2962656"/>
-            <a:ext cx="164592" cy="164592"/>
-          </a:xfrm>
-          <a:prstGeom prst="ellipse">
-            <a:avLst/>
-          </a:prstGeom>
-          <a:solidFill>
-            <a:srgbClr val="487052"/>
-          </a:solidFill>
-          <a:ln w="12700">
-            <a:solidFill>
-              <a:srgbClr val="FFFFFF"/>
-            </a:solidFill>
-            <a:prstDash val="solid"/>
-          </a:ln>
-        </p:spPr>
-      </p:sp>
-      <p:sp>
-        <p:nvSpPr>
-          <p:cNvPr id="36" name="Text 34"/>
-          <p:cNvSpPr/>
-          <p:nvPr/>
-        </p:nvSpPr>
-        <p:spPr>
-          <a:xfrm>
-            <a:off x="8412480" y="3291840"/>
-            <a:ext cx="603504" cy="310896"/>
-          </a:xfrm>
-          <a:prstGeom prst="rect">
-            <a:avLst/>
-          </a:prstGeom>
-          <a:noFill/>
-          <a:ln/>
-        </p:spPr>
-        <p:txBody>
-          <a:bodyPr wrap="square" lIns="0" tIns="0" rIns="0" bIns="0" rtlCol="0" anchor="t">
-            <a:normAutofit/>
-          </a:bodyPr>
-          <a:lstStyle/>
-          <a:p>
-            <a:pPr algn="ctr" indent="0" marL="0">
-              <a:buNone/>
-            </a:pPr>
-            <a:r>
-              <a:rPr lang="en-US" sz="670" dirty="0">
-                <a:solidFill>
-                  <a:srgbClr val="121212"/>
-                </a:solidFill>
-                <a:latin typeface="Microsoft YaHei" pitchFamily="34" charset="0"/>
-                <a:ea typeface="Microsoft YaHei" pitchFamily="34" charset="-122"/>
-                <a:cs typeface="Microsoft YaHei" pitchFamily="34" charset="-120"/>
-              </a:rPr>
-              <a:t>吉利开卖电芯，可能推动</a:t>
-            </a:r>
-            <a:endParaRPr lang="en-US" sz="670" dirty="0"/>
-          </a:p>
-        </p:txBody>
-      </p:sp>
-      <p:sp>
-        <p:nvSpPr>
-          <p:cNvPr id="37" name="Shape 35"/>
-          <p:cNvSpPr/>
-          <p:nvPr/>
-        </p:nvSpPr>
-        <p:spPr>
-          <a:xfrm>
-            <a:off x="9162288" y="2962656"/>
-            <a:ext cx="164592" cy="164592"/>
-          </a:xfrm>
-          <a:prstGeom prst="ellipse">
-            <a:avLst/>
-          </a:prstGeom>
-          <a:solidFill>
-            <a:srgbClr val="487052"/>
-          </a:solidFill>
-          <a:ln w="12700">
-            <a:solidFill>
-              <a:srgbClr val="FFFFFF"/>
-            </a:solidFill>
-            <a:prstDash val="solid"/>
-          </a:ln>
-        </p:spPr>
-      </p:sp>
-      <p:sp>
-        <p:nvSpPr>
-          <p:cNvPr id="38" name="Text 36"/>
-          <p:cNvSpPr/>
-          <p:nvPr/>
-        </p:nvSpPr>
-        <p:spPr>
-          <a:xfrm>
-            <a:off x="9070848" y="3291840"/>
-            <a:ext cx="603504" cy="310896"/>
-          </a:xfrm>
-          <a:prstGeom prst="rect">
-            <a:avLst/>
-          </a:prstGeom>
-          <a:noFill/>
-          <a:ln/>
-        </p:spPr>
-        <p:txBody>
-          <a:bodyPr wrap="square" lIns="0" tIns="0" rIns="0" bIns="0" rtlCol="0" anchor="t">
-            <a:normAutofit/>
-          </a:bodyPr>
-          <a:lstStyle/>
-          <a:p>
-            <a:pPr algn="ctr" indent="0" marL="0">
-              <a:buNone/>
-            </a:pPr>
-            <a:r>
-              <a:rPr lang="en-US" sz="670" dirty="0">
-                <a:solidFill>
-                  <a:srgbClr val="121212"/>
-                </a:solidFill>
-                <a:latin typeface="Microsoft YaHei" pitchFamily="34" charset="0"/>
-                <a:ea typeface="Microsoft YaHei" pitchFamily="34" charset="-122"/>
-                <a:cs typeface="Microsoft YaHei" pitchFamily="34" charset="-120"/>
-              </a:rPr>
-              <a:t>纳米磷酸铁锂可提升能量</a:t>
-            </a:r>
-            <a:endParaRPr lang="en-US" sz="670" dirty="0"/>
-          </a:p>
-        </p:txBody>
-      </p:sp>
-      <p:sp>
-        <p:nvSpPr>
-          <p:cNvPr id="39" name="Shape 37"/>
-          <p:cNvSpPr/>
-          <p:nvPr/>
-        </p:nvSpPr>
-        <p:spPr>
-          <a:xfrm>
-            <a:off x="9820656" y="2962656"/>
-            <a:ext cx="164592" cy="164592"/>
-          </a:xfrm>
-          <a:prstGeom prst="ellipse">
-            <a:avLst/>
-          </a:prstGeom>
-          <a:solidFill>
-            <a:srgbClr val="B85A4A"/>
-          </a:solidFill>
-          <a:ln w="12700">
-            <a:solidFill>
-              <a:srgbClr val="FFFFFF"/>
-            </a:solidFill>
-            <a:prstDash val="solid"/>
-          </a:ln>
-        </p:spPr>
-      </p:sp>
-      <p:sp>
-        <p:nvSpPr>
-          <p:cNvPr id="40" name="Text 38"/>
-          <p:cNvSpPr/>
-          <p:nvPr/>
-        </p:nvSpPr>
-        <p:spPr>
-          <a:xfrm>
-            <a:off x="9729216" y="3291840"/>
-            <a:ext cx="603504" cy="310896"/>
-          </a:xfrm>
-          <a:prstGeom prst="rect">
-            <a:avLst/>
-          </a:prstGeom>
-          <a:noFill/>
-          <a:ln/>
-        </p:spPr>
-        <p:txBody>
-          <a:bodyPr wrap="square" lIns="0" tIns="0" rIns="0" bIns="0" rtlCol="0" anchor="t">
-            <a:normAutofit/>
-          </a:bodyPr>
-          <a:lstStyle/>
-          <a:p>
-            <a:pPr algn="ctr" indent="0" marL="0">
-              <a:buNone/>
-            </a:pPr>
-            <a:r>
-              <a:rPr lang="en-US" sz="670" dirty="0">
-                <a:solidFill>
-                  <a:srgbClr val="121212"/>
-                </a:solidFill>
-                <a:latin typeface="Microsoft YaHei" pitchFamily="34" charset="0"/>
-                <a:ea typeface="Microsoft YaHei" pitchFamily="34" charset="-122"/>
-                <a:cs typeface="Microsoft YaHei" pitchFamily="34" charset="-120"/>
-              </a:rPr>
-              <a:t>纳米磷酸铁锂可提升能量</a:t>
-            </a:r>
-            <a:endParaRPr lang="en-US" sz="670" dirty="0"/>
-          </a:p>
-        </p:txBody>
-      </p:sp>
-      <p:sp>
-        <p:nvSpPr>
-          <p:cNvPr id="41" name="Text 39"/>
-          <p:cNvSpPr/>
-          <p:nvPr/>
-        </p:nvSpPr>
-        <p:spPr>
-          <a:xfrm>
-            <a:off x="7726680" y="4315968"/>
-            <a:ext cx="2697480" cy="384048"/>
-          </a:xfrm>
-          <a:prstGeom prst="rect">
-            <a:avLst/>
-          </a:prstGeom>
-          <a:noFill/>
-          <a:ln/>
-        </p:spPr>
-        <p:txBody>
-          <a:bodyPr wrap="square" lIns="0" tIns="0" rIns="0" bIns="0" rtlCol="0" anchor="t">
-            <a:normAutofit/>
-          </a:bodyPr>
-          <a:lstStyle/>
-          <a:p>
             <a:pPr indent="0" marL="0">
               <a:buNone/>
             </a:pPr>
@@ -12808,7 +12606,7 @@
                 <a:ea typeface="Microsoft YaHei" pitchFamily="34" charset="-122"/>
                 <a:cs typeface="Microsoft YaHei" pitchFamily="34" charset="-120"/>
               </a:rPr>
-              <a:t>参考培训 PPT 的阶段路线表达，按事件顺序拆成判断路径。</a:t>
+              <a:t>检测到对比/分类信号，用矩阵压缩呈现，不新增外部判断。</a:t>
             </a:r>
             <a:endParaRPr lang="en-US" sz="760" dirty="0"/>
           </a:p>
@@ -12816,7 +12614,7 @@
       </p:sp>
       <p:sp>
         <p:nvSpPr>
-          <p:cNvPr id="42" name="Shape 40"/>
+          <p:cNvPr id="40" name="Shape 38"/>
           <p:cNvSpPr/>
           <p:nvPr/>
         </p:nvSpPr>
@@ -12841,7 +12639,7 @@
       </p:sp>
       <p:sp>
         <p:nvSpPr>
-          <p:cNvPr id="43" name="Text 41"/>
+          <p:cNvPr id="41" name="Text 39"/>
           <p:cNvSpPr/>
           <p:nvPr/>
         </p:nvSpPr>
@@ -12880,7 +12678,7 @@
       </p:sp>
       <p:sp>
         <p:nvSpPr>
-          <p:cNvPr id="44" name="Text 42"/>
+          <p:cNvPr id="42" name="Text 40"/>
           <p:cNvSpPr/>
           <p:nvPr/>
         </p:nvSpPr>
@@ -12913,7 +12711,7 @@
                 <a:ea typeface="Microsoft YaHei" pitchFamily="34" charset="-122"/>
                 <a:cs typeface="Microsoft YaHei" pitchFamily="34" charset="-120"/>
               </a:rPr>
-              <a:t>若纳米磷酸铁锂量产成本下降，则高端车型渗透率可能提升</a:t>
+              <a:t>若宝马第六代电池确认采用磷酸铁锂或磷酸铁锰锂体系，则可能提升磷酸铁锂在高端乘用车市场的份额，跟踪指标为宝马新车型电池供应商公告和材料体系披露</a:t>
             </a:r>
             <a:endParaRPr lang="en-US" sz="1020" dirty="0"/>
           </a:p>
@@ -13062,7 +12860,7 @@
                 <a:ea typeface="Aptos" pitchFamily="34" charset="-122"/>
                 <a:cs typeface="Aptos" pitchFamily="34" charset="-120"/>
               </a:rPr>
-              <a:t>2026-10-12</a:t>
+              <a:t>2026-10-19</a:t>
             </a:r>
             <a:endParaRPr lang="en-US" sz="800" dirty="0"/>
           </a:p>
@@ -13268,7 +13066,7 @@
                 <a:ea typeface="Microsoft YaHei" pitchFamily="34" charset="-122"/>
                 <a:cs typeface="Microsoft YaHei" pitchFamily="34" charset="-120"/>
               </a:rPr>
-              <a:t>3 条公开来源交叉验证｜事实、影响与后续研判</a:t>
+              <a:t>2 条公开来源交叉验证｜事实、影响与后续研判</a:t>
             </a:r>
             <a:endParaRPr lang="en-US" sz="860" dirty="0"/>
           </a:p>
@@ -13377,7 +13175,7 @@
                 <a:ea typeface="Microsoft YaHei" pitchFamily="34" charset="-122"/>
                 <a:cs typeface="Microsoft YaHei" pitchFamily="34" charset="-120"/>
               </a:rPr>
-              <a:t>龙蟠科技锁定最高56.78万吨磷酸铁锂供货长协，湖南裕能20万吨项目落地，产能与订单同步扩张；华盛锂电差异化权益分派法律意见书发布，资本运作活跃。长协锁定反映下游对供应稳定的需求，但需关注实际执行率。 [2][1][6]</a:t>
+              <a:t>中国储能电池产能激增110%，全球市场同步增长，显示储能端对磷酸铁锂需求形成支撑；全国首批锂+钠示范落地河北，大电芯路线推进，可能加剧储能电池技术路线竞争，磷酸铁锂需关注在储能场景的份额变化。 [2][5]</a:t>
             </a:r>
             <a:endParaRPr lang="en-US" sz="960" dirty="0"/>
           </a:p>
@@ -13418,7 +13216,7 @@
                 <a:ea typeface="Aptos" pitchFamily="34" charset="-122"/>
                 <a:cs typeface="Aptos" pitchFamily="34" charset="-120"/>
               </a:rPr>
-              <a:t>依据：[2][1][6]</a:t>
+              <a:t>依据：[2][5]</a:t>
             </a:r>
             <a:endParaRPr lang="en-US" sz="740" dirty="0"/>
           </a:p>
@@ -13527,7 +13325,7 @@
                 <a:ea typeface="Microsoft YaHei" pitchFamily="34" charset="-122"/>
                 <a:cs typeface="Microsoft YaHei" pitchFamily="34" charset="-120"/>
               </a:rPr>
-              <a:t>龙蟠科技长协规模较大，若完全执行将显著提升其市场份额；湖南裕能扩产可能加剧供给过剩风险。华盛锂电法律意见书或预示后续资本动作。需验证：长协定价机制、项目投产时间、华盛锂电分派目的。</a:t>
+              <a:t>储能电池产能激增信息来自VOI.ID，锂+钠示范项目来自搜狐，两者均涉及储能电池供给格局。产能激增可能带动磷酸铁锂正极材料需求，但锂+钠示范项目意味着钠离子电池在储能场景的替代尝试，可能分流部分低端储能需求。需验证储能电池产能激增的实际开工率和订单来源，以及锂+钠示范项目的规模和商业化时间表。</a:t>
             </a:r>
             <a:endParaRPr lang="en-US" sz="960" dirty="0"/>
           </a:p>
@@ -13661,7 +13459,7 @@
                 <a:ea typeface="Microsoft YaHei" pitchFamily="34" charset="-122"/>
                 <a:cs typeface="Microsoft YaHei" pitchFamily="34" charset="-120"/>
               </a:rPr>
-              <a:t>若长协执行率高于预期，则龙蟠科技营收确定性增强；若湖南裕能项目按期投产，则行业供给压力可能加大。跟踪指标：龙蟠科技季度出货量、湖南裕能项目进度。</a:t>
+              <a:t>若储能电池产能激增伴随开工率维持高位，则可能持续拉动磷酸铁锂正极材料需求，跟踪指标为储能电池月度产量、出口数据和磷酸铁锂正极材料开工率；若锂+钠示范项目在储能场景实现规模化应用，则可能对磷酸铁锂在低端储能市场的份额形成挤压，跟踪指标为钠离子电池储能项目招标规模和成本对比。证据边界限于公开报道，未覆盖具体企业订单和产能利用率数据。</a:t>
             </a:r>
             <a:endParaRPr lang="en-US" sz="960" dirty="0"/>
           </a:p>
@@ -13729,7 +13527,7 @@
                 <a:ea typeface="Microsoft YaHei" pitchFamily="34" charset="-122"/>
                 <a:cs typeface="Microsoft YaHei" pitchFamily="34" charset="-120"/>
               </a:rPr>
-              <a:t>对比矩阵</a:t>
+              <a:t>关键数据解读</a:t>
             </a:r>
             <a:endParaRPr lang="en-US" sz="1200" dirty="0"/>
           </a:p>
@@ -13743,16 +13541,18 @@
         </p:nvSpPr>
         <p:spPr>
           <a:xfrm>
-            <a:off x="7818120" y="2176272"/>
-            <a:ext cx="2487168" cy="1609344"/>
-          </a:xfrm>
-          <a:prstGeom prst="rect">
-            <a:avLst/>
+            <a:off x="7772400" y="1993392"/>
+            <a:ext cx="2560320" cy="1389888"/>
+          </a:xfrm>
+          <a:prstGeom prst="roundRect">
+            <a:avLst>
+              <a:gd name="adj" fmla="val 2632"/>
+            </a:avLst>
           </a:prstGeom>
           <a:solidFill>
-            <a:srgbClr val="FFFFFF"/>
+            <a:srgbClr val="F4FAF6"/>
           </a:solidFill>
-          <a:ln w="10160">
+          <a:ln w="7620">
             <a:solidFill>
               <a:srgbClr val="DADADA"/>
             </a:solidFill>
@@ -13762,74 +13562,126 @@
       </p:sp>
       <p:sp>
         <p:nvSpPr>
-          <p:cNvPr id="25" name="Shape 23"/>
-          <p:cNvSpPr/>
-          <p:nvPr/>
-        </p:nvSpPr>
-        <p:spPr>
-          <a:xfrm>
-            <a:off x="9061704" y="2176272"/>
-            <a:ext cx="0" cy="1609344"/>
-          </a:xfrm>
-          <a:prstGeom prst="line">
-            <a:avLst/>
-          </a:prstGeom>
-          <a:noFill/>
-          <a:ln w="8890">
-            <a:solidFill>
-              <a:srgbClr val="DADADA"/>
-            </a:solidFill>
-            <a:prstDash val="solid"/>
-          </a:ln>
-        </p:spPr>
-      </p:sp>
-      <p:sp>
-        <p:nvSpPr>
-          <p:cNvPr id="26" name="Shape 24"/>
-          <p:cNvSpPr/>
-          <p:nvPr/>
-        </p:nvSpPr>
-        <p:spPr>
-          <a:xfrm>
-            <a:off x="7818120" y="2980944"/>
-            <a:ext cx="2487168" cy="0"/>
-          </a:xfrm>
-          <a:prstGeom prst="line">
-            <a:avLst/>
-          </a:prstGeom>
-          <a:noFill/>
-          <a:ln w="8890">
-            <a:solidFill>
-              <a:srgbClr val="DADADA"/>
-            </a:solidFill>
-            <a:prstDash val="solid"/>
-          </a:ln>
-        </p:spPr>
-      </p:sp>
-      <p:sp>
-        <p:nvSpPr>
-          <p:cNvPr id="27" name="Shape 25"/>
-          <p:cNvSpPr/>
-          <p:nvPr/>
-        </p:nvSpPr>
-        <p:spPr>
-          <a:xfrm>
-            <a:off x="7818120" y="2176272"/>
-            <a:ext cx="1243584" cy="804672"/>
-          </a:xfrm>
-          <a:prstGeom prst="rect">
-            <a:avLst/>
-          </a:prstGeom>
-          <a:solidFill>
-            <a:srgbClr val="DDEBE0"/>
-          </a:solidFill>
-          <a:ln w="3810">
-            <a:solidFill>
-              <a:srgbClr val="DADADA"/>
-            </a:solidFill>
-            <a:prstDash val="solid"/>
-          </a:ln>
-        </p:spPr>
+          <p:cNvPr id="25" name="Text 23"/>
+          <p:cNvSpPr/>
+          <p:nvPr/>
+        </p:nvSpPr>
+        <p:spPr>
+          <a:xfrm>
+            <a:off x="7918704" y="2103120"/>
+            <a:ext cx="822960" cy="384048"/>
+          </a:xfrm>
+          <a:prstGeom prst="rect">
+            <a:avLst/>
+          </a:prstGeom>
+          <a:noFill/>
+          <a:ln/>
+        </p:spPr>
+        <p:txBody>
+          <a:bodyPr wrap="square" lIns="0" tIns="0" rIns="0" bIns="0" rtlCol="0" anchor="ctr">
+            <a:normAutofit/>
+          </a:bodyPr>
+          <a:lstStyle/>
+          <a:p>
+            <a:pPr indent="0" marL="0">
+              <a:buNone/>
+            </a:pPr>
+            <a:r>
+              <a:rPr lang="en-US" sz="2100" b="1" dirty="0">
+                <a:solidFill>
+                  <a:srgbClr val="487052"/>
+                </a:solidFill>
+                <a:latin typeface="Aptos" pitchFamily="34" charset="0"/>
+                <a:ea typeface="Aptos" pitchFamily="34" charset="-122"/>
+                <a:cs typeface="Aptos" pitchFamily="34" charset="-120"/>
+              </a:rPr>
+              <a:t>10%</a:t>
+            </a:r>
+            <a:endParaRPr lang="en-US" sz="2100" dirty="0"/>
+          </a:p>
+        </p:txBody>
+      </p:sp>
+      <p:sp>
+        <p:nvSpPr>
+          <p:cNvPr id="26" name="Text 24"/>
+          <p:cNvSpPr/>
+          <p:nvPr/>
+        </p:nvSpPr>
+        <p:spPr>
+          <a:xfrm>
+            <a:off x="8759952" y="2167128"/>
+            <a:ext cx="1371600" cy="201168"/>
+          </a:xfrm>
+          <a:prstGeom prst="rect">
+            <a:avLst/>
+          </a:prstGeom>
+          <a:noFill/>
+          <a:ln/>
+        </p:spPr>
+        <p:txBody>
+          <a:bodyPr wrap="square" lIns="0" tIns="0" rIns="0" bIns="0" rtlCol="0" anchor="ctr">
+            <a:normAutofit/>
+          </a:bodyPr>
+          <a:lstStyle/>
+          <a:p>
+            <a:pPr indent="0" marL="0">
+              <a:buNone/>
+            </a:pPr>
+            <a:r>
+              <a:rPr lang="en-US" sz="820" b="1" dirty="0">
+                <a:solidFill>
+                  <a:srgbClr val="121212"/>
+                </a:solidFill>
+                <a:latin typeface="Microsoft YaHei" pitchFamily="34" charset="0"/>
+                <a:ea typeface="Microsoft YaHei" pitchFamily="34" charset="-122"/>
+                <a:cs typeface="Microsoft YaHei" pitchFamily="34" charset="-120"/>
+              </a:rPr>
+              <a:t>中国储能电池产能激增1</a:t>
+            </a:r>
+            <a:endParaRPr lang="en-US" sz="820" dirty="0"/>
+          </a:p>
+        </p:txBody>
+      </p:sp>
+      <p:sp>
+        <p:nvSpPr>
+          <p:cNvPr id="27" name="Text 25"/>
+          <p:cNvSpPr/>
+          <p:nvPr/>
+        </p:nvSpPr>
+        <p:spPr>
+          <a:xfrm>
+            <a:off x="7918704" y="2578608"/>
+            <a:ext cx="2176272" cy="512064"/>
+          </a:xfrm>
+          <a:prstGeom prst="rect">
+            <a:avLst/>
+          </a:prstGeom>
+          <a:noFill/>
+          <a:ln/>
+        </p:spPr>
+        <p:txBody>
+          <a:bodyPr wrap="square" lIns="0" tIns="0" rIns="0" bIns="0" rtlCol="0" anchor="t">
+            <a:normAutofit/>
+          </a:bodyPr>
+          <a:lstStyle/>
+          <a:p>
+            <a:pPr indent="0" marL="0">
+              <a:buNone/>
+            </a:pPr>
+            <a:r>
+              <a:rPr lang="en-US" sz="840" dirty="0">
+                <a:solidFill>
+                  <a:srgbClr val="121212"/>
+                </a:solidFill>
+                <a:latin typeface="Microsoft YaHei" pitchFamily="34" charset="0"/>
+                <a:ea typeface="Microsoft YaHei" pitchFamily="34" charset="-122"/>
+                <a:cs typeface="Microsoft YaHei" pitchFamily="34" charset="-120"/>
+              </a:rPr>
+              <a:t>公开信息：中国储能电池产能激增110%，全球市场同步增长，显示储能端对磷酸铁锂需求形成支撑</a:t>
+            </a:r>
+            <a:endParaRPr lang="en-US" sz="840" dirty="0"/>
+          </a:p>
+        </p:txBody>
       </p:sp>
       <p:sp>
         <p:nvSpPr>
@@ -13839,49 +13691,8 @@
         </p:nvSpPr>
         <p:spPr>
           <a:xfrm>
-            <a:off x="7891272" y="2286000"/>
-            <a:ext cx="438912" cy="109728"/>
-          </a:xfrm>
-          <a:prstGeom prst="rect">
-            <a:avLst/>
-          </a:prstGeom>
-          <a:noFill/>
-          <a:ln/>
-        </p:spPr>
-        <p:txBody>
-          <a:bodyPr wrap="square" lIns="0" tIns="0" rIns="0" bIns="0" rtlCol="0" anchor="ctr">
-            <a:normAutofit/>
-          </a:bodyPr>
-          <a:lstStyle/>
-          <a:p>
-            <a:pPr indent="0" marL="0">
-              <a:buNone/>
-            </a:pPr>
-            <a:r>
-              <a:rPr lang="en-US" sz="710" b="1" dirty="0">
-                <a:solidFill>
-                  <a:srgbClr val="487052"/>
-                </a:solidFill>
-                <a:latin typeface="Microsoft YaHei" pitchFamily="34" charset="0"/>
-                <a:ea typeface="Microsoft YaHei" pitchFamily="34" charset="-122"/>
-                <a:cs typeface="Microsoft YaHei" pitchFamily="34" charset="-120"/>
-              </a:rPr>
-              <a:t>路线A</a:t>
-            </a:r>
-            <a:endParaRPr lang="en-US" sz="710" dirty="0"/>
-          </a:p>
-        </p:txBody>
-      </p:sp>
-      <p:sp>
-        <p:nvSpPr>
-          <p:cNvPr id="29" name="Text 27"/>
-          <p:cNvSpPr/>
-          <p:nvPr/>
-        </p:nvSpPr>
-        <p:spPr>
-          <a:xfrm>
-            <a:off x="7891272" y="2505456"/>
-            <a:ext cx="1024128" cy="201168"/>
+            <a:off x="7772400" y="4498848"/>
+            <a:ext cx="2560320" cy="384048"/>
           </a:xfrm>
           <a:prstGeom prst="rect">
             <a:avLst/>
@@ -13899,369 +13710,7 @@
               <a:buNone/>
             </a:pPr>
             <a:r>
-              <a:rPr lang="en-US" sz="670" dirty="0">
-                <a:solidFill>
-                  <a:srgbClr val="121212"/>
-                </a:solidFill>
-                <a:latin typeface="Microsoft YaHei" pitchFamily="34" charset="0"/>
-                <a:ea typeface="Microsoft YaHei" pitchFamily="34" charset="-122"/>
-                <a:cs typeface="Microsoft YaHei" pitchFamily="34" charset="-120"/>
-              </a:rPr>
-              <a:t>龙蟠科技锁定最高56.78</a:t>
-            </a:r>
-            <a:endParaRPr lang="en-US" sz="670" dirty="0"/>
-          </a:p>
-        </p:txBody>
-      </p:sp>
-      <p:sp>
-        <p:nvSpPr>
-          <p:cNvPr id="30" name="Shape 28"/>
-          <p:cNvSpPr/>
-          <p:nvPr/>
-        </p:nvSpPr>
-        <p:spPr>
-          <a:xfrm>
-            <a:off x="9061704" y="2176272"/>
-            <a:ext cx="1243584" cy="804672"/>
-          </a:xfrm>
-          <a:prstGeom prst="rect">
-            <a:avLst/>
-          </a:prstGeom>
-          <a:solidFill>
-            <a:srgbClr val="FFFFFF"/>
-          </a:solidFill>
-          <a:ln w="3810">
-            <a:solidFill>
-              <a:srgbClr val="DADADA"/>
-            </a:solidFill>
-            <a:prstDash val="solid"/>
-          </a:ln>
-        </p:spPr>
-      </p:sp>
-      <p:sp>
-        <p:nvSpPr>
-          <p:cNvPr id="31" name="Text 29"/>
-          <p:cNvSpPr/>
-          <p:nvPr/>
-        </p:nvSpPr>
-        <p:spPr>
-          <a:xfrm>
-            <a:off x="9134856" y="2286000"/>
-            <a:ext cx="438912" cy="109728"/>
-          </a:xfrm>
-          <a:prstGeom prst="rect">
-            <a:avLst/>
-          </a:prstGeom>
-          <a:noFill/>
-          <a:ln/>
-        </p:spPr>
-        <p:txBody>
-          <a:bodyPr wrap="square" lIns="0" tIns="0" rIns="0" bIns="0" rtlCol="0" anchor="ctr">
-            <a:normAutofit/>
-          </a:bodyPr>
-          <a:lstStyle/>
-          <a:p>
-            <a:pPr indent="0" marL="0">
-              <a:buNone/>
-            </a:pPr>
-            <a:r>
-              <a:rPr lang="en-US" sz="710" b="1" dirty="0">
-                <a:solidFill>
-                  <a:srgbClr val="487052"/>
-                </a:solidFill>
-                <a:latin typeface="Microsoft YaHei" pitchFamily="34" charset="0"/>
-                <a:ea typeface="Microsoft YaHei" pitchFamily="34" charset="-122"/>
-                <a:cs typeface="Microsoft YaHei" pitchFamily="34" charset="-120"/>
-              </a:rPr>
-              <a:t>路线B</a:t>
-            </a:r>
-            <a:endParaRPr lang="en-US" sz="710" dirty="0"/>
-          </a:p>
-        </p:txBody>
-      </p:sp>
-      <p:sp>
-        <p:nvSpPr>
-          <p:cNvPr id="32" name="Text 30"/>
-          <p:cNvSpPr/>
-          <p:nvPr/>
-        </p:nvSpPr>
-        <p:spPr>
-          <a:xfrm>
-            <a:off x="9134856" y="2505456"/>
-            <a:ext cx="1024128" cy="201168"/>
-          </a:xfrm>
-          <a:prstGeom prst="rect">
-            <a:avLst/>
-          </a:prstGeom>
-          <a:noFill/>
-          <a:ln/>
-        </p:spPr>
-        <p:txBody>
-          <a:bodyPr wrap="square" lIns="0" tIns="0" rIns="0" bIns="0" rtlCol="0" anchor="t">
-            <a:normAutofit/>
-          </a:bodyPr>
-          <a:lstStyle/>
-          <a:p>
-            <a:pPr indent="0" marL="0">
-              <a:buNone/>
-            </a:pPr>
-            <a:r>
-              <a:rPr lang="en-US" sz="670" dirty="0">
-                <a:solidFill>
-                  <a:srgbClr val="121212"/>
-                </a:solidFill>
-                <a:latin typeface="Microsoft YaHei" pitchFamily="34" charset="0"/>
-                <a:ea typeface="Microsoft YaHei" pitchFamily="34" charset="-122"/>
-                <a:cs typeface="Microsoft YaHei" pitchFamily="34" charset="-120"/>
-              </a:rPr>
-              <a:t>华盛锂电差异化权益分派法律</a:t>
-            </a:r>
-            <a:endParaRPr lang="en-US" sz="670" dirty="0"/>
-          </a:p>
-        </p:txBody>
-      </p:sp>
-      <p:sp>
-        <p:nvSpPr>
-          <p:cNvPr id="33" name="Shape 31"/>
-          <p:cNvSpPr/>
-          <p:nvPr/>
-        </p:nvSpPr>
-        <p:spPr>
-          <a:xfrm>
-            <a:off x="7818120" y="2980944"/>
-            <a:ext cx="1243584" cy="804672"/>
-          </a:xfrm>
-          <a:prstGeom prst="rect">
-            <a:avLst/>
-          </a:prstGeom>
-          <a:solidFill>
-            <a:srgbClr val="FFFFFF"/>
-          </a:solidFill>
-          <a:ln w="3810">
-            <a:solidFill>
-              <a:srgbClr val="DADADA"/>
-            </a:solidFill>
-            <a:prstDash val="solid"/>
-          </a:ln>
-        </p:spPr>
-      </p:sp>
-      <p:sp>
-        <p:nvSpPr>
-          <p:cNvPr id="34" name="Text 32"/>
-          <p:cNvSpPr/>
-          <p:nvPr/>
-        </p:nvSpPr>
-        <p:spPr>
-          <a:xfrm>
-            <a:off x="7891272" y="3090672"/>
-            <a:ext cx="438912" cy="109728"/>
-          </a:xfrm>
-          <a:prstGeom prst="rect">
-            <a:avLst/>
-          </a:prstGeom>
-          <a:noFill/>
-          <a:ln/>
-        </p:spPr>
-        <p:txBody>
-          <a:bodyPr wrap="square" lIns="0" tIns="0" rIns="0" bIns="0" rtlCol="0" anchor="ctr">
-            <a:normAutofit/>
-          </a:bodyPr>
-          <a:lstStyle/>
-          <a:p>
-            <a:pPr indent="0" marL="0">
-              <a:buNone/>
-            </a:pPr>
-            <a:r>
-              <a:rPr lang="en-US" sz="710" b="1" dirty="0">
-                <a:solidFill>
-                  <a:srgbClr val="487052"/>
-                </a:solidFill>
-                <a:latin typeface="Microsoft YaHei" pitchFamily="34" charset="0"/>
-                <a:ea typeface="Microsoft YaHei" pitchFamily="34" charset="-122"/>
-                <a:cs typeface="Microsoft YaHei" pitchFamily="34" charset="-120"/>
-              </a:rPr>
-              <a:t>机会</a:t>
-            </a:r>
-            <a:endParaRPr lang="en-US" sz="710" dirty="0"/>
-          </a:p>
-        </p:txBody>
-      </p:sp>
-      <p:sp>
-        <p:nvSpPr>
-          <p:cNvPr id="35" name="Text 33"/>
-          <p:cNvSpPr/>
-          <p:nvPr/>
-        </p:nvSpPr>
-        <p:spPr>
-          <a:xfrm>
-            <a:off x="7891272" y="3310128"/>
-            <a:ext cx="1024128" cy="201168"/>
-          </a:xfrm>
-          <a:prstGeom prst="rect">
-            <a:avLst/>
-          </a:prstGeom>
-          <a:noFill/>
-          <a:ln/>
-        </p:spPr>
-        <p:txBody>
-          <a:bodyPr wrap="square" lIns="0" tIns="0" rIns="0" bIns="0" rtlCol="0" anchor="t">
-            <a:normAutofit/>
-          </a:bodyPr>
-          <a:lstStyle/>
-          <a:p>
-            <a:pPr indent="0" marL="0">
-              <a:buNone/>
-            </a:pPr>
-            <a:r>
-              <a:rPr lang="en-US" sz="670" dirty="0">
-                <a:solidFill>
-                  <a:srgbClr val="121212"/>
-                </a:solidFill>
-                <a:latin typeface="Microsoft YaHei" pitchFamily="34" charset="0"/>
-                <a:ea typeface="Microsoft YaHei" pitchFamily="34" charset="-122"/>
-                <a:cs typeface="Microsoft YaHei" pitchFamily="34" charset="-120"/>
-              </a:rPr>
-              <a:t>长协锁定反映下游对供应稳定</a:t>
-            </a:r>
-            <a:endParaRPr lang="en-US" sz="670" dirty="0"/>
-          </a:p>
-        </p:txBody>
-      </p:sp>
-      <p:sp>
-        <p:nvSpPr>
-          <p:cNvPr id="36" name="Shape 34"/>
-          <p:cNvSpPr/>
-          <p:nvPr/>
-        </p:nvSpPr>
-        <p:spPr>
-          <a:xfrm>
-            <a:off x="9061704" y="2980944"/>
-            <a:ext cx="1243584" cy="804672"/>
-          </a:xfrm>
-          <a:prstGeom prst="rect">
-            <a:avLst/>
-          </a:prstGeom>
-          <a:solidFill>
-            <a:srgbClr val="F4FAF6"/>
-          </a:solidFill>
-          <a:ln w="3810">
-            <a:solidFill>
-              <a:srgbClr val="DADADA"/>
-            </a:solidFill>
-            <a:prstDash val="solid"/>
-          </a:ln>
-        </p:spPr>
-      </p:sp>
-      <p:sp>
-        <p:nvSpPr>
-          <p:cNvPr id="37" name="Text 35"/>
-          <p:cNvSpPr/>
-          <p:nvPr/>
-        </p:nvSpPr>
-        <p:spPr>
-          <a:xfrm>
-            <a:off x="9134856" y="3090672"/>
-            <a:ext cx="438912" cy="109728"/>
-          </a:xfrm>
-          <a:prstGeom prst="rect">
-            <a:avLst/>
-          </a:prstGeom>
-          <a:noFill/>
-          <a:ln/>
-        </p:spPr>
-        <p:txBody>
-          <a:bodyPr wrap="square" lIns="0" tIns="0" rIns="0" bIns="0" rtlCol="0" anchor="ctr">
-            <a:normAutofit/>
-          </a:bodyPr>
-          <a:lstStyle/>
-          <a:p>
-            <a:pPr indent="0" marL="0">
-              <a:buNone/>
-            </a:pPr>
-            <a:r>
-              <a:rPr lang="en-US" sz="710" b="1" dirty="0">
-                <a:solidFill>
-                  <a:srgbClr val="487052"/>
-                </a:solidFill>
-                <a:latin typeface="Microsoft YaHei" pitchFamily="34" charset="0"/>
-                <a:ea typeface="Microsoft YaHei" pitchFamily="34" charset="-122"/>
-                <a:cs typeface="Microsoft YaHei" pitchFamily="34" charset="-120"/>
-              </a:rPr>
-              <a:t>约束</a:t>
-            </a:r>
-            <a:endParaRPr lang="en-US" sz="710" dirty="0"/>
-          </a:p>
-        </p:txBody>
-      </p:sp>
-      <p:sp>
-        <p:nvSpPr>
-          <p:cNvPr id="38" name="Text 36"/>
-          <p:cNvSpPr/>
-          <p:nvPr/>
-        </p:nvSpPr>
-        <p:spPr>
-          <a:xfrm>
-            <a:off x="9134856" y="3310128"/>
-            <a:ext cx="1024128" cy="201168"/>
-          </a:xfrm>
-          <a:prstGeom prst="rect">
-            <a:avLst/>
-          </a:prstGeom>
-          <a:noFill/>
-          <a:ln/>
-        </p:spPr>
-        <p:txBody>
-          <a:bodyPr wrap="square" lIns="0" tIns="0" rIns="0" bIns="0" rtlCol="0" anchor="t">
-            <a:normAutofit/>
-          </a:bodyPr>
-          <a:lstStyle/>
-          <a:p>
-            <a:pPr indent="0" marL="0">
-              <a:buNone/>
-            </a:pPr>
-            <a:r>
-              <a:rPr lang="en-US" sz="670" dirty="0">
-                <a:solidFill>
-                  <a:srgbClr val="121212"/>
-                </a:solidFill>
-                <a:latin typeface="Microsoft YaHei" pitchFamily="34" charset="0"/>
-                <a:ea typeface="Microsoft YaHei" pitchFamily="34" charset="-122"/>
-                <a:cs typeface="Microsoft YaHei" pitchFamily="34" charset="-120"/>
-              </a:rPr>
-              <a:t>龙蟠科技锁定最高56.78</a:t>
-            </a:r>
-            <a:endParaRPr lang="en-US" sz="670" dirty="0"/>
-          </a:p>
-        </p:txBody>
-      </p:sp>
-      <p:sp>
-        <p:nvSpPr>
-          <p:cNvPr id="39" name="Text 37"/>
-          <p:cNvSpPr/>
-          <p:nvPr/>
-        </p:nvSpPr>
-        <p:spPr>
-          <a:xfrm>
-            <a:off x="7726680" y="4187952"/>
-            <a:ext cx="2697480" cy="493776"/>
-          </a:xfrm>
-          <a:prstGeom prst="rect">
-            <a:avLst/>
-          </a:prstGeom>
-          <a:noFill/>
-          <a:ln/>
-        </p:spPr>
-        <p:txBody>
-          <a:bodyPr wrap="square" lIns="0" tIns="0" rIns="0" bIns="0" rtlCol="0" anchor="t">
-            <a:normAutofit/>
-          </a:bodyPr>
-          <a:lstStyle/>
-          <a:p>
-            <a:pPr indent="0" marL="0">
-              <a:buNone/>
-            </a:pPr>
-            <a:r>
-              <a:rPr lang="en-US" sz="760" dirty="0">
+              <a:rPr lang="en-US" sz="800" dirty="0">
                 <a:solidFill>
                   <a:srgbClr val="6D756F"/>
                 </a:solidFill>
@@ -14269,15 +13718,15 @@
                 <a:ea typeface="Microsoft YaHei" pitchFamily="34" charset="-122"/>
                 <a:cs typeface="Microsoft YaHei" pitchFamily="34" charset="-120"/>
               </a:rPr>
-              <a:t>检测到对比/分类信号，用矩阵压缩呈现，不新增外部判断。</a:t>
-            </a:r>
-            <a:endParaRPr lang="en-US" sz="760" dirty="0"/>
-          </a:p>
-        </p:txBody>
-      </p:sp>
-      <p:sp>
-        <p:nvSpPr>
-          <p:cNvPr id="40" name="Shape 38"/>
+              <a:t>阅读提示：仅按公开报道原文呈现；不同企业、时间和统计范围不可直接横向比较。</a:t>
+            </a:r>
+            <a:endParaRPr lang="en-US" sz="800" dirty="0"/>
+          </a:p>
+        </p:txBody>
+      </p:sp>
+      <p:sp>
+        <p:nvSpPr>
+          <p:cNvPr id="29" name="Shape 27"/>
           <p:cNvSpPr/>
           <p:nvPr/>
         </p:nvSpPr>
@@ -14302,7 +13751,7 @@
       </p:sp>
       <p:sp>
         <p:nvSpPr>
-          <p:cNvPr id="41" name="Text 39"/>
+          <p:cNvPr id="30" name="Text 28"/>
           <p:cNvSpPr/>
           <p:nvPr/>
         </p:nvSpPr>
@@ -14341,7 +13790,7 @@
       </p:sp>
       <p:sp>
         <p:nvSpPr>
-          <p:cNvPr id="42" name="Text 40"/>
+          <p:cNvPr id="31" name="Text 29"/>
           <p:cNvSpPr/>
           <p:nvPr/>
         </p:nvSpPr>
@@ -14374,7 +13823,7 @@
                 <a:ea typeface="Microsoft YaHei" pitchFamily="34" charset="-122"/>
                 <a:cs typeface="Microsoft YaHei" pitchFamily="34" charset="-120"/>
               </a:rPr>
-              <a:t>若长协执行率高于预期，则龙蟠科技营收确定性增强</a:t>
+              <a:t>若储能电池产能激增伴随开工率维持高位，则可能持续拉动磷酸铁锂正极材料需求，跟踪指标为储能电池月度产量、出口数据和磷酸铁锂正极材料开工率</a:t>
             </a:r>
             <a:endParaRPr lang="en-US" sz="1020" dirty="0"/>
           </a:p>
@@ -14523,7 +13972,7 @@
                 <a:ea typeface="Aptos" pitchFamily="34" charset="-122"/>
                 <a:cs typeface="Aptos" pitchFamily="34" charset="-120"/>
               </a:rPr>
-              <a:t>2026-10-12</a:t>
+              <a:t>2026-10-19</a:t>
             </a:r>
             <a:endParaRPr lang="en-US" sz="800" dirty="0"/>
           </a:p>
@@ -14838,7 +14287,7 @@
                 <a:ea typeface="Microsoft YaHei" pitchFamily="34" charset="-122"/>
                 <a:cs typeface="Microsoft YaHei" pitchFamily="34" charset="-120"/>
               </a:rPr>
-              <a:t>碳酸锂价格暴跌近90%，动力电池回收行业进入洗牌深水区；电池板块跌幅居前，反映价格下行压力。成本端坍塌削弱磷酸铁锂价格支撑，回收企业退出可能加速，但上游材料企业盈利分化。 [3][7]</a:t>
+              <a:t>储能电池产能激增110%可能加剧行业供给竞争，对磷酸铁锂正极材料价格形成压制；电动摩托车锂电池强制性国标发布，可能提高小动力电池合规成本，推动低端产能出清，短期对磷酸铁锂价格影响有限。 [2][3]</a:t>
             </a:r>
             <a:endParaRPr lang="en-US" sz="960" dirty="0"/>
           </a:p>
@@ -14879,7 +14328,7 @@
                 <a:ea typeface="Aptos" pitchFamily="34" charset="-122"/>
                 <a:cs typeface="Aptos" pitchFamily="34" charset="-120"/>
               </a:rPr>
-              <a:t>依据：[3][7]</a:t>
+              <a:t>依据：[2][3]</a:t>
             </a:r>
             <a:endParaRPr lang="en-US" sz="740" dirty="0"/>
           </a:p>
@@ -14988,7 +14437,7 @@
                 <a:ea typeface="Microsoft YaHei" pitchFamily="34" charset="-122"/>
                 <a:cs typeface="Microsoft YaHei" pitchFamily="34" charset="-120"/>
               </a:rPr>
-              <a:t>碳酸锂价格暴跌直接降低磷酸铁锂生产成本，但产品价格同步下行，企业盈利取决于成本传导能力；回收行业洗牌可能减少再生碳酸锂供应，长期或影响原料结构。需验证：碳酸锂现货价拐点、回收企业退出规模。</a:t>
+              <a:t>储能产能激增信息来自VOI.ID，电摩国标信息来自温州新闻，两者分别从供给扩张和合规成本角度影响盈利。储能产能快速扩张可能导致电池环节价格竞争加剧，向上传导至磷酸铁锂正极材料价格；电摩国标提高安全门槛，可能增加小动力电池企业合规成本，加速低端产能退出。需验证储能电池实际价格走势和电摩国标执行力度。</a:t>
             </a:r>
             <a:endParaRPr lang="en-US" sz="960" dirty="0"/>
           </a:p>
@@ -15122,7 +14571,7 @@
                 <a:ea typeface="Microsoft YaHei" pitchFamily="34" charset="-122"/>
                 <a:cs typeface="Microsoft YaHei" pitchFamily="34" charset="-120"/>
               </a:rPr>
-              <a:t>若碳酸锂价格继续下跌，则磷酸铁锂价格可能进一步承压，高成本产能或退出；若回收行业洗牌导致再生供应减少，则长期碳酸锂供给结构可能变化。跟踪指标：碳酸锂现货价、回收企业开工率。</a:t>
+              <a:t>若储能电池产能利用率不足且价格竞争加剧，则可能传导至磷酸铁锂正极材料价格承压，跟踪指标为储能电池月度均价和磷酸铁锂正极材料报价；若电摩国标执行严格且合规成本上升，则可能加速小动力电池行业集中度提升，跟踪指标为电摩电池企业认证通过率和退出数量。证据边界限于公开报道，未覆盖具体价格数据和成本测算。</a:t>
             </a:r>
             <a:endParaRPr lang="en-US" sz="960" dirty="0"/>
           </a:p>
@@ -15258,7 +14707,7 @@
                 <a:ea typeface="Aptos" pitchFamily="34" charset="-122"/>
                 <a:cs typeface="Aptos" pitchFamily="34" charset="-120"/>
               </a:rPr>
-              <a:t>90%</a:t>
+              <a:t>10%</a:t>
             </a:r>
             <a:endParaRPr lang="en-US" sz="2100" dirty="0"/>
           </a:p>
@@ -15299,7 +14748,7 @@
                 <a:ea typeface="Microsoft YaHei" pitchFamily="34" charset="-122"/>
                 <a:cs typeface="Microsoft YaHei" pitchFamily="34" charset="-120"/>
               </a:rPr>
-              <a:t>碳酸锂价格暴跌</a:t>
+              <a:t>可能加剧行业供给竞争</a:t>
             </a:r>
             <a:endParaRPr lang="en-US" sz="820" dirty="0"/>
           </a:p>
@@ -15340,7 +14789,7 @@
                 <a:ea typeface="Microsoft YaHei" pitchFamily="34" charset="-122"/>
                 <a:cs typeface="Microsoft YaHei" pitchFamily="34" charset="-120"/>
               </a:rPr>
-              <a:t>公开信息：碳酸锂价格暴跌近90%，动力电池回收行业进入洗牌深水区</a:t>
+              <a:t>公开信息：储能电池产能激增110%可能加剧行业供给竞争，对磷酸铁锂正极材料价格形成压制</a:t>
             </a:r>
             <a:endParaRPr lang="en-US" sz="840" dirty="0"/>
           </a:p>
@@ -15486,7 +14935,7 @@
                 <a:ea typeface="Microsoft YaHei" pitchFamily="34" charset="-122"/>
                 <a:cs typeface="Microsoft YaHei" pitchFamily="34" charset="-120"/>
               </a:rPr>
-              <a:t>若碳酸锂价格继续下跌，则磷酸铁锂价格可能进一步承压，高成本产能或退出</a:t>
+              <a:t>若储能电池产能利用率不足且价格竞争加剧，则可能传导至磷酸铁锂正极材料价格承压，跟踪指标为储能电池月度均价和磷酸铁锂正极材料报价</a:t>
             </a:r>
             <a:endParaRPr lang="en-US" sz="1020" dirty="0"/>
           </a:p>
@@ -15635,7 +15084,7 @@
                 <a:ea typeface="Aptos" pitchFamily="34" charset="-122"/>
                 <a:cs typeface="Aptos" pitchFamily="34" charset="-120"/>
               </a:rPr>
-              <a:t>2026-10-12</a:t>
+              <a:t>2026-10-19</a:t>
             </a:r>
             <a:endParaRPr lang="en-US" sz="800" dirty="0"/>
           </a:p>
@@ -15841,7 +15290,7 @@
                 <a:ea typeface="Microsoft YaHei" pitchFamily="34" charset="-122"/>
                 <a:cs typeface="Microsoft YaHei" pitchFamily="34" charset="-120"/>
               </a:rPr>
-              <a:t>3 条公开来源交叉验证｜事实、影响与后续研判</a:t>
+              <a:t>2 条公开来源交叉验证｜事实、影响与后续研判</a:t>
             </a:r>
             <a:endParaRPr lang="en-US" sz="860" dirty="0"/>
           </a:p>
@@ -15950,7 +15399,7 @@
                 <a:ea typeface="Microsoft YaHei" pitchFamily="34" charset="-122"/>
                 <a:cs typeface="Microsoft YaHei" pitchFamily="34" charset="-120"/>
               </a:rPr>
-              <a:t>欧盟要求中国自限插混出口，贸易政策风险升温；国内出台19项举措推进新质生产力，动力电池政策环境总体支持；法国电池谷争抢中国企业，显示海外本地化需求。政策博弈可能影响磷酸铁锂出口预期。 [4][8][9]</a:t>
+              <a:t>电动摩托车锂电池强制性国标发布，明年7月实施，将提高小动力电池安全门槛，利好合规产能；商务部将12项光伏技术列入禁止、限制出口名单，虽不直接涉及磷酸铁锂，但反映新能源领域出口管制趋严，需关注电池材料出口政策变化。 [3][6]</a:t>
             </a:r>
             <a:endParaRPr lang="en-US" sz="960" dirty="0"/>
           </a:p>
@@ -15991,7 +15440,7 @@
                 <a:ea typeface="Aptos" pitchFamily="34" charset="-122"/>
                 <a:cs typeface="Aptos" pitchFamily="34" charset="-120"/>
               </a:rPr>
-              <a:t>依据：[4][8][9]</a:t>
+              <a:t>依据：[3][6]</a:t>
             </a:r>
             <a:endParaRPr lang="en-US" sz="740" dirty="0"/>
           </a:p>
@@ -16100,7 +15549,7 @@
                 <a:ea typeface="Microsoft YaHei" pitchFamily="34" charset="-122"/>
                 <a:cs typeface="Microsoft YaHei" pitchFamily="34" charset="-120"/>
               </a:rPr>
-              <a:t>欧盟自限要求若落地，将直接限制插混车型出口，进而影响配套磷酸铁锂电池需求；国内新质生产力举措可能利好技术升级，但海外本地化生产要求增加合规成本。需验证：欧盟政策具体条款、国内政策落地细节。</a:t>
+              <a:t>电摩国标信息来自温州新闻，光伏出口管制信息来自国际新能源网，两者均涉及新能源领域政策合规。电摩国标直接提高小动力锂电池安全要求，可能加速低端产能出清；光伏出口管制虽不直接涉及磷酸铁锂，但显示新能源技术出口管理趋严，可能对电池材料出口预期产生间接影响。需验证电摩国标的具体技术指标和过渡期安排，以及电池材料出口政策是否有联动调整。</a:t>
             </a:r>
             <a:endParaRPr lang="en-US" sz="960" dirty="0"/>
           </a:p>
@@ -16234,7 +15683,7 @@
                 <a:ea typeface="Microsoft YaHei" pitchFamily="34" charset="-122"/>
                 <a:cs typeface="Microsoft YaHei" pitchFamily="34" charset="-120"/>
               </a:rPr>
-              <a:t>若欧盟自限政策实施，则插混出口量可能下滑，磷酸铁锂需求受拖累；若国内新质生产力举措加大研发支持，则技术领先企业可能受益。跟踪指标：欧盟政策文本、插混出口数据。</a:t>
+              <a:t>若电摩国标执行严格且过渡期较短，则可能加速小动力电池行业洗牌，跟踪指标为电摩电池企业认证进度和行业集中度变化；若新能源领域出口管制范围扩大至电池材料，则可能影响磷酸铁锂出口预期，跟踪指标为商务部出口管制清单更新和电池材料出口数据。证据边界限于公开报道，未覆盖政策执行细则和行业反馈。</a:t>
             </a:r>
             <a:endParaRPr lang="en-US" sz="960" dirty="0"/>
           </a:p>
@@ -16409,7 +15858,7 @@
                 <a:ea typeface="Microsoft YaHei" pitchFamily="34" charset="-122"/>
                 <a:cs typeface="Microsoft YaHei" pitchFamily="34" charset="-120"/>
               </a:rPr>
-              <a:t>欧盟要求中国自限插混出口，贸易政策</a:t>
+              <a:t>电动摩托车锂电池强制性国标发布，明</a:t>
             </a:r>
             <a:endParaRPr lang="en-US" sz="660" dirty="0"/>
           </a:p>
@@ -16516,7 +15965,7 @@
                 <a:ea typeface="Microsoft YaHei" pitchFamily="34" charset="-122"/>
                 <a:cs typeface="Microsoft YaHei" pitchFamily="34" charset="-120"/>
               </a:rPr>
-              <a:t>国内出台19项举措推进新质生产力，</a:t>
+              <a:t>商务部将12项光伏技术列入禁止、限</a:t>
             </a:r>
             <a:endParaRPr lang="en-US" sz="660" dirty="0"/>
           </a:p>
@@ -16623,7 +16072,7 @@
                 <a:ea typeface="Microsoft YaHei" pitchFamily="34" charset="-122"/>
                 <a:cs typeface="Microsoft YaHei" pitchFamily="34" charset="-120"/>
               </a:rPr>
-              <a:t>法国电池谷争抢中国企业，显示海外本</a:t>
+              <a:t>[3][6] 电摩国标信息来自温州</a:t>
             </a:r>
             <a:endParaRPr lang="en-US" sz="660" dirty="0"/>
           </a:p>
@@ -16728,7 +16177,7 @@
                 <a:ea typeface="Microsoft YaHei" pitchFamily="34" charset="-122"/>
                 <a:cs typeface="Microsoft YaHei" pitchFamily="34" charset="-120"/>
               </a:rPr>
-              <a:t>若欧盟自限政策实施，则插混出口量可能下滑，磷酸铁锂需求受拖累</a:t>
+              <a:t>若电摩国标执行严格且过渡期较短，则可能加速小动力电池行业洗牌，跟踪指标为电摩电池企业认证进度和行业集中度变化</a:t>
             </a:r>
             <a:endParaRPr lang="en-US" sz="1020" dirty="0"/>
           </a:p>
@@ -16877,7 +16326,7 @@
                 <a:ea typeface="Aptos" pitchFamily="34" charset="-122"/>
                 <a:cs typeface="Aptos" pitchFamily="34" charset="-120"/>
               </a:rPr>
-              <a:t>2026-10-12</a:t>
+              <a:t>2026-10-19</a:t>
             </a:r>
             <a:endParaRPr lang="en-US" sz="800" dirty="0"/>
           </a:p>
@@ -17192,7 +16641,7 @@
                 <a:ea typeface="Microsoft YaHei" pitchFamily="34" charset="-122"/>
                 <a:cs typeface="Microsoft YaHei" pitchFamily="34" charset="-120"/>
               </a:rPr>
-              <a:t>吉利开卖电芯，车企自供电池趋势增强，可能挤压第三方磷酸铁锂供应商份额；法国电池谷争抢中国企业，海外竞争加剧。竞品动态显示行业垂直整合与全球化布局并行。 [5][9]</a:t>
+              <a:t>全国首批锂+钠示范落地河北，大电芯路线推进，钠离子电池在储能场景的替代尝试可能对磷酸铁锂形成潜在竞争；固态电池专家提出2030年实用化量产目标，长期技术路线竞争需持续跟踪。 [5][4]</a:t>
             </a:r>
             <a:endParaRPr lang="en-US" sz="960" dirty="0"/>
           </a:p>
@@ -17233,7 +16682,7 @@
                 <a:ea typeface="Aptos" pitchFamily="34" charset="-122"/>
                 <a:cs typeface="Aptos" pitchFamily="34" charset="-120"/>
               </a:rPr>
-              <a:t>依据：[5][9]</a:t>
+              <a:t>依据：[5][4]</a:t>
             </a:r>
             <a:endParaRPr lang="en-US" sz="740" dirty="0"/>
           </a:p>
@@ -17342,7 +16791,7 @@
                 <a:ea typeface="Microsoft YaHei" pitchFamily="34" charset="-122"/>
                 <a:cs typeface="Microsoft YaHei" pitchFamily="34" charset="-120"/>
               </a:rPr>
-              <a:t>吉利作为车企自供电芯，可能优先采购自家产品，影响外部磷酸铁锂订单；法国电池谷招商反映欧洲本地化生产需求，中国企业出海面临竞争与合作。需验证：吉利电芯技术来源、法国电池谷招商政策。</a:t>
+              <a:t>锂+钠示范项目来自搜狐，固态电池观点来自每日经济新闻，两者分别代表钠离子电池和固态电池对磷酸铁锂的潜在替代。钠离子电池在储能场景的成本优势可能分流部分低端需求；固态电池量产目标在2030年，短期不构成威胁，但长期可能改变动力电池技术格局。需验证钠离子电池储能项目的实际规模和成本，以及固态电池量产时间表的可信度。</a:t>
             </a:r>
             <a:endParaRPr lang="en-US" sz="960" dirty="0"/>
           </a:p>
@@ -17476,7 +16925,7 @@
                 <a:ea typeface="Microsoft YaHei" pitchFamily="34" charset="-122"/>
                 <a:cs typeface="Microsoft YaHei" pitchFamily="34" charset="-120"/>
               </a:rPr>
-              <a:t>若吉利电芯大规模外供，则第三方磷酸铁锂企业客户结构可能恶化；若法国电池谷成功吸引中国企业，则海外产能布局可能加速。跟踪指标：吉利电芯外供量、法国电池谷入驻企业名单。</a:t>
+              <a:t>若钠离子电池在储能场景实现规模化应用且成本低于磷酸铁锂，则可能对磷酸铁锂在低端储能市场的份额形成挤压，跟踪指标为钠离子电池储能项目招标规模和度电成本对比；若固态电池在2030年前实现小批量装车，则可能对磷酸铁锂长期需求预期形成扰动，跟踪指标为固态电池装车验证进度和成本下降曲线。证据边界限于公开报道，未覆盖具体项目经济性数据。</a:t>
             </a:r>
             <a:endParaRPr lang="en-US" sz="960" dirty="0"/>
           </a:p>
@@ -17544,7 +16993,7 @@
                 <a:ea typeface="Microsoft YaHei" pitchFamily="34" charset="-122"/>
                 <a:cs typeface="Microsoft YaHei" pitchFamily="34" charset="-120"/>
               </a:rPr>
-              <a:t>路线图</a:t>
+              <a:t>对比矩阵</a:t>
             </a:r>
             <a:endParaRPr lang="en-US" sz="1200" dirty="0"/>
           </a:p>
@@ -17558,18 +17007,89 @@
         </p:nvSpPr>
         <p:spPr>
           <a:xfrm>
-            <a:off x="7754112" y="2249424"/>
-            <a:ext cx="612648" cy="402336"/>
-          </a:xfrm>
-          <a:prstGeom prst="chevron">
+            <a:off x="7818120" y="2176272"/>
+            <a:ext cx="2487168" cy="1609344"/>
+          </a:xfrm>
+          <a:prstGeom prst="rect">
+            <a:avLst/>
+          </a:prstGeom>
+          <a:solidFill>
+            <a:srgbClr val="FFFFFF"/>
+          </a:solidFill>
+          <a:ln w="10160">
+            <a:solidFill>
+              <a:srgbClr val="DADADA"/>
+            </a:solidFill>
+            <a:prstDash val="solid"/>
+          </a:ln>
+        </p:spPr>
+      </p:sp>
+      <p:sp>
+        <p:nvSpPr>
+          <p:cNvPr id="25" name="Shape 23"/>
+          <p:cNvSpPr/>
+          <p:nvPr/>
+        </p:nvSpPr>
+        <p:spPr>
+          <a:xfrm>
+            <a:off x="9061704" y="2176272"/>
+            <a:ext cx="0" cy="1609344"/>
+          </a:xfrm>
+          <a:prstGeom prst="line">
+            <a:avLst/>
+          </a:prstGeom>
+          <a:noFill/>
+          <a:ln w="8890">
+            <a:solidFill>
+              <a:srgbClr val="DADADA"/>
+            </a:solidFill>
+            <a:prstDash val="solid"/>
+          </a:ln>
+        </p:spPr>
+      </p:sp>
+      <p:sp>
+        <p:nvSpPr>
+          <p:cNvPr id="26" name="Shape 24"/>
+          <p:cNvSpPr/>
+          <p:nvPr/>
+        </p:nvSpPr>
+        <p:spPr>
+          <a:xfrm>
+            <a:off x="7818120" y="2980944"/>
+            <a:ext cx="2487168" cy="0"/>
+          </a:xfrm>
+          <a:prstGeom prst="line">
+            <a:avLst/>
+          </a:prstGeom>
+          <a:noFill/>
+          <a:ln w="8890">
+            <a:solidFill>
+              <a:srgbClr val="DADADA"/>
+            </a:solidFill>
+            <a:prstDash val="solid"/>
+          </a:ln>
+        </p:spPr>
+      </p:sp>
+      <p:sp>
+        <p:nvSpPr>
+          <p:cNvPr id="27" name="Shape 25"/>
+          <p:cNvSpPr/>
+          <p:nvPr/>
+        </p:nvSpPr>
+        <p:spPr>
+          <a:xfrm>
+            <a:off x="7818120" y="2176272"/>
+            <a:ext cx="1243584" cy="804672"/>
+          </a:xfrm>
+          <a:prstGeom prst="rect">
             <a:avLst/>
           </a:prstGeom>
           <a:solidFill>
             <a:srgbClr val="DDEBE0"/>
           </a:solidFill>
-          <a:ln w="13970">
+          <a:ln w="3810">
             <a:solidFill>
-              <a:srgbClr val="487052"/>
+              <a:srgbClr val="DADADA"/>
             </a:solidFill>
             <a:prstDash val="solid"/>
           </a:ln>
@@ -17577,14 +17097,14 @@
       </p:sp>
       <p:sp>
         <p:nvSpPr>
-          <p:cNvPr id="25" name="Text 23"/>
-          <p:cNvSpPr/>
-          <p:nvPr/>
-        </p:nvSpPr>
-        <p:spPr>
-          <a:xfrm>
-            <a:off x="7827264" y="2386584"/>
-            <a:ext cx="448056" cy="109728"/>
+          <p:cNvPr id="28" name="Text 26"/>
+          <p:cNvSpPr/>
+          <p:nvPr/>
+        </p:nvSpPr>
+        <p:spPr>
+          <a:xfrm>
+            <a:off x="7891272" y="2286000"/>
+            <a:ext cx="438912" cy="109728"/>
           </a:xfrm>
           <a:prstGeom prst="rect">
             <a:avLst/>
@@ -17598,11 +17118,52 @@
           </a:bodyPr>
           <a:lstStyle/>
           <a:p>
-            <a:pPr algn="ctr" indent="0" marL="0">
-              <a:buNone/>
-            </a:pPr>
-            <a:r>
-              <a:rPr lang="en-US" sz="670" b="1" dirty="0">
+            <a:pPr indent="0" marL="0">
+              <a:buNone/>
+            </a:pPr>
+            <a:r>
+              <a:rPr lang="en-US" sz="710" b="1" dirty="0">
+                <a:solidFill>
+                  <a:srgbClr val="487052"/>
+                </a:solidFill>
+                <a:latin typeface="Microsoft YaHei" pitchFamily="34" charset="0"/>
+                <a:ea typeface="Microsoft YaHei" pitchFamily="34" charset="-122"/>
+                <a:cs typeface="Microsoft YaHei" pitchFamily="34" charset="-120"/>
+              </a:rPr>
+              <a:t>路线A</a:t>
+            </a:r>
+            <a:endParaRPr lang="en-US" sz="710" dirty="0"/>
+          </a:p>
+        </p:txBody>
+      </p:sp>
+      <p:sp>
+        <p:nvSpPr>
+          <p:cNvPr id="29" name="Text 27"/>
+          <p:cNvSpPr/>
+          <p:nvPr/>
+        </p:nvSpPr>
+        <p:spPr>
+          <a:xfrm>
+            <a:off x="7891272" y="2505456"/>
+            <a:ext cx="1024128" cy="201168"/>
+          </a:xfrm>
+          <a:prstGeom prst="rect">
+            <a:avLst/>
+          </a:prstGeom>
+          <a:noFill/>
+          <a:ln/>
+        </p:spPr>
+        <p:txBody>
+          <a:bodyPr wrap="square" lIns="0" tIns="0" rIns="0" bIns="0" rtlCol="0" anchor="t">
+            <a:normAutofit/>
+          </a:bodyPr>
+          <a:lstStyle/>
+          <a:p>
+            <a:pPr indent="0" marL="0">
+              <a:buNone/>
+            </a:pPr>
+            <a:r>
+              <a:rPr lang="en-US" sz="670" dirty="0">
                 <a:solidFill>
                   <a:srgbClr val="121212"/>
                 </a:solidFill>
@@ -17610,7 +17171,7 @@
                 <a:ea typeface="Microsoft YaHei" pitchFamily="34" charset="-122"/>
                 <a:cs typeface="Microsoft YaHei" pitchFamily="34" charset="-120"/>
               </a:rPr>
-              <a:t>技术</a:t>
+              <a:t>全国首批锂+钠示范落地河北</a:t>
             </a:r>
             <a:endParaRPr lang="en-US" sz="670" dirty="0"/>
           </a:p>
@@ -17618,24 +17179,24 @@
       </p:sp>
       <p:sp>
         <p:nvSpPr>
-          <p:cNvPr id="26" name="Shape 24"/>
-          <p:cNvSpPr/>
-          <p:nvPr/>
-        </p:nvSpPr>
-        <p:spPr>
-          <a:xfrm>
-            <a:off x="8375904" y="2249424"/>
-            <a:ext cx="612648" cy="402336"/>
-          </a:xfrm>
-          <a:prstGeom prst="chevron">
+          <p:cNvPr id="30" name="Shape 28"/>
+          <p:cNvSpPr/>
+          <p:nvPr/>
+        </p:nvSpPr>
+        <p:spPr>
+          <a:xfrm>
+            <a:off x="9061704" y="2176272"/>
+            <a:ext cx="1243584" cy="804672"/>
+          </a:xfrm>
+          <a:prstGeom prst="rect">
             <a:avLst/>
           </a:prstGeom>
           <a:solidFill>
             <a:srgbClr val="FFFFFF"/>
           </a:solidFill>
-          <a:ln w="13970">
+          <a:ln w="3810">
             <a:solidFill>
-              <a:srgbClr val="487052"/>
+              <a:srgbClr val="DADADA"/>
             </a:solidFill>
             <a:prstDash val="solid"/>
           </a:ln>
@@ -17643,14 +17204,14 @@
       </p:sp>
       <p:sp>
         <p:nvSpPr>
-          <p:cNvPr id="27" name="Text 25"/>
-          <p:cNvSpPr/>
-          <p:nvPr/>
-        </p:nvSpPr>
-        <p:spPr>
-          <a:xfrm>
-            <a:off x="8449056" y="2386584"/>
-            <a:ext cx="448056" cy="109728"/>
+          <p:cNvPr id="31" name="Text 29"/>
+          <p:cNvSpPr/>
+          <p:nvPr/>
+        </p:nvSpPr>
+        <p:spPr>
+          <a:xfrm>
+            <a:off x="9134856" y="2286000"/>
+            <a:ext cx="438912" cy="109728"/>
           </a:xfrm>
           <a:prstGeom prst="rect">
             <a:avLst/>
@@ -17664,11 +17225,52 @@
           </a:bodyPr>
           <a:lstStyle/>
           <a:p>
-            <a:pPr algn="ctr" indent="0" marL="0">
-              <a:buNone/>
-            </a:pPr>
-            <a:r>
-              <a:rPr lang="en-US" sz="670" b="1" dirty="0">
+            <a:pPr indent="0" marL="0">
+              <a:buNone/>
+            </a:pPr>
+            <a:r>
+              <a:rPr lang="en-US" sz="710" b="1" dirty="0">
+                <a:solidFill>
+                  <a:srgbClr val="487052"/>
+                </a:solidFill>
+                <a:latin typeface="Microsoft YaHei" pitchFamily="34" charset="0"/>
+                <a:ea typeface="Microsoft YaHei" pitchFamily="34" charset="-122"/>
+                <a:cs typeface="Microsoft YaHei" pitchFamily="34" charset="-120"/>
+              </a:rPr>
+              <a:t>路线B</a:t>
+            </a:r>
+            <a:endParaRPr lang="en-US" sz="710" dirty="0"/>
+          </a:p>
+        </p:txBody>
+      </p:sp>
+      <p:sp>
+        <p:nvSpPr>
+          <p:cNvPr id="32" name="Text 30"/>
+          <p:cNvSpPr/>
+          <p:nvPr/>
+        </p:nvSpPr>
+        <p:spPr>
+          <a:xfrm>
+            <a:off x="9134856" y="2505456"/>
+            <a:ext cx="1024128" cy="201168"/>
+          </a:xfrm>
+          <a:prstGeom prst="rect">
+            <a:avLst/>
+          </a:prstGeom>
+          <a:noFill/>
+          <a:ln/>
+        </p:spPr>
+        <p:txBody>
+          <a:bodyPr wrap="square" lIns="0" tIns="0" rIns="0" bIns="0" rtlCol="0" anchor="t">
+            <a:normAutofit/>
+          </a:bodyPr>
+          <a:lstStyle/>
+          <a:p>
+            <a:pPr indent="0" marL="0">
+              <a:buNone/>
+            </a:pPr>
+            <a:r>
+              <a:rPr lang="en-US" sz="670" dirty="0">
                 <a:solidFill>
                   <a:srgbClr val="121212"/>
                 </a:solidFill>
@@ -17676,7 +17278,7 @@
                 <a:ea typeface="Microsoft YaHei" pitchFamily="34" charset="-122"/>
                 <a:cs typeface="Microsoft YaHei" pitchFamily="34" charset="-120"/>
               </a:rPr>
-              <a:t>产品</a:t>
+              <a:t>固态电池专家提出2030年</a:t>
             </a:r>
             <a:endParaRPr lang="en-US" sz="670" dirty="0"/>
           </a:p>
@@ -17684,24 +17286,24 @@
       </p:sp>
       <p:sp>
         <p:nvSpPr>
-          <p:cNvPr id="28" name="Shape 26"/>
-          <p:cNvSpPr/>
-          <p:nvPr/>
-        </p:nvSpPr>
-        <p:spPr>
-          <a:xfrm>
-            <a:off x="8997696" y="2249424"/>
-            <a:ext cx="612648" cy="402336"/>
-          </a:xfrm>
-          <a:prstGeom prst="chevron">
+          <p:cNvPr id="33" name="Shape 31"/>
+          <p:cNvSpPr/>
+          <p:nvPr/>
+        </p:nvSpPr>
+        <p:spPr>
+          <a:xfrm>
+            <a:off x="7818120" y="2980944"/>
+            <a:ext cx="1243584" cy="804672"/>
+          </a:xfrm>
+          <a:prstGeom prst="rect">
             <a:avLst/>
           </a:prstGeom>
           <a:solidFill>
             <a:srgbClr val="FFFFFF"/>
           </a:solidFill>
-          <a:ln w="13970">
+          <a:ln w="3810">
             <a:solidFill>
-              <a:srgbClr val="487052"/>
+              <a:srgbClr val="DADADA"/>
             </a:solidFill>
             <a:prstDash val="solid"/>
           </a:ln>
@@ -17709,14 +17311,14 @@
       </p:sp>
       <p:sp>
         <p:nvSpPr>
-          <p:cNvPr id="29" name="Text 27"/>
-          <p:cNvSpPr/>
-          <p:nvPr/>
-        </p:nvSpPr>
-        <p:spPr>
-          <a:xfrm>
-            <a:off x="9070848" y="2386584"/>
-            <a:ext cx="448056" cy="109728"/>
+          <p:cNvPr id="34" name="Text 32"/>
+          <p:cNvSpPr/>
+          <p:nvPr/>
+        </p:nvSpPr>
+        <p:spPr>
+          <a:xfrm>
+            <a:off x="7891272" y="3090672"/>
+            <a:ext cx="438912" cy="109728"/>
           </a:xfrm>
           <a:prstGeom prst="rect">
             <a:avLst/>
@@ -17730,11 +17332,52 @@
           </a:bodyPr>
           <a:lstStyle/>
           <a:p>
-            <a:pPr algn="ctr" indent="0" marL="0">
-              <a:buNone/>
-            </a:pPr>
-            <a:r>
-              <a:rPr lang="en-US" sz="670" b="1" dirty="0">
+            <a:pPr indent="0" marL="0">
+              <a:buNone/>
+            </a:pPr>
+            <a:r>
+              <a:rPr lang="en-US" sz="710" b="1" dirty="0">
+                <a:solidFill>
+                  <a:srgbClr val="487052"/>
+                </a:solidFill>
+                <a:latin typeface="Microsoft YaHei" pitchFamily="34" charset="0"/>
+                <a:ea typeface="Microsoft YaHei" pitchFamily="34" charset="-122"/>
+                <a:cs typeface="Microsoft YaHei" pitchFamily="34" charset="-120"/>
+              </a:rPr>
+              <a:t>机会</a:t>
+            </a:r>
+            <a:endParaRPr lang="en-US" sz="710" dirty="0"/>
+          </a:p>
+        </p:txBody>
+      </p:sp>
+      <p:sp>
+        <p:nvSpPr>
+          <p:cNvPr id="35" name="Text 33"/>
+          <p:cNvSpPr/>
+          <p:nvPr/>
+        </p:nvSpPr>
+        <p:spPr>
+          <a:xfrm>
+            <a:off x="7891272" y="3310128"/>
+            <a:ext cx="1024128" cy="201168"/>
+          </a:xfrm>
+          <a:prstGeom prst="rect">
+            <a:avLst/>
+          </a:prstGeom>
+          <a:noFill/>
+          <a:ln/>
+        </p:spPr>
+        <p:txBody>
+          <a:bodyPr wrap="square" lIns="0" tIns="0" rIns="0" bIns="0" rtlCol="0" anchor="t">
+            <a:normAutofit/>
+          </a:bodyPr>
+          <a:lstStyle/>
+          <a:p>
+            <a:pPr indent="0" marL="0">
+              <a:buNone/>
+            </a:pPr>
+            <a:r>
+              <a:rPr lang="en-US" sz="670" dirty="0">
                 <a:solidFill>
                   <a:srgbClr val="121212"/>
                 </a:solidFill>
@@ -17742,7 +17385,7 @@
                 <a:ea typeface="Microsoft YaHei" pitchFamily="34" charset="-122"/>
                 <a:cs typeface="Microsoft YaHei" pitchFamily="34" charset="-120"/>
               </a:rPr>
-              <a:t>验证</a:t>
+              <a:t>[5][4] 锂+钠示范项</a:t>
             </a:r>
             <a:endParaRPr lang="en-US" sz="670" dirty="0"/>
           </a:p>
@@ -17750,24 +17393,24 @@
       </p:sp>
       <p:sp>
         <p:nvSpPr>
-          <p:cNvPr id="30" name="Shape 28"/>
-          <p:cNvSpPr/>
-          <p:nvPr/>
-        </p:nvSpPr>
-        <p:spPr>
-          <a:xfrm>
-            <a:off x="9619488" y="2249424"/>
-            <a:ext cx="612648" cy="402336"/>
-          </a:xfrm>
-          <a:prstGeom prst="chevron">
+          <p:cNvPr id="36" name="Shape 34"/>
+          <p:cNvSpPr/>
+          <p:nvPr/>
+        </p:nvSpPr>
+        <p:spPr>
+          <a:xfrm>
+            <a:off x="9061704" y="2980944"/>
+            <a:ext cx="1243584" cy="804672"/>
+          </a:xfrm>
+          <a:prstGeom prst="rect">
             <a:avLst/>
           </a:prstGeom>
           <a:solidFill>
-            <a:srgbClr val="FFFFFF"/>
+            <a:srgbClr val="F4FAF6"/>
           </a:solidFill>
-          <a:ln w="13970">
+          <a:ln w="3810">
             <a:solidFill>
-              <a:srgbClr val="487052"/>
+              <a:srgbClr val="DADADA"/>
             </a:solidFill>
             <a:prstDash val="solid"/>
           </a:ln>
@@ -17775,14 +17418,14 @@
       </p:sp>
       <p:sp>
         <p:nvSpPr>
-          <p:cNvPr id="31" name="Text 29"/>
-          <p:cNvSpPr/>
-          <p:nvPr/>
-        </p:nvSpPr>
-        <p:spPr>
-          <a:xfrm>
-            <a:off x="9692640" y="2386584"/>
-            <a:ext cx="448056" cy="109728"/>
+          <p:cNvPr id="37" name="Text 35"/>
+          <p:cNvSpPr/>
+          <p:nvPr/>
+        </p:nvSpPr>
+        <p:spPr>
+          <a:xfrm>
+            <a:off x="9134856" y="3090672"/>
+            <a:ext cx="438912" cy="109728"/>
           </a:xfrm>
           <a:prstGeom prst="rect">
             <a:avLst/>
@@ -17796,11 +17439,52 @@
           </a:bodyPr>
           <a:lstStyle/>
           <a:p>
-            <a:pPr algn="ctr" indent="0" marL="0">
-              <a:buNone/>
-            </a:pPr>
-            <a:r>
-              <a:rPr lang="en-US" sz="670" b="1" dirty="0">
+            <a:pPr indent="0" marL="0">
+              <a:buNone/>
+            </a:pPr>
+            <a:r>
+              <a:rPr lang="en-US" sz="710" b="1" dirty="0">
+                <a:solidFill>
+                  <a:srgbClr val="487052"/>
+                </a:solidFill>
+                <a:latin typeface="Microsoft YaHei" pitchFamily="34" charset="0"/>
+                <a:ea typeface="Microsoft YaHei" pitchFamily="34" charset="-122"/>
+                <a:cs typeface="Microsoft YaHei" pitchFamily="34" charset="-120"/>
+              </a:rPr>
+              <a:t>约束</a:t>
+            </a:r>
+            <a:endParaRPr lang="en-US" sz="710" dirty="0"/>
+          </a:p>
+        </p:txBody>
+      </p:sp>
+      <p:sp>
+        <p:nvSpPr>
+          <p:cNvPr id="38" name="Text 36"/>
+          <p:cNvSpPr/>
+          <p:nvPr/>
+        </p:nvSpPr>
+        <p:spPr>
+          <a:xfrm>
+            <a:off x="9134856" y="3310128"/>
+            <a:ext cx="1024128" cy="201168"/>
+          </a:xfrm>
+          <a:prstGeom prst="rect">
+            <a:avLst/>
+          </a:prstGeom>
+          <a:noFill/>
+          <a:ln/>
+        </p:spPr>
+        <p:txBody>
+          <a:bodyPr wrap="square" lIns="0" tIns="0" rIns="0" bIns="0" rtlCol="0" anchor="t">
+            <a:normAutofit/>
+          </a:bodyPr>
+          <a:lstStyle/>
+          <a:p>
+            <a:pPr indent="0" marL="0">
+              <a:buNone/>
+            </a:pPr>
+            <a:r>
+              <a:rPr lang="en-US" sz="670" dirty="0">
                 <a:solidFill>
                   <a:srgbClr val="121212"/>
                 </a:solidFill>
@@ -17808,7 +17492,7 @@
                 <a:ea typeface="Microsoft YaHei" pitchFamily="34" charset="-122"/>
                 <a:cs typeface="Microsoft YaHei" pitchFamily="34" charset="-120"/>
               </a:rPr>
-              <a:t>量产</a:t>
+              <a:t>全国首批锂+钠示范落地河北</a:t>
             </a:r>
             <a:endParaRPr lang="en-US" sz="670" dirty="0"/>
           </a:p>
@@ -17816,62 +17500,14 @@
       </p:sp>
       <p:sp>
         <p:nvSpPr>
-          <p:cNvPr id="32" name="Shape 30"/>
-          <p:cNvSpPr/>
-          <p:nvPr/>
-        </p:nvSpPr>
-        <p:spPr>
-          <a:xfrm>
-            <a:off x="7882128" y="3063240"/>
-            <a:ext cx="2331720" cy="0"/>
-          </a:xfrm>
-          <a:prstGeom prst="line">
-            <a:avLst/>
-          </a:prstGeom>
-          <a:noFill/>
-          <a:ln w="13970">
-            <a:solidFill>
-              <a:srgbClr val="7F9D84"/>
-            </a:solidFill>
-            <a:prstDash val="solid"/>
-          </a:ln>
-        </p:spPr>
-      </p:sp>
-      <p:sp>
-        <p:nvSpPr>
-          <p:cNvPr id="33" name="Shape 31"/>
-          <p:cNvSpPr/>
-          <p:nvPr/>
-        </p:nvSpPr>
-        <p:spPr>
-          <a:xfrm>
-            <a:off x="7845552" y="2962656"/>
-            <a:ext cx="164592" cy="164592"/>
-          </a:xfrm>
-          <a:prstGeom prst="ellipse">
-            <a:avLst/>
-          </a:prstGeom>
-          <a:solidFill>
-            <a:srgbClr val="487052"/>
-          </a:solidFill>
-          <a:ln w="12700">
-            <a:solidFill>
-              <a:srgbClr val="FFFFFF"/>
-            </a:solidFill>
-            <a:prstDash val="solid"/>
-          </a:ln>
-        </p:spPr>
-      </p:sp>
-      <p:sp>
-        <p:nvSpPr>
-          <p:cNvPr id="34" name="Text 32"/>
-          <p:cNvSpPr/>
-          <p:nvPr/>
-        </p:nvSpPr>
-        <p:spPr>
-          <a:xfrm>
-            <a:off x="7754112" y="3291840"/>
-            <a:ext cx="603504" cy="310896"/>
+          <p:cNvPr id="39" name="Text 37"/>
+          <p:cNvSpPr/>
+          <p:nvPr/>
+        </p:nvSpPr>
+        <p:spPr>
+          <a:xfrm>
+            <a:off x="7726680" y="4187952"/>
+            <a:ext cx="2697480" cy="493776"/>
           </a:xfrm>
           <a:prstGeom prst="rect">
             <a:avLst/>
@@ -17885,245 +17521,6 @@
           </a:bodyPr>
           <a:lstStyle/>
           <a:p>
-            <a:pPr algn="ctr" indent="0" marL="0">
-              <a:buNone/>
-            </a:pPr>
-            <a:r>
-              <a:rPr lang="en-US" sz="670" dirty="0">
-                <a:solidFill>
-                  <a:srgbClr val="121212"/>
-                </a:solidFill>
-                <a:latin typeface="Microsoft YaHei" pitchFamily="34" charset="0"/>
-                <a:ea typeface="Microsoft YaHei" pitchFamily="34" charset="-122"/>
-                <a:cs typeface="Microsoft YaHei" pitchFamily="34" charset="-120"/>
-              </a:rPr>
-              <a:t>吉利开卖电芯，车企自供</a:t>
-            </a:r>
-            <a:endParaRPr lang="en-US" sz="670" dirty="0"/>
-          </a:p>
-        </p:txBody>
-      </p:sp>
-      <p:sp>
-        <p:nvSpPr>
-          <p:cNvPr id="35" name="Shape 33"/>
-          <p:cNvSpPr/>
-          <p:nvPr/>
-        </p:nvSpPr>
-        <p:spPr>
-          <a:xfrm>
-            <a:off x="8503920" y="2962656"/>
-            <a:ext cx="164592" cy="164592"/>
-          </a:xfrm>
-          <a:prstGeom prst="ellipse">
-            <a:avLst/>
-          </a:prstGeom>
-          <a:solidFill>
-            <a:srgbClr val="487052"/>
-          </a:solidFill>
-          <a:ln w="12700">
-            <a:solidFill>
-              <a:srgbClr val="FFFFFF"/>
-            </a:solidFill>
-            <a:prstDash val="solid"/>
-          </a:ln>
-        </p:spPr>
-      </p:sp>
-      <p:sp>
-        <p:nvSpPr>
-          <p:cNvPr id="36" name="Text 34"/>
-          <p:cNvSpPr/>
-          <p:nvPr/>
-        </p:nvSpPr>
-        <p:spPr>
-          <a:xfrm>
-            <a:off x="8412480" y="3291840"/>
-            <a:ext cx="603504" cy="310896"/>
-          </a:xfrm>
-          <a:prstGeom prst="rect">
-            <a:avLst/>
-          </a:prstGeom>
-          <a:noFill/>
-          <a:ln/>
-        </p:spPr>
-        <p:txBody>
-          <a:bodyPr wrap="square" lIns="0" tIns="0" rIns="0" bIns="0" rtlCol="0" anchor="t">
-            <a:normAutofit/>
-          </a:bodyPr>
-          <a:lstStyle/>
-          <a:p>
-            <a:pPr algn="ctr" indent="0" marL="0">
-              <a:buNone/>
-            </a:pPr>
-            <a:r>
-              <a:rPr lang="en-US" sz="670" dirty="0">
-                <a:solidFill>
-                  <a:srgbClr val="121212"/>
-                </a:solidFill>
-                <a:latin typeface="Microsoft YaHei" pitchFamily="34" charset="0"/>
-                <a:ea typeface="Microsoft YaHei" pitchFamily="34" charset="-122"/>
-                <a:cs typeface="Microsoft YaHei" pitchFamily="34" charset="-120"/>
-              </a:rPr>
-              <a:t>法国电池谷争抢中国企业</a:t>
-            </a:r>
-            <a:endParaRPr lang="en-US" sz="670" dirty="0"/>
-          </a:p>
-        </p:txBody>
-      </p:sp>
-      <p:sp>
-        <p:nvSpPr>
-          <p:cNvPr id="37" name="Shape 35"/>
-          <p:cNvSpPr/>
-          <p:nvPr/>
-        </p:nvSpPr>
-        <p:spPr>
-          <a:xfrm>
-            <a:off x="9162288" y="2962656"/>
-            <a:ext cx="164592" cy="164592"/>
-          </a:xfrm>
-          <a:prstGeom prst="ellipse">
-            <a:avLst/>
-          </a:prstGeom>
-          <a:solidFill>
-            <a:srgbClr val="487052"/>
-          </a:solidFill>
-          <a:ln w="12700">
-            <a:solidFill>
-              <a:srgbClr val="FFFFFF"/>
-            </a:solidFill>
-            <a:prstDash val="solid"/>
-          </a:ln>
-        </p:spPr>
-      </p:sp>
-      <p:sp>
-        <p:nvSpPr>
-          <p:cNvPr id="38" name="Text 36"/>
-          <p:cNvSpPr/>
-          <p:nvPr/>
-        </p:nvSpPr>
-        <p:spPr>
-          <a:xfrm>
-            <a:off x="9070848" y="3291840"/>
-            <a:ext cx="603504" cy="310896"/>
-          </a:xfrm>
-          <a:prstGeom prst="rect">
-            <a:avLst/>
-          </a:prstGeom>
-          <a:noFill/>
-          <a:ln/>
-        </p:spPr>
-        <p:txBody>
-          <a:bodyPr wrap="square" lIns="0" tIns="0" rIns="0" bIns="0" rtlCol="0" anchor="t">
-            <a:normAutofit/>
-          </a:bodyPr>
-          <a:lstStyle/>
-          <a:p>
-            <a:pPr algn="ctr" indent="0" marL="0">
-              <a:buNone/>
-            </a:pPr>
-            <a:r>
-              <a:rPr lang="en-US" sz="670" dirty="0">
-                <a:solidFill>
-                  <a:srgbClr val="121212"/>
-                </a:solidFill>
-                <a:latin typeface="Microsoft YaHei" pitchFamily="34" charset="0"/>
-                <a:ea typeface="Microsoft YaHei" pitchFamily="34" charset="-122"/>
-                <a:cs typeface="Microsoft YaHei" pitchFamily="34" charset="-120"/>
-              </a:rPr>
-              <a:t>竞品动态显示行业垂直整</a:t>
-            </a:r>
-            <a:endParaRPr lang="en-US" sz="670" dirty="0"/>
-          </a:p>
-        </p:txBody>
-      </p:sp>
-      <p:sp>
-        <p:nvSpPr>
-          <p:cNvPr id="39" name="Shape 37"/>
-          <p:cNvSpPr/>
-          <p:nvPr/>
-        </p:nvSpPr>
-        <p:spPr>
-          <a:xfrm>
-            <a:off x="9820656" y="2962656"/>
-            <a:ext cx="164592" cy="164592"/>
-          </a:xfrm>
-          <a:prstGeom prst="ellipse">
-            <a:avLst/>
-          </a:prstGeom>
-          <a:solidFill>
-            <a:srgbClr val="B85A4A"/>
-          </a:solidFill>
-          <a:ln w="12700">
-            <a:solidFill>
-              <a:srgbClr val="FFFFFF"/>
-            </a:solidFill>
-            <a:prstDash val="solid"/>
-          </a:ln>
-        </p:spPr>
-      </p:sp>
-      <p:sp>
-        <p:nvSpPr>
-          <p:cNvPr id="40" name="Text 38"/>
-          <p:cNvSpPr/>
-          <p:nvPr/>
-        </p:nvSpPr>
-        <p:spPr>
-          <a:xfrm>
-            <a:off x="9729216" y="3291840"/>
-            <a:ext cx="603504" cy="310896"/>
-          </a:xfrm>
-          <a:prstGeom prst="rect">
-            <a:avLst/>
-          </a:prstGeom>
-          <a:noFill/>
-          <a:ln/>
-        </p:spPr>
-        <p:txBody>
-          <a:bodyPr wrap="square" lIns="0" tIns="0" rIns="0" bIns="0" rtlCol="0" anchor="t">
-            <a:normAutofit/>
-          </a:bodyPr>
-          <a:lstStyle/>
-          <a:p>
-            <a:pPr algn="ctr" indent="0" marL="0">
-              <a:buNone/>
-            </a:pPr>
-            <a:r>
-              <a:rPr lang="en-US" sz="670" dirty="0">
-                <a:solidFill>
-                  <a:srgbClr val="121212"/>
-                </a:solidFill>
-                <a:latin typeface="Microsoft YaHei" pitchFamily="34" charset="0"/>
-                <a:ea typeface="Microsoft YaHei" pitchFamily="34" charset="-122"/>
-                <a:cs typeface="Microsoft YaHei" pitchFamily="34" charset="-120"/>
-              </a:rPr>
-              <a:t>竞品动态显示行业垂直整</a:t>
-            </a:r>
-            <a:endParaRPr lang="en-US" sz="670" dirty="0"/>
-          </a:p>
-        </p:txBody>
-      </p:sp>
-      <p:sp>
-        <p:nvSpPr>
-          <p:cNvPr id="41" name="Text 39"/>
-          <p:cNvSpPr/>
-          <p:nvPr/>
-        </p:nvSpPr>
-        <p:spPr>
-          <a:xfrm>
-            <a:off x="7726680" y="4315968"/>
-            <a:ext cx="2697480" cy="384048"/>
-          </a:xfrm>
-          <a:prstGeom prst="rect">
-            <a:avLst/>
-          </a:prstGeom>
-          <a:noFill/>
-          <a:ln/>
-        </p:spPr>
-        <p:txBody>
-          <a:bodyPr wrap="square" lIns="0" tIns="0" rIns="0" bIns="0" rtlCol="0" anchor="t">
-            <a:normAutofit/>
-          </a:bodyPr>
-          <a:lstStyle/>
-          <a:p>
             <a:pPr indent="0" marL="0">
               <a:buNone/>
             </a:pPr>
@@ -18136,7 +17533,7 @@
                 <a:ea typeface="Microsoft YaHei" pitchFamily="34" charset="-122"/>
                 <a:cs typeface="Microsoft YaHei" pitchFamily="34" charset="-120"/>
               </a:rPr>
-              <a:t>参考培训 PPT 的阶段路线表达，按事件顺序拆成判断路径。</a:t>
+              <a:t>检测到对比/分类信号，用矩阵压缩呈现，不新增外部判断。</a:t>
             </a:r>
             <a:endParaRPr lang="en-US" sz="760" dirty="0"/>
           </a:p>
@@ -18144,7 +17541,7 @@
       </p:sp>
       <p:sp>
         <p:nvSpPr>
-          <p:cNvPr id="42" name="Shape 40"/>
+          <p:cNvPr id="40" name="Shape 38"/>
           <p:cNvSpPr/>
           <p:nvPr/>
         </p:nvSpPr>
@@ -18169,7 +17566,7 @@
       </p:sp>
       <p:sp>
         <p:nvSpPr>
-          <p:cNvPr id="43" name="Text 41"/>
+          <p:cNvPr id="41" name="Text 39"/>
           <p:cNvSpPr/>
           <p:nvPr/>
         </p:nvSpPr>
@@ -18208,7 +17605,7 @@
       </p:sp>
       <p:sp>
         <p:nvSpPr>
-          <p:cNvPr id="44" name="Text 42"/>
+          <p:cNvPr id="42" name="Text 40"/>
           <p:cNvSpPr/>
           <p:nvPr/>
         </p:nvSpPr>
@@ -18241,7 +17638,7 @@
                 <a:ea typeface="Microsoft YaHei" pitchFamily="34" charset="-122"/>
                 <a:cs typeface="Microsoft YaHei" pitchFamily="34" charset="-120"/>
               </a:rPr>
-              <a:t>若吉利电芯大规模外供，则第三方磷酸铁锂企业客户结构可能恶化</a:t>
+              <a:t>若钠离子电池在储能场景实现规模化应用且成本低于磷酸铁锂，则可能对磷酸铁锂在低端储能市场的份额形成挤压，跟踪指标为钠离子电池储能项目招标规模和度电成本对比</a:t>
             </a:r>
             <a:endParaRPr lang="en-US" sz="1020" dirty="0"/>
           </a:p>
@@ -18390,7 +17787,7 @@
                 <a:ea typeface="Aptos" pitchFamily="34" charset="-122"/>
                 <a:cs typeface="Aptos" pitchFamily="34" charset="-120"/>
               </a:rPr>
-              <a:t>2026-10-12</a:t>
+              <a:t>2026-10-19</a:t>
             </a:r>
             <a:endParaRPr lang="en-US" sz="800" dirty="0"/>
           </a:p>
@@ -18596,7 +17993,7 @@
                 <a:ea typeface="Microsoft YaHei" pitchFamily="34" charset="-122"/>
                 <a:cs typeface="Microsoft YaHei" pitchFamily="34" charset="-120"/>
               </a:rPr>
-              <a:t>4 条公开来源交叉验证｜事实、影响与后续研判</a:t>
+              <a:t>3 条公开来源交叉验证｜事实、影响与后续研判</a:t>
             </a:r>
             <a:endParaRPr lang="en-US" sz="860" dirty="0"/>
           </a:p>
@@ -18705,7 +18102,7 @@
                 <a:ea typeface="Microsoft YaHei" pitchFamily="34" charset="-122"/>
                 <a:cs typeface="Microsoft YaHei" pitchFamily="34" charset="-120"/>
               </a:rPr>
-              <a:t>风险：碳酸锂价格暴跌致盈利压力，欧盟自限出口政策压制需求；机会：湖南裕能扩产和龙蟠科技长协显示龙头扩张，国内新质生产力政策支持；观察：华盛锂电资本运作、电池板块股价波动。 [3][4][1][6]</a:t>
+              <a:t>机会方面，宝马第六代电池量产和储能产能激增可能支撑磷酸铁锂需求；风险方面，储能产能快速扩张可能加剧价格竞争，钠离子电池和固态电池长期替代威胁需跟踪；观察电摩国标执行对小动力电池行业集中度的影响。 [1][2][3]</a:t>
             </a:r>
             <a:endParaRPr lang="en-US" sz="960" dirty="0"/>
           </a:p>
@@ -18746,7 +18143,7 @@
                 <a:ea typeface="Aptos" pitchFamily="34" charset="-122"/>
                 <a:cs typeface="Aptos" pitchFamily="34" charset="-120"/>
               </a:rPr>
-              <a:t>依据：[3][4][1][6]</a:t>
+              <a:t>依据：[1][2][3]</a:t>
             </a:r>
             <a:endParaRPr lang="en-US" sz="740" dirty="0"/>
           </a:p>
@@ -18855,7 +18252,7 @@
                 <a:ea typeface="Microsoft YaHei" pitchFamily="34" charset="-122"/>
                 <a:cs typeface="Microsoft YaHei" pitchFamily="34" charset="-120"/>
               </a:rPr>
-              <a:t>价格下行与政策风险是主要压制因素，但龙头扩产和长协锁定表明行业仍具成长性；华盛锂电法律意见书可能预示资本动作，电池板块跌幅居前反映市场情绪。需验证：碳酸锂价格拐点、政策落地节奏、企业资本运作意图。</a:t>
+              <a:t>综合今日信息，需求端有宝马量产和储能扩张支撑，但供给端储能产能激增可能带来价格压力，技术路线端钠离子电池和固态电池构成长期竞争。电摩国标从合规端加速小动力电池行业出清。需持续跟踪宝马电池技术路线确认、储能电池开工率和价格走势、钠离子电池储能项目经济性、固态电池量产进展以及电摩国标执行效果。</a:t>
             </a:r>
             <a:endParaRPr lang="en-US" sz="960" dirty="0"/>
           </a:p>
@@ -18989,7 +18386,7 @@
                 <a:ea typeface="Microsoft YaHei" pitchFamily="34" charset="-122"/>
                 <a:cs typeface="Microsoft YaHei" pitchFamily="34" charset="-120"/>
               </a:rPr>
-              <a:t>若碳酸锂价格企稳，则磷酸铁锂盈利可能修复；若欧盟政策放松，则出口需求可能回升。跟踪指标：碳酸锂期货价、欧盟政策动向、华盛锂电公告。</a:t>
+              <a:t>若宝马第六代电池放量且储能电池开工率维持高位，则磷酸铁锂需求端可能获得双重支撑，跟踪指标为宝马新车型电池供应商公告和储能电池月度产量；若储能电池价格竞争加剧且钠离子电池储能项目规模化落地，则磷酸铁锂盈利压力可能上升，跟踪指标为储能电池均价和钠离子电池招标规模；若电摩国标执行严格，则小动力电池行业集中度可能提升，跟踪指标为合规企业认证进度。证据边界限于公开报道，未覆盖企业实际订单和成本数据。</a:t>
             </a:r>
             <a:endParaRPr lang="en-US" sz="960" dirty="0"/>
           </a:p>
@@ -19057,7 +18454,7 @@
                 <a:ea typeface="Microsoft YaHei" pitchFamily="34" charset="-122"/>
                 <a:cs typeface="Microsoft YaHei" pitchFamily="34" charset="-120"/>
               </a:rPr>
-              <a:t>路线图</a:t>
+              <a:t>对比矩阵</a:t>
             </a:r>
             <a:endParaRPr lang="en-US" sz="1200" dirty="0"/>
           </a:p>
@@ -19071,18 +18468,89 @@
         </p:nvSpPr>
         <p:spPr>
           <a:xfrm>
-            <a:off x="7754112" y="2249424"/>
-            <a:ext cx="612648" cy="402336"/>
-          </a:xfrm>
-          <a:prstGeom prst="chevron">
+            <a:off x="7818120" y="2176272"/>
+            <a:ext cx="2487168" cy="1609344"/>
+          </a:xfrm>
+          <a:prstGeom prst="rect">
+            <a:avLst/>
+          </a:prstGeom>
+          <a:solidFill>
+            <a:srgbClr val="FFFFFF"/>
+          </a:solidFill>
+          <a:ln w="10160">
+            <a:solidFill>
+              <a:srgbClr val="DADADA"/>
+            </a:solidFill>
+            <a:prstDash val="solid"/>
+          </a:ln>
+        </p:spPr>
+      </p:sp>
+      <p:sp>
+        <p:nvSpPr>
+          <p:cNvPr id="25" name="Shape 23"/>
+          <p:cNvSpPr/>
+          <p:nvPr/>
+        </p:nvSpPr>
+        <p:spPr>
+          <a:xfrm>
+            <a:off x="9061704" y="2176272"/>
+            <a:ext cx="0" cy="1609344"/>
+          </a:xfrm>
+          <a:prstGeom prst="line">
+            <a:avLst/>
+          </a:prstGeom>
+          <a:noFill/>
+          <a:ln w="8890">
+            <a:solidFill>
+              <a:srgbClr val="DADADA"/>
+            </a:solidFill>
+            <a:prstDash val="solid"/>
+          </a:ln>
+        </p:spPr>
+      </p:sp>
+      <p:sp>
+        <p:nvSpPr>
+          <p:cNvPr id="26" name="Shape 24"/>
+          <p:cNvSpPr/>
+          <p:nvPr/>
+        </p:nvSpPr>
+        <p:spPr>
+          <a:xfrm>
+            <a:off x="7818120" y="2980944"/>
+            <a:ext cx="2487168" cy="0"/>
+          </a:xfrm>
+          <a:prstGeom prst="line">
+            <a:avLst/>
+          </a:prstGeom>
+          <a:noFill/>
+          <a:ln w="8890">
+            <a:solidFill>
+              <a:srgbClr val="DADADA"/>
+            </a:solidFill>
+            <a:prstDash val="solid"/>
+          </a:ln>
+        </p:spPr>
+      </p:sp>
+      <p:sp>
+        <p:nvSpPr>
+          <p:cNvPr id="27" name="Shape 25"/>
+          <p:cNvSpPr/>
+          <p:nvPr/>
+        </p:nvSpPr>
+        <p:spPr>
+          <a:xfrm>
+            <a:off x="7818120" y="2176272"/>
+            <a:ext cx="1243584" cy="804672"/>
+          </a:xfrm>
+          <a:prstGeom prst="rect">
             <a:avLst/>
           </a:prstGeom>
           <a:solidFill>
             <a:srgbClr val="DDEBE0"/>
           </a:solidFill>
-          <a:ln w="13970">
+          <a:ln w="3810">
             <a:solidFill>
-              <a:srgbClr val="487052"/>
+              <a:srgbClr val="DADADA"/>
             </a:solidFill>
             <a:prstDash val="solid"/>
           </a:ln>
@@ -19090,14 +18558,14 @@
       </p:sp>
       <p:sp>
         <p:nvSpPr>
-          <p:cNvPr id="25" name="Text 23"/>
-          <p:cNvSpPr/>
-          <p:nvPr/>
-        </p:nvSpPr>
-        <p:spPr>
-          <a:xfrm>
-            <a:off x="7827264" y="2386584"/>
-            <a:ext cx="448056" cy="109728"/>
+          <p:cNvPr id="28" name="Text 26"/>
+          <p:cNvSpPr/>
+          <p:nvPr/>
+        </p:nvSpPr>
+        <p:spPr>
+          <a:xfrm>
+            <a:off x="7891272" y="2286000"/>
+            <a:ext cx="438912" cy="109728"/>
           </a:xfrm>
           <a:prstGeom prst="rect">
             <a:avLst/>
@@ -19111,11 +18579,52 @@
           </a:bodyPr>
           <a:lstStyle/>
           <a:p>
-            <a:pPr algn="ctr" indent="0" marL="0">
-              <a:buNone/>
-            </a:pPr>
-            <a:r>
-              <a:rPr lang="en-US" sz="670" b="1" dirty="0">
+            <a:pPr indent="0" marL="0">
+              <a:buNone/>
+            </a:pPr>
+            <a:r>
+              <a:rPr lang="en-US" sz="710" b="1" dirty="0">
+                <a:solidFill>
+                  <a:srgbClr val="487052"/>
+                </a:solidFill>
+                <a:latin typeface="Microsoft YaHei" pitchFamily="34" charset="0"/>
+                <a:ea typeface="Microsoft YaHei" pitchFamily="34" charset="-122"/>
+                <a:cs typeface="Microsoft YaHei" pitchFamily="34" charset="-120"/>
+              </a:rPr>
+              <a:t>路线A</a:t>
+            </a:r>
+            <a:endParaRPr lang="en-US" sz="710" dirty="0"/>
+          </a:p>
+        </p:txBody>
+      </p:sp>
+      <p:sp>
+        <p:nvSpPr>
+          <p:cNvPr id="29" name="Text 27"/>
+          <p:cNvSpPr/>
+          <p:nvPr/>
+        </p:nvSpPr>
+        <p:spPr>
+          <a:xfrm>
+            <a:off x="7891272" y="2505456"/>
+            <a:ext cx="1024128" cy="201168"/>
+          </a:xfrm>
+          <a:prstGeom prst="rect">
+            <a:avLst/>
+          </a:prstGeom>
+          <a:noFill/>
+          <a:ln/>
+        </p:spPr>
+        <p:txBody>
+          <a:bodyPr wrap="square" lIns="0" tIns="0" rIns="0" bIns="0" rtlCol="0" anchor="t">
+            <a:normAutofit/>
+          </a:bodyPr>
+          <a:lstStyle/>
+          <a:p>
+            <a:pPr indent="0" marL="0">
+              <a:buNone/>
+            </a:pPr>
+            <a:r>
+              <a:rPr lang="en-US" sz="670" dirty="0">
                 <a:solidFill>
                   <a:srgbClr val="121212"/>
                 </a:solidFill>
@@ -19123,7 +18632,7 @@
                 <a:ea typeface="Microsoft YaHei" pitchFamily="34" charset="-122"/>
                 <a:cs typeface="Microsoft YaHei" pitchFamily="34" charset="-120"/>
               </a:rPr>
-              <a:t>技术</a:t>
+              <a:t>机会方面，宝马第六代电池量</a:t>
             </a:r>
             <a:endParaRPr lang="en-US" sz="670" dirty="0"/>
           </a:p>
@@ -19131,24 +18640,24 @@
       </p:sp>
       <p:sp>
         <p:nvSpPr>
-          <p:cNvPr id="26" name="Shape 24"/>
-          <p:cNvSpPr/>
-          <p:nvPr/>
-        </p:nvSpPr>
-        <p:spPr>
-          <a:xfrm>
-            <a:off x="8375904" y="2249424"/>
-            <a:ext cx="612648" cy="402336"/>
-          </a:xfrm>
-          <a:prstGeom prst="chevron">
+          <p:cNvPr id="30" name="Shape 28"/>
+          <p:cNvSpPr/>
+          <p:nvPr/>
+        </p:nvSpPr>
+        <p:spPr>
+          <a:xfrm>
+            <a:off x="9061704" y="2176272"/>
+            <a:ext cx="1243584" cy="804672"/>
+          </a:xfrm>
+          <a:prstGeom prst="rect">
             <a:avLst/>
           </a:prstGeom>
           <a:solidFill>
             <a:srgbClr val="FFFFFF"/>
           </a:solidFill>
-          <a:ln w="13970">
+          <a:ln w="3810">
             <a:solidFill>
-              <a:srgbClr val="487052"/>
+              <a:srgbClr val="DADADA"/>
             </a:solidFill>
             <a:prstDash val="solid"/>
           </a:ln>
@@ -19156,14 +18665,14 @@
       </p:sp>
       <p:sp>
         <p:nvSpPr>
-          <p:cNvPr id="27" name="Text 25"/>
-          <p:cNvSpPr/>
-          <p:nvPr/>
-        </p:nvSpPr>
-        <p:spPr>
-          <a:xfrm>
-            <a:off x="8449056" y="2386584"/>
-            <a:ext cx="448056" cy="109728"/>
+          <p:cNvPr id="31" name="Text 29"/>
+          <p:cNvSpPr/>
+          <p:nvPr/>
+        </p:nvSpPr>
+        <p:spPr>
+          <a:xfrm>
+            <a:off x="9134856" y="2286000"/>
+            <a:ext cx="438912" cy="109728"/>
           </a:xfrm>
           <a:prstGeom prst="rect">
             <a:avLst/>
@@ -19177,11 +18686,52 @@
           </a:bodyPr>
           <a:lstStyle/>
           <a:p>
-            <a:pPr algn="ctr" indent="0" marL="0">
-              <a:buNone/>
-            </a:pPr>
-            <a:r>
-              <a:rPr lang="en-US" sz="670" b="1" dirty="0">
+            <a:pPr indent="0" marL="0">
+              <a:buNone/>
+            </a:pPr>
+            <a:r>
+              <a:rPr lang="en-US" sz="710" b="1" dirty="0">
+                <a:solidFill>
+                  <a:srgbClr val="487052"/>
+                </a:solidFill>
+                <a:latin typeface="Microsoft YaHei" pitchFamily="34" charset="0"/>
+                <a:ea typeface="Microsoft YaHei" pitchFamily="34" charset="-122"/>
+                <a:cs typeface="Microsoft YaHei" pitchFamily="34" charset="-120"/>
+              </a:rPr>
+              <a:t>路线B</a:t>
+            </a:r>
+            <a:endParaRPr lang="en-US" sz="710" dirty="0"/>
+          </a:p>
+        </p:txBody>
+      </p:sp>
+      <p:sp>
+        <p:nvSpPr>
+          <p:cNvPr id="32" name="Text 30"/>
+          <p:cNvSpPr/>
+          <p:nvPr/>
+        </p:nvSpPr>
+        <p:spPr>
+          <a:xfrm>
+            <a:off x="9134856" y="2505456"/>
+            <a:ext cx="1024128" cy="201168"/>
+          </a:xfrm>
+          <a:prstGeom prst="rect">
+            <a:avLst/>
+          </a:prstGeom>
+          <a:noFill/>
+          <a:ln/>
+        </p:spPr>
+        <p:txBody>
+          <a:bodyPr wrap="square" lIns="0" tIns="0" rIns="0" bIns="0" rtlCol="0" anchor="t">
+            <a:normAutofit/>
+          </a:bodyPr>
+          <a:lstStyle/>
+          <a:p>
+            <a:pPr indent="0" marL="0">
+              <a:buNone/>
+            </a:pPr>
+            <a:r>
+              <a:rPr lang="en-US" sz="670" dirty="0">
                 <a:solidFill>
                   <a:srgbClr val="121212"/>
                 </a:solidFill>
@@ -19189,7 +18739,7 @@
                 <a:ea typeface="Microsoft YaHei" pitchFamily="34" charset="-122"/>
                 <a:cs typeface="Microsoft YaHei" pitchFamily="34" charset="-120"/>
               </a:rPr>
-              <a:t>产品</a:t>
+              <a:t>风险方面，储能产能快速扩张</a:t>
             </a:r>
             <a:endParaRPr lang="en-US" sz="670" dirty="0"/>
           </a:p>
@@ -19197,24 +18747,24 @@
       </p:sp>
       <p:sp>
         <p:nvSpPr>
-          <p:cNvPr id="28" name="Shape 26"/>
-          <p:cNvSpPr/>
-          <p:nvPr/>
-        </p:nvSpPr>
-        <p:spPr>
-          <a:xfrm>
-            <a:off x="8997696" y="2249424"/>
-            <a:ext cx="612648" cy="402336"/>
-          </a:xfrm>
-          <a:prstGeom prst="chevron">
+          <p:cNvPr id="33" name="Shape 31"/>
+          <p:cNvSpPr/>
+          <p:nvPr/>
+        </p:nvSpPr>
+        <p:spPr>
+          <a:xfrm>
+            <a:off x="7818120" y="2980944"/>
+            <a:ext cx="1243584" cy="804672"/>
+          </a:xfrm>
+          <a:prstGeom prst="rect">
             <a:avLst/>
           </a:prstGeom>
           <a:solidFill>
             <a:srgbClr val="FFFFFF"/>
           </a:solidFill>
-          <a:ln w="13970">
+          <a:ln w="3810">
             <a:solidFill>
-              <a:srgbClr val="487052"/>
+              <a:srgbClr val="DADADA"/>
             </a:solidFill>
             <a:prstDash val="solid"/>
           </a:ln>
@@ -19222,14 +18772,14 @@
       </p:sp>
       <p:sp>
         <p:nvSpPr>
-          <p:cNvPr id="29" name="Text 27"/>
-          <p:cNvSpPr/>
-          <p:nvPr/>
-        </p:nvSpPr>
-        <p:spPr>
-          <a:xfrm>
-            <a:off x="9070848" y="2386584"/>
-            <a:ext cx="448056" cy="109728"/>
+          <p:cNvPr id="34" name="Text 32"/>
+          <p:cNvSpPr/>
+          <p:nvPr/>
+        </p:nvSpPr>
+        <p:spPr>
+          <a:xfrm>
+            <a:off x="7891272" y="3090672"/>
+            <a:ext cx="438912" cy="109728"/>
           </a:xfrm>
           <a:prstGeom prst="rect">
             <a:avLst/>
@@ -19243,11 +18793,52 @@
           </a:bodyPr>
           <a:lstStyle/>
           <a:p>
-            <a:pPr algn="ctr" indent="0" marL="0">
-              <a:buNone/>
-            </a:pPr>
-            <a:r>
-              <a:rPr lang="en-US" sz="670" b="1" dirty="0">
+            <a:pPr indent="0" marL="0">
+              <a:buNone/>
+            </a:pPr>
+            <a:r>
+              <a:rPr lang="en-US" sz="710" b="1" dirty="0">
+                <a:solidFill>
+                  <a:srgbClr val="487052"/>
+                </a:solidFill>
+                <a:latin typeface="Microsoft YaHei" pitchFamily="34" charset="0"/>
+                <a:ea typeface="Microsoft YaHei" pitchFamily="34" charset="-122"/>
+                <a:cs typeface="Microsoft YaHei" pitchFamily="34" charset="-120"/>
+              </a:rPr>
+              <a:t>机会</a:t>
+            </a:r>
+            <a:endParaRPr lang="en-US" sz="710" dirty="0"/>
+          </a:p>
+        </p:txBody>
+      </p:sp>
+      <p:sp>
+        <p:nvSpPr>
+          <p:cNvPr id="35" name="Text 33"/>
+          <p:cNvSpPr/>
+          <p:nvPr/>
+        </p:nvSpPr>
+        <p:spPr>
+          <a:xfrm>
+            <a:off x="7891272" y="3310128"/>
+            <a:ext cx="1024128" cy="201168"/>
+          </a:xfrm>
+          <a:prstGeom prst="rect">
+            <a:avLst/>
+          </a:prstGeom>
+          <a:noFill/>
+          <a:ln/>
+        </p:spPr>
+        <p:txBody>
+          <a:bodyPr wrap="square" lIns="0" tIns="0" rIns="0" bIns="0" rtlCol="0" anchor="t">
+            <a:normAutofit/>
+          </a:bodyPr>
+          <a:lstStyle/>
+          <a:p>
+            <a:pPr indent="0" marL="0">
+              <a:buNone/>
+            </a:pPr>
+            <a:r>
+              <a:rPr lang="en-US" sz="670" dirty="0">
                 <a:solidFill>
                   <a:srgbClr val="121212"/>
                 </a:solidFill>
@@ -19255,7 +18846,7 @@
                 <a:ea typeface="Microsoft YaHei" pitchFamily="34" charset="-122"/>
                 <a:cs typeface="Microsoft YaHei" pitchFamily="34" charset="-120"/>
               </a:rPr>
-              <a:t>验证</a:t>
+              <a:t>观察电摩国标执行对小动力电</a:t>
             </a:r>
             <a:endParaRPr lang="en-US" sz="670" dirty="0"/>
           </a:p>
@@ -19263,24 +18854,24 @@
       </p:sp>
       <p:sp>
         <p:nvSpPr>
-          <p:cNvPr id="30" name="Shape 28"/>
-          <p:cNvSpPr/>
-          <p:nvPr/>
-        </p:nvSpPr>
-        <p:spPr>
-          <a:xfrm>
-            <a:off x="9619488" y="2249424"/>
-            <a:ext cx="612648" cy="402336"/>
-          </a:xfrm>
-          <a:prstGeom prst="chevron">
+          <p:cNvPr id="36" name="Shape 34"/>
+          <p:cNvSpPr/>
+          <p:nvPr/>
+        </p:nvSpPr>
+        <p:spPr>
+          <a:xfrm>
+            <a:off x="9061704" y="2980944"/>
+            <a:ext cx="1243584" cy="804672"/>
+          </a:xfrm>
+          <a:prstGeom prst="rect">
             <a:avLst/>
           </a:prstGeom>
           <a:solidFill>
-            <a:srgbClr val="FFFFFF"/>
+            <a:srgbClr val="F4FAF6"/>
           </a:solidFill>
-          <a:ln w="13970">
+          <a:ln w="3810">
             <a:solidFill>
-              <a:srgbClr val="487052"/>
+              <a:srgbClr val="DADADA"/>
             </a:solidFill>
             <a:prstDash val="solid"/>
           </a:ln>
@@ -19288,14 +18879,14 @@
       </p:sp>
       <p:sp>
         <p:nvSpPr>
-          <p:cNvPr id="31" name="Text 29"/>
-          <p:cNvSpPr/>
-          <p:nvPr/>
-        </p:nvSpPr>
-        <p:spPr>
-          <a:xfrm>
-            <a:off x="9692640" y="2386584"/>
-            <a:ext cx="448056" cy="109728"/>
+          <p:cNvPr id="37" name="Text 35"/>
+          <p:cNvSpPr/>
+          <p:nvPr/>
+        </p:nvSpPr>
+        <p:spPr>
+          <a:xfrm>
+            <a:off x="9134856" y="3090672"/>
+            <a:ext cx="438912" cy="109728"/>
           </a:xfrm>
           <a:prstGeom prst="rect">
             <a:avLst/>
@@ -19309,11 +18900,52 @@
           </a:bodyPr>
           <a:lstStyle/>
           <a:p>
-            <a:pPr algn="ctr" indent="0" marL="0">
-              <a:buNone/>
-            </a:pPr>
-            <a:r>
-              <a:rPr lang="en-US" sz="670" b="1" dirty="0">
+            <a:pPr indent="0" marL="0">
+              <a:buNone/>
+            </a:pPr>
+            <a:r>
+              <a:rPr lang="en-US" sz="710" b="1" dirty="0">
+                <a:solidFill>
+                  <a:srgbClr val="487052"/>
+                </a:solidFill>
+                <a:latin typeface="Microsoft YaHei" pitchFamily="34" charset="0"/>
+                <a:ea typeface="Microsoft YaHei" pitchFamily="34" charset="-122"/>
+                <a:cs typeface="Microsoft YaHei" pitchFamily="34" charset="-120"/>
+              </a:rPr>
+              <a:t>约束</a:t>
+            </a:r>
+            <a:endParaRPr lang="en-US" sz="710" dirty="0"/>
+          </a:p>
+        </p:txBody>
+      </p:sp>
+      <p:sp>
+        <p:nvSpPr>
+          <p:cNvPr id="38" name="Text 36"/>
+          <p:cNvSpPr/>
+          <p:nvPr/>
+        </p:nvSpPr>
+        <p:spPr>
+          <a:xfrm>
+            <a:off x="9134856" y="3310128"/>
+            <a:ext cx="1024128" cy="201168"/>
+          </a:xfrm>
+          <a:prstGeom prst="rect">
+            <a:avLst/>
+          </a:prstGeom>
+          <a:noFill/>
+          <a:ln/>
+        </p:spPr>
+        <p:txBody>
+          <a:bodyPr wrap="square" lIns="0" tIns="0" rIns="0" bIns="0" rtlCol="0" anchor="t">
+            <a:normAutofit/>
+          </a:bodyPr>
+          <a:lstStyle/>
+          <a:p>
+            <a:pPr indent="0" marL="0">
+              <a:buNone/>
+            </a:pPr>
+            <a:r>
+              <a:rPr lang="en-US" sz="670" dirty="0">
                 <a:solidFill>
                   <a:srgbClr val="121212"/>
                 </a:solidFill>
@@ -19321,7 +18953,7 @@
                 <a:ea typeface="Microsoft YaHei" pitchFamily="34" charset="-122"/>
                 <a:cs typeface="Microsoft YaHei" pitchFamily="34" charset="-120"/>
               </a:rPr>
-              <a:t>量产</a:t>
+              <a:t>机会方面，宝马第六代电池量</a:t>
             </a:r>
             <a:endParaRPr lang="en-US" sz="670" dirty="0"/>
           </a:p>
@@ -19329,62 +18961,14 @@
       </p:sp>
       <p:sp>
         <p:nvSpPr>
-          <p:cNvPr id="32" name="Shape 30"/>
-          <p:cNvSpPr/>
-          <p:nvPr/>
-        </p:nvSpPr>
-        <p:spPr>
-          <a:xfrm>
-            <a:off x="7882128" y="3063240"/>
-            <a:ext cx="2331720" cy="0"/>
-          </a:xfrm>
-          <a:prstGeom prst="line">
-            <a:avLst/>
-          </a:prstGeom>
-          <a:noFill/>
-          <a:ln w="13970">
-            <a:solidFill>
-              <a:srgbClr val="7F9D84"/>
-            </a:solidFill>
-            <a:prstDash val="solid"/>
-          </a:ln>
-        </p:spPr>
-      </p:sp>
-      <p:sp>
-        <p:nvSpPr>
-          <p:cNvPr id="33" name="Shape 31"/>
-          <p:cNvSpPr/>
-          <p:nvPr/>
-        </p:nvSpPr>
-        <p:spPr>
-          <a:xfrm>
-            <a:off x="7845552" y="2962656"/>
-            <a:ext cx="164592" cy="164592"/>
-          </a:xfrm>
-          <a:prstGeom prst="ellipse">
-            <a:avLst/>
-          </a:prstGeom>
-          <a:solidFill>
-            <a:srgbClr val="487052"/>
-          </a:solidFill>
-          <a:ln w="12700">
-            <a:solidFill>
-              <a:srgbClr val="FFFFFF"/>
-            </a:solidFill>
-            <a:prstDash val="solid"/>
-          </a:ln>
-        </p:spPr>
-      </p:sp>
-      <p:sp>
-        <p:nvSpPr>
-          <p:cNvPr id="34" name="Text 32"/>
-          <p:cNvSpPr/>
-          <p:nvPr/>
-        </p:nvSpPr>
-        <p:spPr>
-          <a:xfrm>
-            <a:off x="7754112" y="3291840"/>
-            <a:ext cx="603504" cy="310896"/>
+          <p:cNvPr id="39" name="Text 37"/>
+          <p:cNvSpPr/>
+          <p:nvPr/>
+        </p:nvSpPr>
+        <p:spPr>
+          <a:xfrm>
+            <a:off x="7726680" y="4187952"/>
+            <a:ext cx="2697480" cy="493776"/>
           </a:xfrm>
           <a:prstGeom prst="rect">
             <a:avLst/>
@@ -19398,245 +18982,6 @@
           </a:bodyPr>
           <a:lstStyle/>
           <a:p>
-            <a:pPr algn="ctr" indent="0" marL="0">
-              <a:buNone/>
-            </a:pPr>
-            <a:r>
-              <a:rPr lang="en-US" sz="670" dirty="0">
-                <a:solidFill>
-                  <a:srgbClr val="121212"/>
-                </a:solidFill>
-                <a:latin typeface="Microsoft YaHei" pitchFamily="34" charset="0"/>
-                <a:ea typeface="Microsoft YaHei" pitchFamily="34" charset="-122"/>
-                <a:cs typeface="Microsoft YaHei" pitchFamily="34" charset="-120"/>
-              </a:rPr>
-              <a:t>风险：碳酸锂价格暴跌致</a:t>
-            </a:r>
-            <a:endParaRPr lang="en-US" sz="670" dirty="0"/>
-          </a:p>
-        </p:txBody>
-      </p:sp>
-      <p:sp>
-        <p:nvSpPr>
-          <p:cNvPr id="35" name="Shape 33"/>
-          <p:cNvSpPr/>
-          <p:nvPr/>
-        </p:nvSpPr>
-        <p:spPr>
-          <a:xfrm>
-            <a:off x="8503920" y="2962656"/>
-            <a:ext cx="164592" cy="164592"/>
-          </a:xfrm>
-          <a:prstGeom prst="ellipse">
-            <a:avLst/>
-          </a:prstGeom>
-          <a:solidFill>
-            <a:srgbClr val="487052"/>
-          </a:solidFill>
-          <a:ln w="12700">
-            <a:solidFill>
-              <a:srgbClr val="FFFFFF"/>
-            </a:solidFill>
-            <a:prstDash val="solid"/>
-          </a:ln>
-        </p:spPr>
-      </p:sp>
-      <p:sp>
-        <p:nvSpPr>
-          <p:cNvPr id="36" name="Text 34"/>
-          <p:cNvSpPr/>
-          <p:nvPr/>
-        </p:nvSpPr>
-        <p:spPr>
-          <a:xfrm>
-            <a:off x="8412480" y="3291840"/>
-            <a:ext cx="603504" cy="310896"/>
-          </a:xfrm>
-          <a:prstGeom prst="rect">
-            <a:avLst/>
-          </a:prstGeom>
-          <a:noFill/>
-          <a:ln/>
-        </p:spPr>
-        <p:txBody>
-          <a:bodyPr wrap="square" lIns="0" tIns="0" rIns="0" bIns="0" rtlCol="0" anchor="t">
-            <a:normAutofit/>
-          </a:bodyPr>
-          <a:lstStyle/>
-          <a:p>
-            <a:pPr algn="ctr" indent="0" marL="0">
-              <a:buNone/>
-            </a:pPr>
-            <a:r>
-              <a:rPr lang="en-US" sz="670" dirty="0">
-                <a:solidFill>
-                  <a:srgbClr val="121212"/>
-                </a:solidFill>
-                <a:latin typeface="Microsoft YaHei" pitchFamily="34" charset="0"/>
-                <a:ea typeface="Microsoft YaHei" pitchFamily="34" charset="-122"/>
-                <a:cs typeface="Microsoft YaHei" pitchFamily="34" charset="-120"/>
-              </a:rPr>
-              <a:t>机会：湖南裕能扩产和龙</a:t>
-            </a:r>
-            <a:endParaRPr lang="en-US" sz="670" dirty="0"/>
-          </a:p>
-        </p:txBody>
-      </p:sp>
-      <p:sp>
-        <p:nvSpPr>
-          <p:cNvPr id="37" name="Shape 35"/>
-          <p:cNvSpPr/>
-          <p:nvPr/>
-        </p:nvSpPr>
-        <p:spPr>
-          <a:xfrm>
-            <a:off x="9162288" y="2962656"/>
-            <a:ext cx="164592" cy="164592"/>
-          </a:xfrm>
-          <a:prstGeom prst="ellipse">
-            <a:avLst/>
-          </a:prstGeom>
-          <a:solidFill>
-            <a:srgbClr val="487052"/>
-          </a:solidFill>
-          <a:ln w="12700">
-            <a:solidFill>
-              <a:srgbClr val="FFFFFF"/>
-            </a:solidFill>
-            <a:prstDash val="solid"/>
-          </a:ln>
-        </p:spPr>
-      </p:sp>
-      <p:sp>
-        <p:nvSpPr>
-          <p:cNvPr id="38" name="Text 36"/>
-          <p:cNvSpPr/>
-          <p:nvPr/>
-        </p:nvSpPr>
-        <p:spPr>
-          <a:xfrm>
-            <a:off x="9070848" y="3291840"/>
-            <a:ext cx="603504" cy="310896"/>
-          </a:xfrm>
-          <a:prstGeom prst="rect">
-            <a:avLst/>
-          </a:prstGeom>
-          <a:noFill/>
-          <a:ln/>
-        </p:spPr>
-        <p:txBody>
-          <a:bodyPr wrap="square" lIns="0" tIns="0" rIns="0" bIns="0" rtlCol="0" anchor="t">
-            <a:normAutofit/>
-          </a:bodyPr>
-          <a:lstStyle/>
-          <a:p>
-            <a:pPr algn="ctr" indent="0" marL="0">
-              <a:buNone/>
-            </a:pPr>
-            <a:r>
-              <a:rPr lang="en-US" sz="670" dirty="0">
-                <a:solidFill>
-                  <a:srgbClr val="121212"/>
-                </a:solidFill>
-                <a:latin typeface="Microsoft YaHei" pitchFamily="34" charset="0"/>
-                <a:ea typeface="Microsoft YaHei" pitchFamily="34" charset="-122"/>
-                <a:cs typeface="Microsoft YaHei" pitchFamily="34" charset="-120"/>
-              </a:rPr>
-              <a:t>观察：华盛锂电资本运作</a:t>
-            </a:r>
-            <a:endParaRPr lang="en-US" sz="670" dirty="0"/>
-          </a:p>
-        </p:txBody>
-      </p:sp>
-      <p:sp>
-        <p:nvSpPr>
-          <p:cNvPr id="39" name="Shape 37"/>
-          <p:cNvSpPr/>
-          <p:nvPr/>
-        </p:nvSpPr>
-        <p:spPr>
-          <a:xfrm>
-            <a:off x="9820656" y="2962656"/>
-            <a:ext cx="164592" cy="164592"/>
-          </a:xfrm>
-          <a:prstGeom prst="ellipse">
-            <a:avLst/>
-          </a:prstGeom>
-          <a:solidFill>
-            <a:srgbClr val="B85A4A"/>
-          </a:solidFill>
-          <a:ln w="12700">
-            <a:solidFill>
-              <a:srgbClr val="FFFFFF"/>
-            </a:solidFill>
-            <a:prstDash val="solid"/>
-          </a:ln>
-        </p:spPr>
-      </p:sp>
-      <p:sp>
-        <p:nvSpPr>
-          <p:cNvPr id="40" name="Text 38"/>
-          <p:cNvSpPr/>
-          <p:nvPr/>
-        </p:nvSpPr>
-        <p:spPr>
-          <a:xfrm>
-            <a:off x="9729216" y="3291840"/>
-            <a:ext cx="603504" cy="310896"/>
-          </a:xfrm>
-          <a:prstGeom prst="rect">
-            <a:avLst/>
-          </a:prstGeom>
-          <a:noFill/>
-          <a:ln/>
-        </p:spPr>
-        <p:txBody>
-          <a:bodyPr wrap="square" lIns="0" tIns="0" rIns="0" bIns="0" rtlCol="0" anchor="t">
-            <a:normAutofit/>
-          </a:bodyPr>
-          <a:lstStyle/>
-          <a:p>
-            <a:pPr algn="ctr" indent="0" marL="0">
-              <a:buNone/>
-            </a:pPr>
-            <a:r>
-              <a:rPr lang="en-US" sz="670" dirty="0">
-                <a:solidFill>
-                  <a:srgbClr val="121212"/>
-                </a:solidFill>
-                <a:latin typeface="Microsoft YaHei" pitchFamily="34" charset="0"/>
-                <a:ea typeface="Microsoft YaHei" pitchFamily="34" charset="-122"/>
-                <a:cs typeface="Microsoft YaHei" pitchFamily="34" charset="-120"/>
-              </a:rPr>
-              <a:t>观察：华盛锂电资本运作</a:t>
-            </a:r>
-            <a:endParaRPr lang="en-US" sz="670" dirty="0"/>
-          </a:p>
-        </p:txBody>
-      </p:sp>
-      <p:sp>
-        <p:nvSpPr>
-          <p:cNvPr id="41" name="Text 39"/>
-          <p:cNvSpPr/>
-          <p:nvPr/>
-        </p:nvSpPr>
-        <p:spPr>
-          <a:xfrm>
-            <a:off x="7726680" y="4315968"/>
-            <a:ext cx="2697480" cy="384048"/>
-          </a:xfrm>
-          <a:prstGeom prst="rect">
-            <a:avLst/>
-          </a:prstGeom>
-          <a:noFill/>
-          <a:ln/>
-        </p:spPr>
-        <p:txBody>
-          <a:bodyPr wrap="square" lIns="0" tIns="0" rIns="0" bIns="0" rtlCol="0" anchor="t">
-            <a:normAutofit/>
-          </a:bodyPr>
-          <a:lstStyle/>
-          <a:p>
             <a:pPr indent="0" marL="0">
               <a:buNone/>
             </a:pPr>
@@ -19649,7 +18994,7 @@
                 <a:ea typeface="Microsoft YaHei" pitchFamily="34" charset="-122"/>
                 <a:cs typeface="Microsoft YaHei" pitchFamily="34" charset="-120"/>
               </a:rPr>
-              <a:t>参考培训 PPT 的阶段路线表达，按事件顺序拆成判断路径。</a:t>
+              <a:t>检测到对比/分类信号，用矩阵压缩呈现，不新增外部判断。</a:t>
             </a:r>
             <a:endParaRPr lang="en-US" sz="760" dirty="0"/>
           </a:p>
@@ -19657,7 +19002,7 @@
       </p:sp>
       <p:sp>
         <p:nvSpPr>
-          <p:cNvPr id="42" name="Shape 40"/>
+          <p:cNvPr id="40" name="Shape 38"/>
           <p:cNvSpPr/>
           <p:nvPr/>
         </p:nvSpPr>
@@ -19682,7 +19027,7 @@
       </p:sp>
       <p:sp>
         <p:nvSpPr>
-          <p:cNvPr id="43" name="Text 41"/>
+          <p:cNvPr id="41" name="Text 39"/>
           <p:cNvSpPr/>
           <p:nvPr/>
         </p:nvSpPr>
@@ -19721,7 +19066,7 @@
       </p:sp>
       <p:sp>
         <p:nvSpPr>
-          <p:cNvPr id="44" name="Text 42"/>
+          <p:cNvPr id="42" name="Text 40"/>
           <p:cNvSpPr/>
           <p:nvPr/>
         </p:nvSpPr>
@@ -19754,7 +19099,7 @@
                 <a:ea typeface="Microsoft YaHei" pitchFamily="34" charset="-122"/>
                 <a:cs typeface="Microsoft YaHei" pitchFamily="34" charset="-120"/>
               </a:rPr>
-              <a:t>若碳酸锂价格企稳，则磷酸铁锂盈利可能修复</a:t>
+              <a:t>若宝马第六代电池放量且储能电池开工率维持高位，则磷酸铁锂需求端可能获得双重支撑，跟踪指标为宝马新车型电池供应商公告和储能电池月度产量</a:t>
             </a:r>
             <a:endParaRPr lang="en-US" sz="1020" dirty="0"/>
           </a:p>

</xml_diff>